<commit_message>
Align workshop deck styles to match ai-best-practices design system
Spectrum slides: fontSize 12, rectRadius 0.08, border 1.5pt. GPS slide:
light bg with wrong/right semantic colors and LINE divider. bigNum: x:0.5
w:9, caption 28pt, semantic colors (pink bottleneck, green judgment).
Chain flow: 1.8" boxes, 18pt text, 0.6" gap. Connections: icon PNGs
with widened labels. Skills two-column: LINE divider.

Co-Authored-By: Claude Opus 4.6 <noreply@anthropic.com>
</commit_message>
<xml_diff>
--- a/decks/workshop-2-orchestrator/workshop-2-orchestrator.pptx
+++ b/decks/workshop-2-orchestrator/workshop-2-orchestrator.pptx
@@ -4205,18 +4205,18 @@
         </p:nvSpPr>
         <p:spPr>
           <a:xfrm>
-            <a:off x="365760" y="1645920"/>
-            <a:ext cx="1828800" cy="914400"/>
+            <a:off x="457200" y="2011680"/>
+            <a:ext cx="1645920" cy="822960"/>
           </a:xfrm>
           <a:prstGeom prst="roundRect">
             <a:avLst>
-              <a:gd name="adj" fmla="val 5000"/>
+              <a:gd name="adj" fmla="val 11111"/>
             </a:avLst>
           </a:prstGeom>
           <a:solidFill>
             <a:srgbClr val="0A2540"/>
           </a:solidFill>
-          <a:ln w="12700">
+          <a:ln w="19050">
             <a:solidFill>
               <a:srgbClr val="8B95A5"/>
             </a:solidFill>
@@ -4232,8 +4232,8 @@
         </p:nvSpPr>
         <p:spPr>
           <a:xfrm>
-            <a:off x="365760" y="1645920"/>
-            <a:ext cx="1828800" cy="914400"/>
+            <a:off x="457200" y="2011680"/>
+            <a:ext cx="1645920" cy="822960"/>
           </a:xfrm>
           <a:prstGeom prst="rect">
             <a:avLst/>
@@ -4249,7 +4249,7 @@
               <a:buNone/>
             </a:pPr>
             <a:r>
-              <a:rPr lang="en-US" sz="1400" dirty="0">
+              <a:rPr lang="en-US" sz="1800" b="1" dirty="0">
                 <a:solidFill>
                   <a:srgbClr val="EDEDED"/>
                 </a:solidFill>
@@ -4259,7 +4259,7 @@
               </a:rPr>
               <a:t>Research</a:t>
             </a:r>
-            <a:endParaRPr lang="en-US" sz="1400" dirty="0"/>
+            <a:endParaRPr lang="en-US" sz="1800" dirty="0"/>
           </a:p>
         </p:txBody>
       </p:sp>
@@ -4271,8 +4271,8 @@
         </p:nvSpPr>
         <p:spPr>
           <a:xfrm>
-            <a:off x="2194560" y="1645920"/>
-            <a:ext cx="365760" cy="914400"/>
+            <a:off x="2103120" y="2011680"/>
+            <a:ext cx="548640" cy="822960"/>
           </a:xfrm>
           <a:prstGeom prst="rect">
             <a:avLst/>
@@ -4288,7 +4288,7 @@
               <a:buNone/>
             </a:pPr>
             <a:r>
-              <a:rPr lang="en-US" sz="2200" dirty="0">
+              <a:rPr lang="en-US" sz="2800" b="1" dirty="0">
                 <a:solidFill>
                   <a:srgbClr val="635BFF"/>
                 </a:solidFill>
@@ -4298,7 +4298,7 @@
               </a:rPr>
               <a:t>→</a:t>
             </a:r>
-            <a:endParaRPr lang="en-US" sz="2200" dirty="0"/>
+            <a:endParaRPr lang="en-US" sz="2800" dirty="0"/>
           </a:p>
         </p:txBody>
       </p:sp>
@@ -4310,18 +4310,18 @@
         </p:nvSpPr>
         <p:spPr>
           <a:xfrm>
-            <a:off x="2560320" y="1645920"/>
-            <a:ext cx="1828800" cy="914400"/>
+            <a:off x="2651760" y="2011680"/>
+            <a:ext cx="1645920" cy="822960"/>
           </a:xfrm>
           <a:prstGeom prst="roundRect">
             <a:avLst>
-              <a:gd name="adj" fmla="val 5000"/>
+              <a:gd name="adj" fmla="val 11111"/>
             </a:avLst>
           </a:prstGeom>
           <a:solidFill>
             <a:srgbClr val="0A2540"/>
           </a:solidFill>
-          <a:ln w="12700">
+          <a:ln w="19050">
             <a:solidFill>
               <a:srgbClr val="8B95A5"/>
             </a:solidFill>
@@ -4337,8 +4337,8 @@
         </p:nvSpPr>
         <p:spPr>
           <a:xfrm>
-            <a:off x="2560320" y="1645920"/>
-            <a:ext cx="1828800" cy="914400"/>
+            <a:off x="2651760" y="2011680"/>
+            <a:ext cx="1645920" cy="822960"/>
           </a:xfrm>
           <a:prstGeom prst="rect">
             <a:avLst/>
@@ -4354,7 +4354,7 @@
               <a:buNone/>
             </a:pPr>
             <a:r>
-              <a:rPr lang="en-US" sz="1400" dirty="0">
+              <a:rPr lang="en-US" sz="1800" b="1" dirty="0">
                 <a:solidFill>
                   <a:srgbClr val="EDEDED"/>
                 </a:solidFill>
@@ -4364,7 +4364,7 @@
               </a:rPr>
               <a:t>Draft</a:t>
             </a:r>
-            <a:endParaRPr lang="en-US" sz="1400" dirty="0"/>
+            <a:endParaRPr lang="en-US" sz="1800" dirty="0"/>
           </a:p>
         </p:txBody>
       </p:sp>
@@ -4376,8 +4376,8 @@
         </p:nvSpPr>
         <p:spPr>
           <a:xfrm>
-            <a:off x="4389120" y="1645920"/>
-            <a:ext cx="365760" cy="914400"/>
+            <a:off x="4297680" y="2011680"/>
+            <a:ext cx="548640" cy="822960"/>
           </a:xfrm>
           <a:prstGeom prst="rect">
             <a:avLst/>
@@ -4393,7 +4393,7 @@
               <a:buNone/>
             </a:pPr>
             <a:r>
-              <a:rPr lang="en-US" sz="2200" dirty="0">
+              <a:rPr lang="en-US" sz="2800" b="1" dirty="0">
                 <a:solidFill>
                   <a:srgbClr val="635BFF"/>
                 </a:solidFill>
@@ -4403,7 +4403,7 @@
               </a:rPr>
               <a:t>→</a:t>
             </a:r>
-            <a:endParaRPr lang="en-US" sz="2200" dirty="0"/>
+            <a:endParaRPr lang="en-US" sz="2800" dirty="0"/>
           </a:p>
         </p:txBody>
       </p:sp>
@@ -4415,18 +4415,18 @@
         </p:nvSpPr>
         <p:spPr>
           <a:xfrm>
-            <a:off x="4754880" y="1645920"/>
-            <a:ext cx="1828800" cy="914400"/>
+            <a:off x="4846320" y="2011680"/>
+            <a:ext cx="1645920" cy="822960"/>
           </a:xfrm>
           <a:prstGeom prst="roundRect">
             <a:avLst>
-              <a:gd name="adj" fmla="val 5000"/>
+              <a:gd name="adj" fmla="val 11111"/>
             </a:avLst>
           </a:prstGeom>
           <a:solidFill>
             <a:srgbClr val="0A2540"/>
           </a:solidFill>
-          <a:ln w="12700">
+          <a:ln w="19050">
             <a:solidFill>
               <a:srgbClr val="8B95A5"/>
             </a:solidFill>
@@ -4442,8 +4442,8 @@
         </p:nvSpPr>
         <p:spPr>
           <a:xfrm>
-            <a:off x="4754880" y="1645920"/>
-            <a:ext cx="1828800" cy="914400"/>
+            <a:off x="4846320" y="2011680"/>
+            <a:ext cx="1645920" cy="822960"/>
           </a:xfrm>
           <a:prstGeom prst="rect">
             <a:avLst/>
@@ -4459,7 +4459,7 @@
               <a:buNone/>
             </a:pPr>
             <a:r>
-              <a:rPr lang="en-US" sz="1400" dirty="0">
+              <a:rPr lang="en-US" sz="1800" b="1" dirty="0">
                 <a:solidFill>
                   <a:srgbClr val="EDEDED"/>
                 </a:solidFill>
@@ -4469,7 +4469,7 @@
               </a:rPr>
               <a:t>Review</a:t>
             </a:r>
-            <a:endParaRPr lang="en-US" sz="1400" dirty="0"/>
+            <a:endParaRPr lang="en-US" sz="1800" dirty="0"/>
           </a:p>
         </p:txBody>
       </p:sp>
@@ -4481,8 +4481,8 @@
         </p:nvSpPr>
         <p:spPr>
           <a:xfrm>
-            <a:off x="6583680" y="1645920"/>
-            <a:ext cx="365760" cy="914400"/>
+            <a:off x="6492240" y="2011680"/>
+            <a:ext cx="548640" cy="822960"/>
           </a:xfrm>
           <a:prstGeom prst="rect">
             <a:avLst/>
@@ -4498,7 +4498,7 @@
               <a:buNone/>
             </a:pPr>
             <a:r>
-              <a:rPr lang="en-US" sz="2200" dirty="0">
+              <a:rPr lang="en-US" sz="2800" b="1" dirty="0">
                 <a:solidFill>
                   <a:srgbClr val="635BFF"/>
                 </a:solidFill>
@@ -4508,7 +4508,7 @@
               </a:rPr>
               <a:t>→</a:t>
             </a:r>
-            <a:endParaRPr lang="en-US" sz="2200" dirty="0"/>
+            <a:endParaRPr lang="en-US" sz="2800" dirty="0"/>
           </a:p>
         </p:txBody>
       </p:sp>
@@ -4520,23 +4520,18 @@
         </p:nvSpPr>
         <p:spPr>
           <a:xfrm>
-            <a:off x="6949440" y="1645920"/>
-            <a:ext cx="1828800" cy="914400"/>
+            <a:off x="7040880" y="2011680"/>
+            <a:ext cx="1645920" cy="822960"/>
           </a:xfrm>
           <a:prstGeom prst="roundRect">
             <a:avLst>
-              <a:gd name="adj" fmla="val 5000"/>
+              <a:gd name="adj" fmla="val 11111"/>
             </a:avLst>
           </a:prstGeom>
           <a:solidFill>
             <a:srgbClr val="635BFF"/>
           </a:solidFill>
-          <a:ln w="12700">
-            <a:solidFill>
-              <a:srgbClr val="635BFF"/>
-            </a:solidFill>
-            <a:prstDash val="solid"/>
-          </a:ln>
+          <a:ln/>
         </p:spPr>
       </p:sp>
       <p:sp>
@@ -4547,8 +4542,8 @@
         </p:nvSpPr>
         <p:spPr>
           <a:xfrm>
-            <a:off x="6949440" y="1645920"/>
-            <a:ext cx="1828800" cy="914400"/>
+            <a:off x="7040880" y="2011680"/>
+            <a:ext cx="1645920" cy="822960"/>
           </a:xfrm>
           <a:prstGeom prst="rect">
             <a:avLst/>
@@ -4564,7 +4559,7 @@
               <a:buNone/>
             </a:pPr>
             <a:r>
-              <a:rPr lang="en-US" sz="1400" b="1" dirty="0">
+              <a:rPr lang="en-US" sz="1800" b="1" dirty="0">
                 <a:solidFill>
                   <a:srgbClr val="FFFFFF"/>
                 </a:solidFill>
@@ -4574,7 +4569,7 @@
               </a:rPr>
               <a:t>You</a:t>
             </a:r>
-            <a:endParaRPr lang="en-US" sz="1400" dirty="0"/>
+            <a:endParaRPr lang="en-US" sz="1800" dirty="0"/>
           </a:p>
         </p:txBody>
       </p:sp>
@@ -4586,7 +4581,7 @@
         </p:nvSpPr>
         <p:spPr>
           <a:xfrm>
-            <a:off x="914400" y="3017520"/>
+            <a:off x="914400" y="3291840"/>
             <a:ext cx="7315200" cy="548640"/>
           </a:xfrm>
           <a:prstGeom prst="rect">
@@ -5067,16 +5062,19 @@
         </p:nvSpPr>
         <p:spPr>
           <a:xfrm>
-            <a:off x="4544568" y="1097280"/>
-            <a:ext cx="54864" cy="1828800"/>
-          </a:xfrm>
-          <a:prstGeom prst="rect">
-            <a:avLst/>
-          </a:prstGeom>
-          <a:solidFill>
-            <a:srgbClr val="635BFF"/>
-          </a:solidFill>
-          <a:ln/>
+            <a:off x="4572000" y="914400"/>
+            <a:ext cx="0" cy="2377440"/>
+          </a:xfrm>
+          <a:prstGeom prst="line">
+            <a:avLst/>
+          </a:prstGeom>
+          <a:noFill/>
+          <a:ln w="25400">
+            <a:solidFill>
+              <a:srgbClr val="635BFF"/>
+            </a:solidFill>
+            <a:prstDash val="solid"/>
+          </a:ln>
         </p:spPr>
       </p:sp>
       <p:sp>
@@ -5263,13 +5261,13 @@
           </a:xfrm>
           <a:prstGeom prst="roundRect">
             <a:avLst>
-              <a:gd name="adj" fmla="val 7143"/>
+              <a:gd name="adj" fmla="val 11429"/>
             </a:avLst>
           </a:prstGeom>
           <a:solidFill>
             <a:srgbClr val="0A2540"/>
           </a:solidFill>
-          <a:ln w="12700">
+          <a:ln w="19050">
             <a:solidFill>
               <a:srgbClr val="8B95A5"/>
             </a:solidFill>
@@ -5302,7 +5300,7 @@
               <a:buNone/>
             </a:pPr>
             <a:r>
-              <a:rPr lang="en-US" sz="1100" dirty="0">
+              <a:rPr lang="en-US" sz="1200" dirty="0">
                 <a:solidFill>
                   <a:srgbClr val="8B95A5"/>
                 </a:solidFill>
@@ -5312,7 +5310,7 @@
               </a:rPr>
               <a:t>Skeptic</a:t>
             </a:r>
-            <a:endParaRPr lang="en-US" sz="1100" dirty="0"/>
+            <a:endParaRPr lang="en-US" sz="1200" dirty="0"/>
           </a:p>
         </p:txBody>
       </p:sp>
@@ -5329,13 +5327,13 @@
           </a:xfrm>
           <a:prstGeom prst="roundRect">
             <a:avLst>
-              <a:gd name="adj" fmla="val 7143"/>
+              <a:gd name="adj" fmla="val 11429"/>
             </a:avLst>
           </a:prstGeom>
           <a:solidFill>
             <a:srgbClr val="0A2540"/>
           </a:solidFill>
-          <a:ln w="12700">
+          <a:ln w="19050">
             <a:solidFill>
               <a:srgbClr val="8B95A5"/>
             </a:solidFill>
@@ -5368,7 +5366,7 @@
               <a:buNone/>
             </a:pPr>
             <a:r>
-              <a:rPr lang="en-US" sz="1100" dirty="0">
+              <a:rPr lang="en-US" sz="1200" dirty="0">
                 <a:solidFill>
                   <a:srgbClr val="8B95A5"/>
                 </a:solidFill>
@@ -5378,7 +5376,7 @@
               </a:rPr>
               <a:t>Explorer</a:t>
             </a:r>
-            <a:endParaRPr lang="en-US" sz="1100" dirty="0"/>
+            <a:endParaRPr lang="en-US" sz="1200" dirty="0"/>
           </a:p>
         </p:txBody>
       </p:sp>
@@ -5395,13 +5393,13 @@
           </a:xfrm>
           <a:prstGeom prst="roundRect">
             <a:avLst>
-              <a:gd name="adj" fmla="val 7143"/>
+              <a:gd name="adj" fmla="val 11429"/>
             </a:avLst>
           </a:prstGeom>
           <a:solidFill>
             <a:srgbClr val="0A2540"/>
           </a:solidFill>
-          <a:ln w="12700">
+          <a:ln w="19050">
             <a:solidFill>
               <a:srgbClr val="8B95A5"/>
             </a:solidFill>
@@ -5434,7 +5432,7 @@
               <a:buNone/>
             </a:pPr>
             <a:r>
-              <a:rPr lang="en-US" sz="1100" dirty="0">
+              <a:rPr lang="en-US" sz="1200" dirty="0">
                 <a:solidFill>
                   <a:srgbClr val="8B95A5"/>
                 </a:solidFill>
@@ -5444,7 +5442,7 @@
               </a:rPr>
               <a:t>Whisperer</a:t>
             </a:r>
-            <a:endParaRPr lang="en-US" sz="1100" dirty="0"/>
+            <a:endParaRPr lang="en-US" sz="1200" dirty="0"/>
           </a:p>
         </p:txBody>
       </p:sp>
@@ -5461,13 +5459,13 @@
           </a:xfrm>
           <a:prstGeom prst="roundRect">
             <a:avLst>
-              <a:gd name="adj" fmla="val 7143"/>
+              <a:gd name="adj" fmla="val 11429"/>
             </a:avLst>
           </a:prstGeom>
           <a:solidFill>
             <a:srgbClr val="635BFF"/>
           </a:solidFill>
-          <a:ln w="12700">
+          <a:ln w="19050">
             <a:solidFill>
               <a:srgbClr val="635BFF"/>
             </a:solidFill>
@@ -5500,7 +5498,7 @@
               <a:buNone/>
             </a:pPr>
             <a:r>
-              <a:rPr lang="en-US" sz="1100" b="1" dirty="0">
+              <a:rPr lang="en-US" sz="1200" b="1" dirty="0">
                 <a:solidFill>
                   <a:srgbClr val="FFFFFF"/>
                 </a:solidFill>
@@ -5510,7 +5508,7 @@
               </a:rPr>
               <a:t>Strategist</a:t>
             </a:r>
-            <a:endParaRPr lang="en-US" sz="1100" dirty="0"/>
+            <a:endParaRPr lang="en-US" sz="1200" dirty="0"/>
           </a:p>
         </p:txBody>
       </p:sp>
@@ -5527,13 +5525,13 @@
           </a:xfrm>
           <a:prstGeom prst="roundRect">
             <a:avLst>
-              <a:gd name="adj" fmla="val 7143"/>
+              <a:gd name="adj" fmla="val 11429"/>
             </a:avLst>
           </a:prstGeom>
           <a:solidFill>
             <a:srgbClr val="635BFF"/>
           </a:solidFill>
-          <a:ln w="12700">
+          <a:ln w="19050">
             <a:solidFill>
               <a:srgbClr val="635BFF"/>
             </a:solidFill>
@@ -5566,7 +5564,7 @@
               <a:buNone/>
             </a:pPr>
             <a:r>
-              <a:rPr lang="en-US" sz="1100" b="1" dirty="0">
+              <a:rPr lang="en-US" sz="1200" b="1" dirty="0">
                 <a:solidFill>
                   <a:srgbClr val="FFFFFF"/>
                 </a:solidFill>
@@ -5576,7 +5574,7 @@
               </a:rPr>
               <a:t>Operator</a:t>
             </a:r>
-            <a:endParaRPr lang="en-US" sz="1100" dirty="0"/>
+            <a:endParaRPr lang="en-US" sz="1200" dirty="0"/>
           </a:p>
         </p:txBody>
       </p:sp>
@@ -5593,13 +5591,13 @@
           </a:xfrm>
           <a:prstGeom prst="roundRect">
             <a:avLst>
-              <a:gd name="adj" fmla="val 7143"/>
+              <a:gd name="adj" fmla="val 11429"/>
             </a:avLst>
           </a:prstGeom>
           <a:solidFill>
             <a:srgbClr val="635BFF"/>
           </a:solidFill>
-          <a:ln w="12700">
+          <a:ln w="19050">
             <a:solidFill>
               <a:srgbClr val="635BFF"/>
             </a:solidFill>
@@ -5632,7 +5630,7 @@
               <a:buNone/>
             </a:pPr>
             <a:r>
-              <a:rPr lang="en-US" sz="1100" b="1" dirty="0">
+              <a:rPr lang="en-US" sz="1200" b="1" dirty="0">
                 <a:solidFill>
                   <a:srgbClr val="FFFFFF"/>
                 </a:solidFill>
@@ -5642,7 +5640,7 @@
               </a:rPr>
               <a:t>Orchestrator</a:t>
             </a:r>
-            <a:endParaRPr lang="en-US" sz="1100" dirty="0"/>
+            <a:endParaRPr lang="en-US" sz="1200" dirty="0"/>
           </a:p>
         </p:txBody>
       </p:sp>
@@ -5659,13 +5657,13 @@
           </a:xfrm>
           <a:prstGeom prst="roundRect">
             <a:avLst>
-              <a:gd name="adj" fmla="val 7143"/>
+              <a:gd name="adj" fmla="val 11429"/>
             </a:avLst>
           </a:prstGeom>
           <a:solidFill>
             <a:srgbClr val="0A2540"/>
           </a:solidFill>
-          <a:ln w="12700">
+          <a:ln w="19050">
             <a:solidFill>
               <a:srgbClr val="8B95A5"/>
             </a:solidFill>
@@ -5698,7 +5696,7 @@
               <a:buNone/>
             </a:pPr>
             <a:r>
-              <a:rPr lang="en-US" sz="1100" dirty="0">
+              <a:rPr lang="en-US" sz="1200" dirty="0">
                 <a:solidFill>
                   <a:srgbClr val="8B95A5"/>
                 </a:solidFill>
@@ -5708,7 +5706,7 @@
               </a:rPr>
               <a:t>Builder</a:t>
             </a:r>
-            <a:endParaRPr lang="en-US" sz="1100" dirty="0"/>
+            <a:endParaRPr lang="en-US" sz="1200" dirty="0"/>
           </a:p>
         </p:txBody>
       </p:sp>
@@ -6050,8 +6048,8 @@
         </p:nvSpPr>
         <p:spPr>
           <a:xfrm>
-            <a:off x="914400" y="731520"/>
-            <a:ext cx="7315200" cy="2286000"/>
+            <a:off x="457200" y="914400"/>
+            <a:ext cx="8229600" cy="2286000"/>
           </a:xfrm>
           <a:prstGeom prst="rect">
             <a:avLst/>
@@ -6069,7 +6067,7 @@
             <a:r>
               <a:rPr lang="en-US" sz="12000" b="1" dirty="0">
                 <a:solidFill>
-                  <a:srgbClr val="635BFF"/>
+                  <a:srgbClr val="FF6B8A"/>
                 </a:solidFill>
                 <a:latin typeface="Georgia" pitchFamily="34" charset="0"/>
                 <a:ea typeface="Georgia" pitchFamily="34" charset="-122"/>
@@ -6089,7 +6087,7 @@
         </p:nvSpPr>
         <p:spPr>
           <a:xfrm>
-            <a:off x="1371600" y="3200400"/>
+            <a:off x="1371600" y="3291840"/>
             <a:ext cx="6400800" cy="731520"/>
           </a:xfrm>
           <a:prstGeom prst="rect">
@@ -6106,7 +6104,7 @@
               <a:buNone/>
             </a:pPr>
             <a:r>
-              <a:rPr lang="en-US" sz="2400" dirty="0">
+              <a:rPr lang="en-US" sz="2800" dirty="0">
                 <a:solidFill>
                   <a:srgbClr val="8B95A5"/>
                 </a:solidFill>
@@ -6116,7 +6114,7 @@
               </a:rPr>
               <a:t>of you being the bottleneck</a:t>
             </a:r>
-            <a:endParaRPr lang="en-US" sz="2400" dirty="0"/>
+            <a:endParaRPr lang="en-US" sz="2800" dirty="0"/>
           </a:p>
         </p:txBody>
       </p:sp>
@@ -6182,8 +6180,8 @@
         </p:nvSpPr>
         <p:spPr>
           <a:xfrm>
-            <a:off x="914400" y="731520"/>
-            <a:ext cx="7315200" cy="2286000"/>
+            <a:off x="457200" y="914400"/>
+            <a:ext cx="8229600" cy="2286000"/>
           </a:xfrm>
           <a:prstGeom prst="rect">
             <a:avLst/>
@@ -6201,7 +6199,7 @@
             <a:r>
               <a:rPr lang="en-US" sz="12000" b="1" dirty="0">
                 <a:solidFill>
-                  <a:srgbClr val="635BFF"/>
+                  <a:srgbClr val="09825D"/>
                 </a:solidFill>
                 <a:latin typeface="Georgia" pitchFamily="34" charset="0"/>
                 <a:ea typeface="Georgia" pitchFamily="34" charset="-122"/>
@@ -6221,7 +6219,7 @@
         </p:nvSpPr>
         <p:spPr>
           <a:xfrm>
-            <a:off x="1371600" y="3200400"/>
+            <a:off x="1371600" y="3291840"/>
             <a:ext cx="6400800" cy="731520"/>
           </a:xfrm>
           <a:prstGeom prst="rect">
@@ -6238,7 +6236,7 @@
               <a:buNone/>
             </a:pPr>
             <a:r>
-              <a:rPr lang="en-US" sz="2400" dirty="0">
+              <a:rPr lang="en-US" sz="2800" dirty="0">
                 <a:solidFill>
                   <a:srgbClr val="8B95A5"/>
                 </a:solidFill>
@@ -6248,7 +6246,7 @@
               </a:rPr>
               <a:t>of judgment — the part only humans can do</a:t>
             </a:r>
-            <a:endParaRPr lang="en-US" sz="2400" dirty="0"/>
+            <a:endParaRPr lang="en-US" sz="2800" dirty="0"/>
           </a:p>
         </p:txBody>
       </p:sp>
@@ -6319,13 +6317,13 @@
           </a:xfrm>
           <a:prstGeom prst="roundRect">
             <a:avLst>
-              <a:gd name="adj" fmla="val 7143"/>
+              <a:gd name="adj" fmla="val 11429"/>
             </a:avLst>
           </a:prstGeom>
           <a:solidFill>
             <a:srgbClr val="0A2540"/>
           </a:solidFill>
-          <a:ln w="12700">
+          <a:ln w="19050">
             <a:solidFill>
               <a:srgbClr val="8B95A5"/>
             </a:solidFill>
@@ -6358,7 +6356,7 @@
               <a:buNone/>
             </a:pPr>
             <a:r>
-              <a:rPr lang="en-US" sz="1100" dirty="0">
+              <a:rPr lang="en-US" sz="1200" dirty="0">
                 <a:solidFill>
                   <a:srgbClr val="8B95A5"/>
                 </a:solidFill>
@@ -6368,7 +6366,7 @@
               </a:rPr>
               <a:t>Skeptic</a:t>
             </a:r>
-            <a:endParaRPr lang="en-US" sz="1100" dirty="0"/>
+            <a:endParaRPr lang="en-US" sz="1200" dirty="0"/>
           </a:p>
         </p:txBody>
       </p:sp>
@@ -6385,13 +6383,13 @@
           </a:xfrm>
           <a:prstGeom prst="roundRect">
             <a:avLst>
-              <a:gd name="adj" fmla="val 7143"/>
+              <a:gd name="adj" fmla="val 11429"/>
             </a:avLst>
           </a:prstGeom>
           <a:solidFill>
             <a:srgbClr val="635BFF"/>
           </a:solidFill>
-          <a:ln w="12700">
+          <a:ln w="19050">
             <a:solidFill>
               <a:srgbClr val="635BFF"/>
             </a:solidFill>
@@ -6424,7 +6422,7 @@
               <a:buNone/>
             </a:pPr>
             <a:r>
-              <a:rPr lang="en-US" sz="1100" b="1" dirty="0">
+              <a:rPr lang="en-US" sz="1200" b="1" dirty="0">
                 <a:solidFill>
                   <a:srgbClr val="FFFFFF"/>
                 </a:solidFill>
@@ -6434,7 +6432,7 @@
               </a:rPr>
               <a:t>Explorer</a:t>
             </a:r>
-            <a:endParaRPr lang="en-US" sz="1100" dirty="0"/>
+            <a:endParaRPr lang="en-US" sz="1200" dirty="0"/>
           </a:p>
         </p:txBody>
       </p:sp>
@@ -6451,13 +6449,13 @@
           </a:xfrm>
           <a:prstGeom prst="roundRect">
             <a:avLst>
-              <a:gd name="adj" fmla="val 7143"/>
+              <a:gd name="adj" fmla="val 11429"/>
             </a:avLst>
           </a:prstGeom>
           <a:solidFill>
             <a:srgbClr val="635BFF"/>
           </a:solidFill>
-          <a:ln w="12700">
+          <a:ln w="19050">
             <a:solidFill>
               <a:srgbClr val="635BFF"/>
             </a:solidFill>
@@ -6490,7 +6488,7 @@
               <a:buNone/>
             </a:pPr>
             <a:r>
-              <a:rPr lang="en-US" sz="1100" b="1" dirty="0">
+              <a:rPr lang="en-US" sz="1200" b="1" dirty="0">
                 <a:solidFill>
                   <a:srgbClr val="FFFFFF"/>
                 </a:solidFill>
@@ -6500,7 +6498,7 @@
               </a:rPr>
               <a:t>Whisperer</a:t>
             </a:r>
-            <a:endParaRPr lang="en-US" sz="1100" dirty="0"/>
+            <a:endParaRPr lang="en-US" sz="1200" dirty="0"/>
           </a:p>
         </p:txBody>
       </p:sp>
@@ -6517,13 +6515,13 @@
           </a:xfrm>
           <a:prstGeom prst="roundRect">
             <a:avLst>
-              <a:gd name="adj" fmla="val 7143"/>
+              <a:gd name="adj" fmla="val 11429"/>
             </a:avLst>
           </a:prstGeom>
           <a:solidFill>
             <a:srgbClr val="635BFF"/>
           </a:solidFill>
-          <a:ln w="12700">
+          <a:ln w="19050">
             <a:solidFill>
               <a:srgbClr val="635BFF"/>
             </a:solidFill>
@@ -6556,7 +6554,7 @@
               <a:buNone/>
             </a:pPr>
             <a:r>
-              <a:rPr lang="en-US" sz="1100" b="1" dirty="0">
+              <a:rPr lang="en-US" sz="1200" b="1" dirty="0">
                 <a:solidFill>
                   <a:srgbClr val="FFFFFF"/>
                 </a:solidFill>
@@ -6566,7 +6564,7 @@
               </a:rPr>
               <a:t>Strategist</a:t>
             </a:r>
-            <a:endParaRPr lang="en-US" sz="1100" dirty="0"/>
+            <a:endParaRPr lang="en-US" sz="1200" dirty="0"/>
           </a:p>
         </p:txBody>
       </p:sp>
@@ -6583,13 +6581,13 @@
           </a:xfrm>
           <a:prstGeom prst="roundRect">
             <a:avLst>
-              <a:gd name="adj" fmla="val 7143"/>
+              <a:gd name="adj" fmla="val 11429"/>
             </a:avLst>
           </a:prstGeom>
           <a:solidFill>
             <a:srgbClr val="635BFF"/>
           </a:solidFill>
-          <a:ln w="12700">
+          <a:ln w="19050">
             <a:solidFill>
               <a:srgbClr val="635BFF"/>
             </a:solidFill>
@@ -6622,7 +6620,7 @@
               <a:buNone/>
             </a:pPr>
             <a:r>
-              <a:rPr lang="en-US" sz="1100" b="1" dirty="0">
+              <a:rPr lang="en-US" sz="1200" b="1" dirty="0">
                 <a:solidFill>
                   <a:srgbClr val="FFFFFF"/>
                 </a:solidFill>
@@ -6632,7 +6630,7 @@
               </a:rPr>
               <a:t>Operator</a:t>
             </a:r>
-            <a:endParaRPr lang="en-US" sz="1100" dirty="0"/>
+            <a:endParaRPr lang="en-US" sz="1200" dirty="0"/>
           </a:p>
         </p:txBody>
       </p:sp>
@@ -6649,13 +6647,13 @@
           </a:xfrm>
           <a:prstGeom prst="roundRect">
             <a:avLst>
-              <a:gd name="adj" fmla="val 7143"/>
+              <a:gd name="adj" fmla="val 11429"/>
             </a:avLst>
           </a:prstGeom>
           <a:solidFill>
             <a:srgbClr val="635BFF"/>
           </a:solidFill>
-          <a:ln w="12700">
+          <a:ln w="19050">
             <a:solidFill>
               <a:srgbClr val="635BFF"/>
             </a:solidFill>
@@ -6688,7 +6686,7 @@
               <a:buNone/>
             </a:pPr>
             <a:r>
-              <a:rPr lang="en-US" sz="1100" b="1" dirty="0">
+              <a:rPr lang="en-US" sz="1200" b="1" dirty="0">
                 <a:solidFill>
                   <a:srgbClr val="FFFFFF"/>
                 </a:solidFill>
@@ -6698,7 +6696,7 @@
               </a:rPr>
               <a:t>Orchestrator</a:t>
             </a:r>
-            <a:endParaRPr lang="en-US" sz="1100" dirty="0"/>
+            <a:endParaRPr lang="en-US" sz="1200" dirty="0"/>
           </a:p>
         </p:txBody>
       </p:sp>
@@ -6715,13 +6713,13 @@
           </a:xfrm>
           <a:prstGeom prst="roundRect">
             <a:avLst>
-              <a:gd name="adj" fmla="val 7143"/>
+              <a:gd name="adj" fmla="val 11429"/>
             </a:avLst>
           </a:prstGeom>
           <a:solidFill>
             <a:srgbClr val="0A2540"/>
           </a:solidFill>
-          <a:ln w="12700">
+          <a:ln w="19050">
             <a:solidFill>
               <a:srgbClr val="8B95A5"/>
             </a:solidFill>
@@ -6754,7 +6752,7 @@
               <a:buNone/>
             </a:pPr>
             <a:r>
-              <a:rPr lang="en-US" sz="1100" dirty="0">
+              <a:rPr lang="en-US" sz="1200" dirty="0">
                 <a:solidFill>
                   <a:srgbClr val="8B95A5"/>
                 </a:solidFill>
@@ -6764,7 +6762,7 @@
               </a:rPr>
               <a:t>Builder</a:t>
             </a:r>
-            <a:endParaRPr lang="en-US" sz="1100" dirty="0"/>
+            <a:endParaRPr lang="en-US" sz="1200" dirty="0"/>
           </a:p>
         </p:txBody>
       </p:sp>
@@ -6996,23 +6994,18 @@
         </p:nvSpPr>
         <p:spPr>
           <a:xfrm>
-            <a:off x="365760" y="1645920"/>
-            <a:ext cx="1828800" cy="914400"/>
+            <a:off x="457200" y="2011680"/>
+            <a:ext cx="1645920" cy="822960"/>
           </a:xfrm>
           <a:prstGeom prst="roundRect">
             <a:avLst>
-              <a:gd name="adj" fmla="val 5000"/>
+              <a:gd name="adj" fmla="val 11111"/>
             </a:avLst>
           </a:prstGeom>
           <a:solidFill>
             <a:srgbClr val="635BFF"/>
           </a:solidFill>
-          <a:ln w="12700">
-            <a:solidFill>
-              <a:srgbClr val="635BFF"/>
-            </a:solidFill>
-            <a:prstDash val="solid"/>
-          </a:ln>
+          <a:ln/>
         </p:spPr>
       </p:sp>
       <p:sp>
@@ -7023,8 +7016,8 @@
         </p:nvSpPr>
         <p:spPr>
           <a:xfrm>
-            <a:off x="365760" y="1645920"/>
-            <a:ext cx="1828800" cy="914400"/>
+            <a:off x="457200" y="2011680"/>
+            <a:ext cx="1645920" cy="822960"/>
           </a:xfrm>
           <a:prstGeom prst="rect">
             <a:avLst/>
@@ -7040,7 +7033,7 @@
               <a:buNone/>
             </a:pPr>
             <a:r>
-              <a:rPr lang="en-US" sz="1400" b="1" dirty="0">
+              <a:rPr lang="en-US" sz="1800" b="1" dirty="0">
                 <a:solidFill>
                   <a:srgbClr val="FFFFFF"/>
                 </a:solidFill>
@@ -7050,7 +7043,7 @@
               </a:rPr>
               <a:t>You search</a:t>
             </a:r>
-            <a:endParaRPr lang="en-US" sz="1400" dirty="0"/>
+            <a:endParaRPr lang="en-US" sz="1800" dirty="0"/>
           </a:p>
         </p:txBody>
       </p:sp>
@@ -7062,8 +7055,8 @@
         </p:nvSpPr>
         <p:spPr>
           <a:xfrm>
-            <a:off x="2194560" y="1645920"/>
-            <a:ext cx="365760" cy="914400"/>
+            <a:off x="2103120" y="2011680"/>
+            <a:ext cx="548640" cy="822960"/>
           </a:xfrm>
           <a:prstGeom prst="rect">
             <a:avLst/>
@@ -7079,7 +7072,7 @@
               <a:buNone/>
             </a:pPr>
             <a:r>
-              <a:rPr lang="en-US" sz="2200" dirty="0">
+              <a:rPr lang="en-US" sz="2800" b="1" dirty="0">
                 <a:solidFill>
                   <a:srgbClr val="635BFF"/>
                 </a:solidFill>
@@ -7089,7 +7082,7 @@
               </a:rPr>
               <a:t>→</a:t>
             </a:r>
-            <a:endParaRPr lang="en-US" sz="2200" dirty="0"/>
+            <a:endParaRPr lang="en-US" sz="2800" dirty="0"/>
           </a:p>
         </p:txBody>
       </p:sp>
@@ -7101,23 +7094,18 @@
         </p:nvSpPr>
         <p:spPr>
           <a:xfrm>
-            <a:off x="2560320" y="1645920"/>
-            <a:ext cx="1828800" cy="914400"/>
+            <a:off x="2651760" y="2011680"/>
+            <a:ext cx="1645920" cy="822960"/>
           </a:xfrm>
           <a:prstGeom prst="roundRect">
             <a:avLst>
-              <a:gd name="adj" fmla="val 5000"/>
+              <a:gd name="adj" fmla="val 11111"/>
             </a:avLst>
           </a:prstGeom>
           <a:solidFill>
             <a:srgbClr val="635BFF"/>
           </a:solidFill>
-          <a:ln w="12700">
-            <a:solidFill>
-              <a:srgbClr val="635BFF"/>
-            </a:solidFill>
-            <a:prstDash val="solid"/>
-          </a:ln>
+          <a:ln/>
         </p:spPr>
       </p:sp>
       <p:sp>
@@ -7128,8 +7116,8 @@
         </p:nvSpPr>
         <p:spPr>
           <a:xfrm>
-            <a:off x="2560320" y="1645920"/>
-            <a:ext cx="1828800" cy="914400"/>
+            <a:off x="2651760" y="2011680"/>
+            <a:ext cx="1645920" cy="822960"/>
           </a:xfrm>
           <a:prstGeom prst="rect">
             <a:avLst/>
@@ -7145,7 +7133,7 @@
               <a:buNone/>
             </a:pPr>
             <a:r>
-              <a:rPr lang="en-US" sz="1400" b="1" dirty="0">
+              <a:rPr lang="en-US" sz="1800" b="1" dirty="0">
                 <a:solidFill>
                   <a:srgbClr val="FFFFFF"/>
                 </a:solidFill>
@@ -7155,7 +7143,7 @@
               </a:rPr>
               <a:t>You paste</a:t>
             </a:r>
-            <a:endParaRPr lang="en-US" sz="1400" dirty="0"/>
+            <a:endParaRPr lang="en-US" sz="1800" dirty="0"/>
           </a:p>
         </p:txBody>
       </p:sp>
@@ -7167,8 +7155,8 @@
         </p:nvSpPr>
         <p:spPr>
           <a:xfrm>
-            <a:off x="4389120" y="1645920"/>
-            <a:ext cx="365760" cy="914400"/>
+            <a:off x="4297680" y="2011680"/>
+            <a:ext cx="548640" cy="822960"/>
           </a:xfrm>
           <a:prstGeom prst="rect">
             <a:avLst/>
@@ -7184,7 +7172,7 @@
               <a:buNone/>
             </a:pPr>
             <a:r>
-              <a:rPr lang="en-US" sz="2200" dirty="0">
+              <a:rPr lang="en-US" sz="2800" b="1" dirty="0">
                 <a:solidFill>
                   <a:srgbClr val="635BFF"/>
                 </a:solidFill>
@@ -7194,7 +7182,7 @@
               </a:rPr>
               <a:t>→</a:t>
             </a:r>
-            <a:endParaRPr lang="en-US" sz="2200" dirty="0"/>
+            <a:endParaRPr lang="en-US" sz="2800" dirty="0"/>
           </a:p>
         </p:txBody>
       </p:sp>
@@ -7206,23 +7194,18 @@
         </p:nvSpPr>
         <p:spPr>
           <a:xfrm>
-            <a:off x="4754880" y="1645920"/>
-            <a:ext cx="1828800" cy="914400"/>
+            <a:off x="4846320" y="2011680"/>
+            <a:ext cx="1645920" cy="822960"/>
           </a:xfrm>
           <a:prstGeom prst="roundRect">
             <a:avLst>
-              <a:gd name="adj" fmla="val 5000"/>
+              <a:gd name="adj" fmla="val 11111"/>
             </a:avLst>
           </a:prstGeom>
           <a:solidFill>
             <a:srgbClr val="635BFF"/>
           </a:solidFill>
-          <a:ln w="12700">
-            <a:solidFill>
-              <a:srgbClr val="635BFF"/>
-            </a:solidFill>
-            <a:prstDash val="solid"/>
-          </a:ln>
+          <a:ln/>
         </p:spPr>
       </p:sp>
       <p:sp>
@@ -7233,8 +7216,8 @@
         </p:nvSpPr>
         <p:spPr>
           <a:xfrm>
-            <a:off x="4754880" y="1645920"/>
-            <a:ext cx="1828800" cy="914400"/>
+            <a:off x="4846320" y="2011680"/>
+            <a:ext cx="1645920" cy="822960"/>
           </a:xfrm>
           <a:prstGeom prst="rect">
             <a:avLst/>
@@ -7250,7 +7233,7 @@
               <a:buNone/>
             </a:pPr>
             <a:r>
-              <a:rPr lang="en-US" sz="1400" b="1" dirty="0">
+              <a:rPr lang="en-US" sz="1800" b="1" dirty="0">
                 <a:solidFill>
                   <a:srgbClr val="FFFFFF"/>
                 </a:solidFill>
@@ -7260,7 +7243,7 @@
               </a:rPr>
               <a:t>AI drafts</a:t>
             </a:r>
-            <a:endParaRPr lang="en-US" sz="1400" dirty="0"/>
+            <a:endParaRPr lang="en-US" sz="1800" dirty="0"/>
           </a:p>
         </p:txBody>
       </p:sp>
@@ -7272,8 +7255,8 @@
         </p:nvSpPr>
         <p:spPr>
           <a:xfrm>
-            <a:off x="6583680" y="1645920"/>
-            <a:ext cx="365760" cy="914400"/>
+            <a:off x="6492240" y="2011680"/>
+            <a:ext cx="548640" cy="822960"/>
           </a:xfrm>
           <a:prstGeom prst="rect">
             <a:avLst/>
@@ -7289,7 +7272,7 @@
               <a:buNone/>
             </a:pPr>
             <a:r>
-              <a:rPr lang="en-US" sz="2200" dirty="0">
+              <a:rPr lang="en-US" sz="2800" b="1" dirty="0">
                 <a:solidFill>
                   <a:srgbClr val="635BFF"/>
                 </a:solidFill>
@@ -7299,7 +7282,7 @@
               </a:rPr>
               <a:t>→</a:t>
             </a:r>
-            <a:endParaRPr lang="en-US" sz="2200" dirty="0"/>
+            <a:endParaRPr lang="en-US" sz="2800" dirty="0"/>
           </a:p>
         </p:txBody>
       </p:sp>
@@ -7311,23 +7294,18 @@
         </p:nvSpPr>
         <p:spPr>
           <a:xfrm>
-            <a:off x="6949440" y="1645920"/>
-            <a:ext cx="1828800" cy="914400"/>
+            <a:off x="7040880" y="2011680"/>
+            <a:ext cx="1645920" cy="822960"/>
           </a:xfrm>
           <a:prstGeom prst="roundRect">
             <a:avLst>
-              <a:gd name="adj" fmla="val 5000"/>
+              <a:gd name="adj" fmla="val 11111"/>
             </a:avLst>
           </a:prstGeom>
           <a:solidFill>
             <a:srgbClr val="635BFF"/>
           </a:solidFill>
-          <a:ln w="12700">
-            <a:solidFill>
-              <a:srgbClr val="635BFF"/>
-            </a:solidFill>
-            <a:prstDash val="solid"/>
-          </a:ln>
+          <a:ln/>
         </p:spPr>
       </p:sp>
       <p:sp>
@@ -7338,8 +7316,8 @@
         </p:nvSpPr>
         <p:spPr>
           <a:xfrm>
-            <a:off x="6949440" y="1645920"/>
-            <a:ext cx="1828800" cy="914400"/>
+            <a:off x="7040880" y="2011680"/>
+            <a:ext cx="1645920" cy="822960"/>
           </a:xfrm>
           <a:prstGeom prst="rect">
             <a:avLst/>
@@ -7355,7 +7333,7 @@
               <a:buNone/>
             </a:pPr>
             <a:r>
-              <a:rPr lang="en-US" sz="1400" b="1" dirty="0">
+              <a:rPr lang="en-US" sz="1800" b="1" dirty="0">
                 <a:solidFill>
                   <a:srgbClr val="FFFFFF"/>
                 </a:solidFill>
@@ -7365,7 +7343,7 @@
               </a:rPr>
               <a:t>You apply</a:t>
             </a:r>
-            <a:endParaRPr lang="en-US" sz="1400" dirty="0"/>
+            <a:endParaRPr lang="en-US" sz="1800" dirty="0"/>
           </a:p>
         </p:txBody>
       </p:sp>
@@ -7377,7 +7355,7 @@
         </p:nvSpPr>
         <p:spPr>
           <a:xfrm>
-            <a:off x="914400" y="3017520"/>
+            <a:off x="914400" y="3291840"/>
             <a:ext cx="7315200" cy="548640"/>
           </a:xfrm>
           <a:prstGeom prst="rect">
@@ -7580,18 +7558,18 @@
         </p:nvSpPr>
         <p:spPr>
           <a:xfrm>
-            <a:off x="365760" y="1645920"/>
-            <a:ext cx="1828800" cy="914400"/>
+            <a:off x="457200" y="2011680"/>
+            <a:ext cx="1645920" cy="822960"/>
           </a:xfrm>
           <a:prstGeom prst="roundRect">
             <a:avLst>
-              <a:gd name="adj" fmla="val 5000"/>
+              <a:gd name="adj" fmla="val 11111"/>
             </a:avLst>
           </a:prstGeom>
           <a:solidFill>
             <a:srgbClr val="0A2540"/>
           </a:solidFill>
-          <a:ln w="12700">
+          <a:ln w="19050">
             <a:solidFill>
               <a:srgbClr val="8B95A5"/>
             </a:solidFill>
@@ -7607,8 +7585,8 @@
         </p:nvSpPr>
         <p:spPr>
           <a:xfrm>
-            <a:off x="365760" y="1645920"/>
-            <a:ext cx="1828800" cy="914400"/>
+            <a:off x="457200" y="2011680"/>
+            <a:ext cx="1645920" cy="822960"/>
           </a:xfrm>
           <a:prstGeom prst="rect">
             <a:avLst/>
@@ -7624,7 +7602,7 @@
               <a:buNone/>
             </a:pPr>
             <a:r>
-              <a:rPr lang="en-US" sz="1400" dirty="0">
+              <a:rPr lang="en-US" sz="1800" b="1" dirty="0">
                 <a:solidFill>
                   <a:srgbClr val="EDEDED"/>
                 </a:solidFill>
@@ -7634,7 +7612,7 @@
               </a:rPr>
               <a:t>Agent retrieves</a:t>
             </a:r>
-            <a:endParaRPr lang="en-US" sz="1400" dirty="0"/>
+            <a:endParaRPr lang="en-US" sz="1800" dirty="0"/>
           </a:p>
         </p:txBody>
       </p:sp>
@@ -7646,8 +7624,8 @@
         </p:nvSpPr>
         <p:spPr>
           <a:xfrm>
-            <a:off x="2194560" y="1645920"/>
-            <a:ext cx="365760" cy="914400"/>
+            <a:off x="2103120" y="2011680"/>
+            <a:ext cx="548640" cy="822960"/>
           </a:xfrm>
           <a:prstGeom prst="rect">
             <a:avLst/>
@@ -7663,7 +7641,7 @@
               <a:buNone/>
             </a:pPr>
             <a:r>
-              <a:rPr lang="en-US" sz="2200" dirty="0">
+              <a:rPr lang="en-US" sz="2800" b="1" dirty="0">
                 <a:solidFill>
                   <a:srgbClr val="635BFF"/>
                 </a:solidFill>
@@ -7673,7 +7651,7 @@
               </a:rPr>
               <a:t>→</a:t>
             </a:r>
-            <a:endParaRPr lang="en-US" sz="2200" dirty="0"/>
+            <a:endParaRPr lang="en-US" sz="2800" dirty="0"/>
           </a:p>
         </p:txBody>
       </p:sp>
@@ -7685,18 +7663,18 @@
         </p:nvSpPr>
         <p:spPr>
           <a:xfrm>
-            <a:off x="2560320" y="1645920"/>
-            <a:ext cx="1828800" cy="914400"/>
+            <a:off x="2651760" y="2011680"/>
+            <a:ext cx="1645920" cy="822960"/>
           </a:xfrm>
           <a:prstGeom prst="roundRect">
             <a:avLst>
-              <a:gd name="adj" fmla="val 5000"/>
+              <a:gd name="adj" fmla="val 11111"/>
             </a:avLst>
           </a:prstGeom>
           <a:solidFill>
             <a:srgbClr val="0A2540"/>
           </a:solidFill>
-          <a:ln w="12700">
+          <a:ln w="19050">
             <a:solidFill>
               <a:srgbClr val="8B95A5"/>
             </a:solidFill>
@@ -7712,8 +7690,8 @@
         </p:nvSpPr>
         <p:spPr>
           <a:xfrm>
-            <a:off x="2560320" y="1645920"/>
-            <a:ext cx="1828800" cy="914400"/>
+            <a:off x="2651760" y="2011680"/>
+            <a:ext cx="1645920" cy="822960"/>
           </a:xfrm>
           <a:prstGeom prst="rect">
             <a:avLst/>
@@ -7729,7 +7707,7 @@
               <a:buNone/>
             </a:pPr>
             <a:r>
-              <a:rPr lang="en-US" sz="1400" dirty="0">
+              <a:rPr lang="en-US" sz="1800" b="1" dirty="0">
                 <a:solidFill>
                   <a:srgbClr val="EDEDED"/>
                 </a:solidFill>
@@ -7739,7 +7717,7 @@
               </a:rPr>
               <a:t>Agent identifies</a:t>
             </a:r>
-            <a:endParaRPr lang="en-US" sz="1400" dirty="0"/>
+            <a:endParaRPr lang="en-US" sz="1800" dirty="0"/>
           </a:p>
         </p:txBody>
       </p:sp>
@@ -7751,8 +7729,8 @@
         </p:nvSpPr>
         <p:spPr>
           <a:xfrm>
-            <a:off x="4389120" y="1645920"/>
-            <a:ext cx="365760" cy="914400"/>
+            <a:off x="4297680" y="2011680"/>
+            <a:ext cx="548640" cy="822960"/>
           </a:xfrm>
           <a:prstGeom prst="rect">
             <a:avLst/>
@@ -7768,7 +7746,7 @@
               <a:buNone/>
             </a:pPr>
             <a:r>
-              <a:rPr lang="en-US" sz="2200" dirty="0">
+              <a:rPr lang="en-US" sz="2800" b="1" dirty="0">
                 <a:solidFill>
                   <a:srgbClr val="635BFF"/>
                 </a:solidFill>
@@ -7778,7 +7756,7 @@
               </a:rPr>
               <a:t>→</a:t>
             </a:r>
-            <a:endParaRPr lang="en-US" sz="2200" dirty="0"/>
+            <a:endParaRPr lang="en-US" sz="2800" dirty="0"/>
           </a:p>
         </p:txBody>
       </p:sp>
@@ -7790,18 +7768,18 @@
         </p:nvSpPr>
         <p:spPr>
           <a:xfrm>
-            <a:off x="4754880" y="1645920"/>
-            <a:ext cx="1828800" cy="914400"/>
+            <a:off x="4846320" y="2011680"/>
+            <a:ext cx="1645920" cy="822960"/>
           </a:xfrm>
           <a:prstGeom prst="roundRect">
             <a:avLst>
-              <a:gd name="adj" fmla="val 5000"/>
+              <a:gd name="adj" fmla="val 11111"/>
             </a:avLst>
           </a:prstGeom>
           <a:solidFill>
             <a:srgbClr val="0A2540"/>
           </a:solidFill>
-          <a:ln w="12700">
+          <a:ln w="19050">
             <a:solidFill>
               <a:srgbClr val="8B95A5"/>
             </a:solidFill>
@@ -7817,8 +7795,8 @@
         </p:nvSpPr>
         <p:spPr>
           <a:xfrm>
-            <a:off x="4754880" y="1645920"/>
-            <a:ext cx="1828800" cy="914400"/>
+            <a:off x="4846320" y="2011680"/>
+            <a:ext cx="1645920" cy="822960"/>
           </a:xfrm>
           <a:prstGeom prst="rect">
             <a:avLst/>
@@ -7834,7 +7812,7 @@
               <a:buNone/>
             </a:pPr>
             <a:r>
-              <a:rPr lang="en-US" sz="1400" dirty="0">
+              <a:rPr lang="en-US" sz="1800" b="1" dirty="0">
                 <a:solidFill>
                   <a:srgbClr val="EDEDED"/>
                 </a:solidFill>
@@ -7844,7 +7822,7 @@
               </a:rPr>
               <a:t>Agent creates</a:t>
             </a:r>
-            <a:endParaRPr lang="en-US" sz="1400" dirty="0"/>
+            <a:endParaRPr lang="en-US" sz="1800" dirty="0"/>
           </a:p>
         </p:txBody>
       </p:sp>
@@ -7856,8 +7834,8 @@
         </p:nvSpPr>
         <p:spPr>
           <a:xfrm>
-            <a:off x="6583680" y="1645920"/>
-            <a:ext cx="365760" cy="914400"/>
+            <a:off x="6492240" y="2011680"/>
+            <a:ext cx="548640" cy="822960"/>
           </a:xfrm>
           <a:prstGeom prst="rect">
             <a:avLst/>
@@ -7873,7 +7851,7 @@
               <a:buNone/>
             </a:pPr>
             <a:r>
-              <a:rPr lang="en-US" sz="2200" dirty="0">
+              <a:rPr lang="en-US" sz="2800" b="1" dirty="0">
                 <a:solidFill>
                   <a:srgbClr val="635BFF"/>
                 </a:solidFill>
@@ -7883,7 +7861,7 @@
               </a:rPr>
               <a:t>→</a:t>
             </a:r>
-            <a:endParaRPr lang="en-US" sz="2200" dirty="0"/>
+            <a:endParaRPr lang="en-US" sz="2800" dirty="0"/>
           </a:p>
         </p:txBody>
       </p:sp>
@@ -7895,23 +7873,18 @@
         </p:nvSpPr>
         <p:spPr>
           <a:xfrm>
-            <a:off x="6949440" y="1645920"/>
-            <a:ext cx="1828800" cy="914400"/>
+            <a:off x="7040880" y="2011680"/>
+            <a:ext cx="1645920" cy="822960"/>
           </a:xfrm>
           <a:prstGeom prst="roundRect">
             <a:avLst>
-              <a:gd name="adj" fmla="val 5000"/>
+              <a:gd name="adj" fmla="val 11111"/>
             </a:avLst>
           </a:prstGeom>
           <a:solidFill>
             <a:srgbClr val="635BFF"/>
           </a:solidFill>
-          <a:ln w="12700">
-            <a:solidFill>
-              <a:srgbClr val="635BFF"/>
-            </a:solidFill>
-            <a:prstDash val="solid"/>
-          </a:ln>
+          <a:ln/>
         </p:spPr>
       </p:sp>
       <p:sp>
@@ -7922,8 +7895,8 @@
         </p:nvSpPr>
         <p:spPr>
           <a:xfrm>
-            <a:off x="6949440" y="1645920"/>
-            <a:ext cx="1828800" cy="914400"/>
+            <a:off x="7040880" y="2011680"/>
+            <a:ext cx="1645920" cy="822960"/>
           </a:xfrm>
           <a:prstGeom prst="rect">
             <a:avLst/>
@@ -7939,7 +7912,7 @@
               <a:buNone/>
             </a:pPr>
             <a:r>
-              <a:rPr lang="en-US" sz="1400" b="1" dirty="0">
+              <a:rPr lang="en-US" sz="1800" b="1" dirty="0">
                 <a:solidFill>
                   <a:srgbClr val="FFFFFF"/>
                 </a:solidFill>
@@ -7949,7 +7922,7 @@
               </a:rPr>
               <a:t>You review</a:t>
             </a:r>
-            <a:endParaRPr lang="en-US" sz="1400" dirty="0"/>
+            <a:endParaRPr lang="en-US" sz="1800" dirty="0"/>
           </a:p>
         </p:txBody>
       </p:sp>
@@ -7961,7 +7934,7 @@
         </p:nvSpPr>
         <p:spPr>
           <a:xfrm>
-            <a:off x="914400" y="3017520"/>
+            <a:off x="914400" y="3291840"/>
             <a:ext cx="7315200" cy="548640"/>
           </a:xfrm>
           <a:prstGeom prst="rect">
@@ -8181,7 +8154,7 @@
         </p:nvSpPr>
         <p:spPr>
           <a:xfrm>
-            <a:off x="731520" y="548640"/>
+            <a:off x="731520" y="365760"/>
             <a:ext cx="7680960" cy="1097280"/>
           </a:xfrm>
           <a:prstGeom prst="rect">
@@ -8229,43 +8202,40 @@
           </a:p>
         </p:txBody>
       </p:sp>
-      <p:sp>
-        <p:nvSpPr>
-          <p:cNvPr id="4" name="Shape 2"/>
-          <p:cNvSpPr/>
-          <p:nvPr/>
-        </p:nvSpPr>
-        <p:spPr>
-          <a:xfrm>
-            <a:off x="822960" y="2286000"/>
-            <a:ext cx="1097280" cy="457200"/>
-          </a:xfrm>
-          <a:prstGeom prst="roundRect">
-            <a:avLst>
-              <a:gd name="adj" fmla="val 10000"/>
-            </a:avLst>
-          </a:prstGeom>
-          <a:solidFill>
-            <a:srgbClr val="0A2540"/>
-          </a:solidFill>
-          <a:ln w="19050">
-            <a:solidFill>
-              <a:srgbClr val="635BFF"/>
-            </a:solidFill>
-            <a:prstDash val="solid"/>
-          </a:ln>
-        </p:spPr>
-      </p:sp>
-      <p:sp>
-        <p:nvSpPr>
-          <p:cNvPr id="5" name="Text 3"/>
-          <p:cNvSpPr/>
-          <p:nvPr/>
-        </p:nvSpPr>
-        <p:spPr>
-          <a:xfrm>
-            <a:off x="822960" y="2286000"/>
-            <a:ext cx="1097280" cy="457200"/>
+      <p:pic>
+        <p:nvPicPr>
+          <p:cNvPr id="4" name="Image 0" descr="/Users/michaelengland/Developer/michaelengland/ai-best-practices/decks/ai-best-practices/icons/envelopeW.png">    </p:cNvPr>
+          <p:cNvPicPr>
+            <a:picLocks noChangeAspect="1"/>
+          </p:cNvPicPr>
+          <p:nvPr/>
+        </p:nvPicPr>
+        <p:blipFill>
+          <a:blip r:embed="rId1"/>
+          <a:stretch>
+            <a:fillRect/>
+          </a:stretch>
+        </p:blipFill>
+        <p:spPr>
+          <a:xfrm>
+            <a:off x="1005840" y="1645920"/>
+            <a:ext cx="731520" cy="731520"/>
+          </a:xfrm>
+          <a:prstGeom prst="rect">
+            <a:avLst/>
+          </a:prstGeom>
+        </p:spPr>
+      </p:pic>
+      <p:sp>
+        <p:nvSpPr>
+          <p:cNvPr id="5" name="Text 2"/>
+          <p:cNvSpPr/>
+          <p:nvPr/>
+        </p:nvSpPr>
+        <p:spPr>
+          <a:xfrm>
+            <a:off x="731520" y="2560320"/>
+            <a:ext cx="1280160" cy="548640"/>
           </a:xfrm>
           <a:prstGeom prst="rect">
             <a:avLst/>
@@ -8274,16 +8244,16 @@
           <a:ln/>
         </p:spPr>
         <p:txBody>
-          <a:bodyPr wrap="square" lIns="0" tIns="0" rIns="0" bIns="0" rtlCol="0" anchor="ctr"/>
-          <a:lstStyle/>
-          <a:p>
-            <a:pPr algn="ctr" indent="0" marL="0">
-              <a:buNone/>
-            </a:pPr>
-            <a:r>
-              <a:rPr lang="en-US" sz="1400" b="1" dirty="0">
-                <a:solidFill>
-                  <a:srgbClr val="635BFF"/>
+          <a:bodyPr wrap="square" lIns="0" tIns="0" rIns="0" bIns="0" rtlCol="0" anchor="t"/>
+          <a:lstStyle/>
+          <a:p>
+            <a:pPr algn="ctr" indent="0" marL="0">
+              <a:buNone/>
+            </a:pPr>
+            <a:r>
+              <a:rPr lang="en-US" sz="2000" dirty="0">
+                <a:solidFill>
+                  <a:srgbClr val="8B95A5"/>
                 </a:solidFill>
                 <a:latin typeface="Verdana" pitchFamily="34" charset="0"/>
                 <a:ea typeface="Verdana" pitchFamily="34" charset="-122"/>
@@ -8291,47 +8261,44 @@
               </a:rPr>
               <a:t>Email</a:t>
             </a:r>
-            <a:endParaRPr lang="en-US" sz="1400" dirty="0"/>
-          </a:p>
-        </p:txBody>
-      </p:sp>
-      <p:sp>
-        <p:nvSpPr>
-          <p:cNvPr id="6" name="Shape 4"/>
-          <p:cNvSpPr/>
-          <p:nvPr/>
-        </p:nvSpPr>
-        <p:spPr>
-          <a:xfrm>
-            <a:off x="2103120" y="2286000"/>
-            <a:ext cx="1097280" cy="457200"/>
-          </a:xfrm>
-          <a:prstGeom prst="roundRect">
-            <a:avLst>
-              <a:gd name="adj" fmla="val 10000"/>
-            </a:avLst>
-          </a:prstGeom>
-          <a:solidFill>
-            <a:srgbClr val="0A2540"/>
-          </a:solidFill>
-          <a:ln w="19050">
-            <a:solidFill>
-              <a:srgbClr val="635BFF"/>
-            </a:solidFill>
-            <a:prstDash val="solid"/>
-          </a:ln>
-        </p:spPr>
-      </p:sp>
-      <p:sp>
-        <p:nvSpPr>
-          <p:cNvPr id="7" name="Text 5"/>
-          <p:cNvSpPr/>
-          <p:nvPr/>
-        </p:nvSpPr>
-        <p:spPr>
-          <a:xfrm>
-            <a:off x="2103120" y="2286000"/>
-            <a:ext cx="1097280" cy="457200"/>
+            <a:endParaRPr lang="en-US" sz="2000" dirty="0"/>
+          </a:p>
+        </p:txBody>
+      </p:sp>
+      <p:pic>
+        <p:nvPicPr>
+          <p:cNvPr id="6" name="Image 1" descr="/Users/michaelengland/Developer/michaelengland/ai-best-practices/decks/ai-best-practices/icons/calendarW.png">    </p:cNvPr>
+          <p:cNvPicPr>
+            <a:picLocks noChangeAspect="1"/>
+          </p:cNvPicPr>
+          <p:nvPr/>
+        </p:nvPicPr>
+        <p:blipFill>
+          <a:blip r:embed="rId2"/>
+          <a:stretch>
+            <a:fillRect/>
+          </a:stretch>
+        </p:blipFill>
+        <p:spPr>
+          <a:xfrm>
+            <a:off x="2286000" y="1645920"/>
+            <a:ext cx="731520" cy="731520"/>
+          </a:xfrm>
+          <a:prstGeom prst="rect">
+            <a:avLst/>
+          </a:prstGeom>
+        </p:spPr>
+      </p:pic>
+      <p:sp>
+        <p:nvSpPr>
+          <p:cNvPr id="7" name="Text 3"/>
+          <p:cNvSpPr/>
+          <p:nvPr/>
+        </p:nvSpPr>
+        <p:spPr>
+          <a:xfrm>
+            <a:off x="2011680" y="2560320"/>
+            <a:ext cx="1280160" cy="548640"/>
           </a:xfrm>
           <a:prstGeom prst="rect">
             <a:avLst/>
@@ -8340,16 +8307,16 @@
           <a:ln/>
         </p:spPr>
         <p:txBody>
-          <a:bodyPr wrap="square" lIns="0" tIns="0" rIns="0" bIns="0" rtlCol="0" anchor="ctr"/>
-          <a:lstStyle/>
-          <a:p>
-            <a:pPr algn="ctr" indent="0" marL="0">
-              <a:buNone/>
-            </a:pPr>
-            <a:r>
-              <a:rPr lang="en-US" sz="1400" b="1" dirty="0">
-                <a:solidFill>
-                  <a:srgbClr val="635BFF"/>
+          <a:bodyPr wrap="square" lIns="0" tIns="0" rIns="0" bIns="0" rtlCol="0" anchor="t"/>
+          <a:lstStyle/>
+          <a:p>
+            <a:pPr algn="ctr" indent="0" marL="0">
+              <a:buNone/>
+            </a:pPr>
+            <a:r>
+              <a:rPr lang="en-US" sz="2000" dirty="0">
+                <a:solidFill>
+                  <a:srgbClr val="8B95A5"/>
                 </a:solidFill>
                 <a:latin typeface="Verdana" pitchFamily="34" charset="0"/>
                 <a:ea typeface="Verdana" pitchFamily="34" charset="-122"/>
@@ -8357,47 +8324,44 @@
               </a:rPr>
               <a:t>Calendar</a:t>
             </a:r>
-            <a:endParaRPr lang="en-US" sz="1400" dirty="0"/>
-          </a:p>
-        </p:txBody>
-      </p:sp>
-      <p:sp>
-        <p:nvSpPr>
-          <p:cNvPr id="8" name="Shape 6"/>
-          <p:cNvSpPr/>
-          <p:nvPr/>
-        </p:nvSpPr>
-        <p:spPr>
-          <a:xfrm>
-            <a:off x="3383280" y="2286000"/>
-            <a:ext cx="1097280" cy="457200"/>
-          </a:xfrm>
-          <a:prstGeom prst="roundRect">
-            <a:avLst>
-              <a:gd name="adj" fmla="val 10000"/>
-            </a:avLst>
-          </a:prstGeom>
-          <a:solidFill>
-            <a:srgbClr val="0A2540"/>
-          </a:solidFill>
-          <a:ln w="19050">
-            <a:solidFill>
-              <a:srgbClr val="635BFF"/>
-            </a:solidFill>
-            <a:prstDash val="solid"/>
-          </a:ln>
-        </p:spPr>
-      </p:sp>
-      <p:sp>
-        <p:nvSpPr>
-          <p:cNvPr id="9" name="Text 7"/>
-          <p:cNvSpPr/>
-          <p:nvPr/>
-        </p:nvSpPr>
-        <p:spPr>
-          <a:xfrm>
-            <a:off x="3383280" y="2286000"/>
-            <a:ext cx="1097280" cy="457200"/>
+            <a:endParaRPr lang="en-US" sz="2000" dirty="0"/>
+          </a:p>
+        </p:txBody>
+      </p:sp>
+      <p:pic>
+        <p:nvPicPr>
+          <p:cNvPr id="8" name="Image 2" descr="/Users/michaelengland/Developer/michaelengland/ai-best-practices/decks/ai-best-practices/icons/fileW.png">    </p:cNvPr>
+          <p:cNvPicPr>
+            <a:picLocks noChangeAspect="1"/>
+          </p:cNvPicPr>
+          <p:nvPr/>
+        </p:nvPicPr>
+        <p:blipFill>
+          <a:blip r:embed="rId3"/>
+          <a:stretch>
+            <a:fillRect/>
+          </a:stretch>
+        </p:blipFill>
+        <p:spPr>
+          <a:xfrm>
+            <a:off x="3566160" y="1645920"/>
+            <a:ext cx="731520" cy="731520"/>
+          </a:xfrm>
+          <a:prstGeom prst="rect">
+            <a:avLst/>
+          </a:prstGeom>
+        </p:spPr>
+      </p:pic>
+      <p:sp>
+        <p:nvSpPr>
+          <p:cNvPr id="9" name="Text 4"/>
+          <p:cNvSpPr/>
+          <p:nvPr/>
+        </p:nvSpPr>
+        <p:spPr>
+          <a:xfrm>
+            <a:off x="3291840" y="2560320"/>
+            <a:ext cx="1280160" cy="548640"/>
           </a:xfrm>
           <a:prstGeom prst="rect">
             <a:avLst/>
@@ -8406,16 +8370,16 @@
           <a:ln/>
         </p:spPr>
         <p:txBody>
-          <a:bodyPr wrap="square" lIns="0" tIns="0" rIns="0" bIns="0" rtlCol="0" anchor="ctr"/>
-          <a:lstStyle/>
-          <a:p>
-            <a:pPr algn="ctr" indent="0" marL="0">
-              <a:buNone/>
-            </a:pPr>
-            <a:r>
-              <a:rPr lang="en-US" sz="1400" b="1" dirty="0">
-                <a:solidFill>
-                  <a:srgbClr val="635BFF"/>
+          <a:bodyPr wrap="square" lIns="0" tIns="0" rIns="0" bIns="0" rtlCol="0" anchor="t"/>
+          <a:lstStyle/>
+          <a:p>
+            <a:pPr algn="ctr" indent="0" marL="0">
+              <a:buNone/>
+            </a:pPr>
+            <a:r>
+              <a:rPr lang="en-US" sz="2000" dirty="0">
+                <a:solidFill>
+                  <a:srgbClr val="8B95A5"/>
                 </a:solidFill>
                 <a:latin typeface="Verdana" pitchFamily="34" charset="0"/>
                 <a:ea typeface="Verdana" pitchFamily="34" charset="-122"/>
@@ -8423,47 +8387,44 @@
               </a:rPr>
               <a:t>Files</a:t>
             </a:r>
-            <a:endParaRPr lang="en-US" sz="1400" dirty="0"/>
-          </a:p>
-        </p:txBody>
-      </p:sp>
-      <p:sp>
-        <p:nvSpPr>
-          <p:cNvPr id="10" name="Shape 8"/>
-          <p:cNvSpPr/>
-          <p:nvPr/>
-        </p:nvSpPr>
-        <p:spPr>
-          <a:xfrm>
-            <a:off x="4663440" y="2286000"/>
-            <a:ext cx="1097280" cy="457200"/>
-          </a:xfrm>
-          <a:prstGeom prst="roundRect">
-            <a:avLst>
-              <a:gd name="adj" fmla="val 10000"/>
-            </a:avLst>
-          </a:prstGeom>
-          <a:solidFill>
-            <a:srgbClr val="0A2540"/>
-          </a:solidFill>
-          <a:ln w="19050">
-            <a:solidFill>
-              <a:srgbClr val="635BFF"/>
-            </a:solidFill>
-            <a:prstDash val="solid"/>
-          </a:ln>
-        </p:spPr>
-      </p:sp>
-      <p:sp>
-        <p:nvSpPr>
-          <p:cNvPr id="11" name="Text 9"/>
-          <p:cNvSpPr/>
-          <p:nvPr/>
-        </p:nvSpPr>
-        <p:spPr>
-          <a:xfrm>
-            <a:off x="4663440" y="2286000"/>
-            <a:ext cx="1097280" cy="457200"/>
+            <a:endParaRPr lang="en-US" sz="2000" dirty="0"/>
+          </a:p>
+        </p:txBody>
+      </p:sp>
+      <p:pic>
+        <p:nvPicPr>
+          <p:cNvPr id="10" name="Image 3" descr="/Users/michaelengland/Developer/michaelengland/ai-best-practices/decks/ai-best-practices/icons/puzzleW.png">    </p:cNvPr>
+          <p:cNvPicPr>
+            <a:picLocks noChangeAspect="1"/>
+          </p:cNvPicPr>
+          <p:nvPr/>
+        </p:nvPicPr>
+        <p:blipFill>
+          <a:blip r:embed="rId4"/>
+          <a:stretch>
+            <a:fillRect/>
+          </a:stretch>
+        </p:blipFill>
+        <p:spPr>
+          <a:xfrm>
+            <a:off x="4846320" y="1645920"/>
+            <a:ext cx="731520" cy="731520"/>
+          </a:xfrm>
+          <a:prstGeom prst="rect">
+            <a:avLst/>
+          </a:prstGeom>
+        </p:spPr>
+      </p:pic>
+      <p:sp>
+        <p:nvSpPr>
+          <p:cNvPr id="11" name="Text 5"/>
+          <p:cNvSpPr/>
+          <p:nvPr/>
+        </p:nvSpPr>
+        <p:spPr>
+          <a:xfrm>
+            <a:off x="4572000" y="2560320"/>
+            <a:ext cx="1280160" cy="548640"/>
           </a:xfrm>
           <a:prstGeom prst="rect">
             <a:avLst/>
@@ -8472,16 +8433,16 @@
           <a:ln/>
         </p:spPr>
         <p:txBody>
-          <a:bodyPr wrap="square" lIns="0" tIns="0" rIns="0" bIns="0" rtlCol="0" anchor="ctr"/>
-          <a:lstStyle/>
-          <a:p>
-            <a:pPr algn="ctr" indent="0" marL="0">
-              <a:buNone/>
-            </a:pPr>
-            <a:r>
-              <a:rPr lang="en-US" sz="1400" b="1" dirty="0">
-                <a:solidFill>
-                  <a:srgbClr val="635BFF"/>
+          <a:bodyPr wrap="square" lIns="0" tIns="0" rIns="0" bIns="0" rtlCol="0" anchor="t"/>
+          <a:lstStyle/>
+          <a:p>
+            <a:pPr algn="ctr" indent="0" marL="0">
+              <a:buNone/>
+            </a:pPr>
+            <a:r>
+              <a:rPr lang="en-US" sz="2000" dirty="0">
+                <a:solidFill>
+                  <a:srgbClr val="8B95A5"/>
                 </a:solidFill>
                 <a:latin typeface="Verdana" pitchFamily="34" charset="0"/>
                 <a:ea typeface="Verdana" pitchFamily="34" charset="-122"/>
@@ -8489,47 +8450,44 @@
               </a:rPr>
               <a:t>Chat</a:t>
             </a:r>
-            <a:endParaRPr lang="en-US" sz="1400" dirty="0"/>
-          </a:p>
-        </p:txBody>
-      </p:sp>
-      <p:sp>
-        <p:nvSpPr>
-          <p:cNvPr id="12" name="Shape 10"/>
-          <p:cNvSpPr/>
-          <p:nvPr/>
-        </p:nvSpPr>
-        <p:spPr>
-          <a:xfrm>
-            <a:off x="5943600" y="2286000"/>
-            <a:ext cx="1097280" cy="457200"/>
-          </a:xfrm>
-          <a:prstGeom prst="roundRect">
-            <a:avLst>
-              <a:gd name="adj" fmla="val 10000"/>
-            </a:avLst>
-          </a:prstGeom>
-          <a:solidFill>
-            <a:srgbClr val="0A2540"/>
-          </a:solidFill>
-          <a:ln w="19050">
-            <a:solidFill>
-              <a:srgbClr val="635BFF"/>
-            </a:solidFill>
-            <a:prstDash val="solid"/>
-          </a:ln>
-        </p:spPr>
-      </p:sp>
-      <p:sp>
-        <p:nvSpPr>
-          <p:cNvPr id="13" name="Text 11"/>
-          <p:cNvSpPr/>
-          <p:nvPr/>
-        </p:nvSpPr>
-        <p:spPr>
-          <a:xfrm>
-            <a:off x="5943600" y="2286000"/>
-            <a:ext cx="1097280" cy="457200"/>
+            <a:endParaRPr lang="en-US" sz="2000" dirty="0"/>
+          </a:p>
+        </p:txBody>
+      </p:sp>
+      <p:pic>
+        <p:nvPicPr>
+          <p:cNvPr id="12" name="Image 4" descr="/Users/michaelengland/Developer/michaelengland/ai-best-practices/decks/ai-best-practices/icons/globeW.png">    </p:cNvPr>
+          <p:cNvPicPr>
+            <a:picLocks noChangeAspect="1"/>
+          </p:cNvPicPr>
+          <p:nvPr/>
+        </p:nvPicPr>
+        <p:blipFill>
+          <a:blip r:embed="rId5"/>
+          <a:stretch>
+            <a:fillRect/>
+          </a:stretch>
+        </p:blipFill>
+        <p:spPr>
+          <a:xfrm>
+            <a:off x="6126480" y="1645920"/>
+            <a:ext cx="731520" cy="731520"/>
+          </a:xfrm>
+          <a:prstGeom prst="rect">
+            <a:avLst/>
+          </a:prstGeom>
+        </p:spPr>
+      </p:pic>
+      <p:sp>
+        <p:nvSpPr>
+          <p:cNvPr id="13" name="Text 6"/>
+          <p:cNvSpPr/>
+          <p:nvPr/>
+        </p:nvSpPr>
+        <p:spPr>
+          <a:xfrm>
+            <a:off x="5852160" y="2560320"/>
+            <a:ext cx="1280160" cy="548640"/>
           </a:xfrm>
           <a:prstGeom prst="rect">
             <a:avLst/>
@@ -8538,16 +8496,16 @@
           <a:ln/>
         </p:spPr>
         <p:txBody>
-          <a:bodyPr wrap="square" lIns="0" tIns="0" rIns="0" bIns="0" rtlCol="0" anchor="ctr"/>
-          <a:lstStyle/>
-          <a:p>
-            <a:pPr algn="ctr" indent="0" marL="0">
-              <a:buNone/>
-            </a:pPr>
-            <a:r>
-              <a:rPr lang="en-US" sz="1400" b="1" dirty="0">
-                <a:solidFill>
-                  <a:srgbClr val="635BFF"/>
+          <a:bodyPr wrap="square" lIns="0" tIns="0" rIns="0" bIns="0" rtlCol="0" anchor="t"/>
+          <a:lstStyle/>
+          <a:p>
+            <a:pPr algn="ctr" indent="0" marL="0">
+              <a:buNone/>
+            </a:pPr>
+            <a:r>
+              <a:rPr lang="en-US" sz="2000" dirty="0">
+                <a:solidFill>
+                  <a:srgbClr val="8B95A5"/>
                 </a:solidFill>
                 <a:latin typeface="Verdana" pitchFamily="34" charset="0"/>
                 <a:ea typeface="Verdana" pitchFamily="34" charset="-122"/>
@@ -8555,47 +8513,44 @@
               </a:rPr>
               <a:t>Web</a:t>
             </a:r>
-            <a:endParaRPr lang="en-US" sz="1400" dirty="0"/>
-          </a:p>
-        </p:txBody>
-      </p:sp>
-      <p:sp>
-        <p:nvSpPr>
-          <p:cNvPr id="14" name="Shape 12"/>
-          <p:cNvSpPr/>
-          <p:nvPr/>
-        </p:nvSpPr>
-        <p:spPr>
-          <a:xfrm>
-            <a:off x="7223760" y="2286000"/>
-            <a:ext cx="1097280" cy="457200"/>
-          </a:xfrm>
-          <a:prstGeom prst="roundRect">
-            <a:avLst>
-              <a:gd name="adj" fmla="val 10000"/>
-            </a:avLst>
-          </a:prstGeom>
-          <a:solidFill>
-            <a:srgbClr val="0A2540"/>
-          </a:solidFill>
-          <a:ln w="19050">
-            <a:solidFill>
-              <a:srgbClr val="635BFF"/>
-            </a:solidFill>
-            <a:prstDash val="solid"/>
-          </a:ln>
-        </p:spPr>
-      </p:sp>
-      <p:sp>
-        <p:nvSpPr>
-          <p:cNvPr id="15" name="Text 13"/>
-          <p:cNvSpPr/>
-          <p:nvPr/>
-        </p:nvSpPr>
-        <p:spPr>
-          <a:xfrm>
-            <a:off x="7223760" y="2286000"/>
-            <a:ext cx="1097280" cy="457200"/>
+            <a:endParaRPr lang="en-US" sz="2000" dirty="0"/>
+          </a:p>
+        </p:txBody>
+      </p:sp>
+      <p:pic>
+        <p:nvPicPr>
+          <p:cNvPr id="14" name="Image 5" descr="/Users/michaelengland/Developer/michaelengland/ai-best-practices/decks/ai-best-practices/icons/arrowW.png">    </p:cNvPr>
+          <p:cNvPicPr>
+            <a:picLocks noChangeAspect="1"/>
+          </p:cNvPicPr>
+          <p:nvPr/>
+        </p:nvPicPr>
+        <p:blipFill>
+          <a:blip r:embed="rId6"/>
+          <a:stretch>
+            <a:fillRect/>
+          </a:stretch>
+        </p:blipFill>
+        <p:spPr>
+          <a:xfrm>
+            <a:off x="7406640" y="1645920"/>
+            <a:ext cx="731520" cy="731520"/>
+          </a:xfrm>
+          <a:prstGeom prst="rect">
+            <a:avLst/>
+          </a:prstGeom>
+        </p:spPr>
+      </p:pic>
+      <p:sp>
+        <p:nvSpPr>
+          <p:cNvPr id="15" name="Text 7"/>
+          <p:cNvSpPr/>
+          <p:nvPr/>
+        </p:nvSpPr>
+        <p:spPr>
+          <a:xfrm>
+            <a:off x="7132320" y="2560320"/>
+            <a:ext cx="1280160" cy="548640"/>
           </a:xfrm>
           <a:prstGeom prst="rect">
             <a:avLst/>
@@ -8604,16 +8559,16 @@
           <a:ln/>
         </p:spPr>
         <p:txBody>
-          <a:bodyPr wrap="square" lIns="0" tIns="0" rIns="0" bIns="0" rtlCol="0" anchor="ctr"/>
-          <a:lstStyle/>
-          <a:p>
-            <a:pPr algn="ctr" indent="0" marL="0">
-              <a:buNone/>
-            </a:pPr>
-            <a:r>
-              <a:rPr lang="en-US" sz="1400" b="1" dirty="0">
-                <a:solidFill>
-                  <a:srgbClr val="635BFF"/>
+          <a:bodyPr wrap="square" lIns="0" tIns="0" rIns="0" bIns="0" rtlCol="0" anchor="t"/>
+          <a:lstStyle/>
+          <a:p>
+            <a:pPr algn="ctr" indent="0" marL="0">
+              <a:buNone/>
+            </a:pPr>
+            <a:r>
+              <a:rPr lang="en-US" sz="2000" dirty="0">
+                <a:solidFill>
+                  <a:srgbClr val="8B95A5"/>
                 </a:solidFill>
                 <a:latin typeface="Verdana" pitchFamily="34" charset="0"/>
                 <a:ea typeface="Verdana" pitchFamily="34" charset="-122"/>
@@ -8621,7 +8576,7 @@
               </a:rPr>
               <a:t>Custom</a:t>
             </a:r>
-            <a:endParaRPr lang="en-US" sz="1400" dirty="0"/>
+            <a:endParaRPr lang="en-US" sz="2000" dirty="0"/>
           </a:p>
         </p:txBody>
       </p:sp>

</xml_diff>

<commit_message>
Change running example from onboarding proposal to tea presentation
All three decks (main, workshop-1, workshop-2) now use "making a
presentation about making a cup of tea" as the running example.
Updates narrative, content outline, slide design, generation scripts,
and regenerated .pptx/.pdf files. Also fixes wrongRight card text
overflow (fontSize 22→18) in workshop-1 and adjusts chain flow box
sizing in main deck.

Co-Authored-By: Claude Opus 4.6 <noreply@anthropic.com>
</commit_message>
<xml_diff>
--- a/decks/workshop-2-orchestrator/workshop-2-orchestrator.pptx
+++ b/decks/workshop-2-orchestrator/workshop-2-orchestrator.pptx
@@ -1054,7 +1054,7 @@
           <a:p>
             <a:r>
               <a:rPr lang="en-US" dirty="0"/>
-              <a:t>Group exercise. Facilitator presents a complex task (the onboarding proposal or another multi-step scenario). Discussion with whiteboard or shared doc. Target: 3-4 phases. e.g., Research → Draft → Review → Approval. Don't let it go beyond 4 — more than that overcomplicates the demo. 5-6 minutes.</a:t>
+              <a:t>Group exercise. Facilitator presents a complex task (the tea presentation or another multi-step scenario). Discussion with whiteboard or shared doc. Target: 3-4 phases. e.g., Research → Draft → Review → Approval. Don't let it go beyond 4 — more than that overcomplicates the demo. 5-6 minutes.</a:t>
             </a:r>
             <a:endParaRPr lang="en-US" dirty="0"/>
           </a:p>
@@ -1318,7 +1318,7 @@
           <a:p>
             <a:r>
               <a:rPr lang="en-US" dirty="0"/>
-              <a:t>10 minutes. Attendees choose their running task from Workshop 1 or the prescribed one. Custom GPTs are in the ChatGPT sidebar. Fallback if time runs short: Phase 1 becomes a facilitator demo, attendees do Phase 2 only. The discussion matters more than both phases completing. Ask: "Where did the chain produce better results? Where did the handoff lose something?"</a:t>
+              <a:t>10 minutes. Attendees choose their running task from Workshop 1 or the tea presentation. Custom GPTs are in the ChatGPT sidebar. Fallback if time runs short: Phase 1 becomes a facilitator demo, attendees do Phase 2 only. The discussion matters more than both phases completing. Ask: "Where did the chain produce better results? Where did the handoff lose something?"</a:t>
             </a:r>
             <a:endParaRPr lang="en-US" dirty="0"/>
           </a:p>
@@ -1846,7 +1846,7 @@
           <a:p>
             <a:r>
               <a:rPr lang="en-US" dirty="0"/>
-              <a:t>Chained workflow: agents handle 1 hour 15 minutes of work. You spend 15 minutes on judgment — reviewing, deciding, approving. "Same proposal. The chain gets smarter every time. Your feedback becomes skills."</a:t>
+              <a:t>Chained workflow: agents handle 1 hour 15 minutes of work. You spend 15 minutes on judgment — reviewing, deciding, approving. "Same tea presentation. The chain gets smarter every time. Your feedback becomes skills."</a:t>
             </a:r>
             <a:endParaRPr lang="en-US" dirty="0"/>
           </a:p>

</xml_diff>

<commit_message>
Replace manual chain with Cowork Skill chain in Workshop 2
Remove demo slide and copy-paste chain exercise. Replace with
Cowork-based chain: one prompt triggers Research Skill, which
saves brief.md and asks user to review before Draft continues.
Skills own the file convention, human reviews at every handoff.
Folder view slide shows the three artifacts and filtered context.

Co-Authored-By: Claude Opus 4.6 <noreply@anthropic.com>
</commit_message>
<xml_diff>
--- a/decks/workshop-2-orchestrator/workshop-2-orchestrator.pptx
+++ b/decks/workshop-2-orchestrator/workshop-2-orchestrator.pptx
@@ -33,10 +33,9 @@
     <p:sldId id="281" r:id="rId27"/>
     <p:sldId id="282" r:id="rId28"/>
     <p:sldId id="283" r:id="rId29"/>
-    <p:sldId id="284" r:id="rId30"/>
   </p:sldIdLst>
   <p:notesMasterIdLst>
-    <p:notesMasterId r:id="rId31"/>
+    <p:notesMasterId r:id="rId30"/>
   </p:notesMasterIdLst>
   <p:sldSz cx="9144000" cy="5143500"/>
   <p:notesSz cx="5143500" cy="9144000"/>
@@ -1674,7 +1673,7 @@
           <a:p>
             <a:r>
               <a:rPr lang="en-US" dirty="0"/>
-              <a:t>Facilitator switches to Claude for the live demo. Run the chain using pre-built org Skills: (1) New conversation → give it the research task → the Research Skill kicks in → show the structured brief output. (2) New conversation → paste the brief → the Draft Skill kicks in → show the polished proposal. (3) New conversation → paste the draft + original brief → the Review Skill kicks in → show the critique. Narrate every step. Point out what the Draft Skill doesn't know: it never saw the raw research, only the structured brief. That's filtered context — each new conversation provides isolation. Compare final output to what a single Claude conversation would have produced. Take your time — this demo earns the exercise that follows. ~7 minutes.</a:t>
+              <a:t>10 minutes. This is the main exercise. One prompt starts the chain. The Research Skill runs, saves to [topic]/brief.md, then asks the user to review. User approves → Draft Skill reads brief.md, saves draft.md, asks user to review. User approves → Review Skill reads both files, saves review.md. Human in the loop at every handoff. The Skills handle the files — attendees just say "Research [topic]" and then approve each step. Walk the room. Fallback: facilitator screen-shares one chain running live while attendees follow along.</a:t>
             </a:r>
             <a:endParaRPr lang="en-US" dirty="0"/>
           </a:p>
@@ -1762,7 +1761,7 @@
           <a:p>
             <a:r>
               <a:rPr lang="en-US" dirty="0"/>
-              <a:t>10 minutes. Attendees choose their running task from Workshop 1 or the tea presentation. The org Skills auto-activate based on the task. Fallback if time runs short: Phase 1 becomes a facilitator demo, attendees do Phase 2 only. The discussion matters more than both phases completing. Ask: "Where did the chain produce better results? Where did the handoff lose something?"</a:t>
+              <a:t>Have them open the folder on their Mac. Three files, three phases, each produced by a different Skill. Point out what draft.md doesn't contain: it was written from brief.md, not from the raw sources. The Draft Skill never saw the original research — only the structured brief. That's the power of decomposition. Compare: "How does this compare to asking Claude to do everything in one prompt?" The chain output is more structured, more thorough, better reviewed. Ask: "Where did the chain produce better results? What would you change about the handoff?"</a:t>
             </a:r>
             <a:endParaRPr lang="en-US" dirty="0"/>
           </a:p>
@@ -1850,7 +1849,7 @@
           <a:p>
             <a:r>
               <a:rPr lang="en-US" dirty="0"/>
-              <a:t>The Workshop 1 callback. In the last session they set up rules (on the page) and pulled Skills from the drawer. Each org Skill in the chain is the same idea taken further — each agent gets its own drawer, its own expertise. They've been building persistent context since last session; now each step in the chain gets its own playbook.</a:t>
+              <a:t>Show where to find the Skill instructions (Customize → Skills → click the Skill). Take 2-3 suggestions from the group. Discuss what difference each change would make. The SKILL.md is tangible — they can see it, read it, edit it. "When you edit that SKILL.md, every future use gets better. Your feedback becomes the skill." Workshop 1 callback: rules go on the page, Skills live in the drawer. Each step in the chain has its own drawer.</a:t>
             </a:r>
             <a:endParaRPr lang="en-US" dirty="0"/>
           </a:p>
@@ -1938,7 +1937,7 @@
           <a:p>
             <a:r>
               <a:rPr lang="en-US" dirty="0"/>
-              <a:t>Show where to find the Skill instructions (Customize → Skills → click the Skill). Take 2-3 suggestions from the group. Discuss what difference each change would make. The SKILL.md is tangible — they can see it, read it, edit it. "When you edit that SKILL.md, every future use gets better. Your feedback becomes the skill."</a:t>
+              <a:t>Emotional climax. Give this a full beat. "And as an org Skill, when you improve it, everyone benefits." This is the payoff of the entire skills arc that started in Workshop 1. The drawer gets better every time you edit a SKILL.md — and it's everyone's drawer. For Pro plan audiences: "Every future use benefits."</a:t>
             </a:r>
             <a:endParaRPr lang="en-US" dirty="0"/>
           </a:p>
@@ -2026,7 +2025,7 @@
           <a:p>
             <a:r>
               <a:rPr lang="en-US" dirty="0"/>
-              <a:t>Emotional climax. Give this a full beat. "And as an org Skill, when you improve it, everyone benefits." This is the payoff of the entire skills arc that started in Workshop 1. The drawer gets better every time you edit a SKILL.md — and it's everyone's drawer. For Pro plan audiences: "Every future use benefits."</a:t>
+              <a:t>The rational payoff begins. Manual workflow: search, copy-paste, draft, re-prompt, reformat, review, apply. All the steps they recognised in Slide 3. "1.5 hours of grunt work where you're the bottleneck at every step."</a:t>
             </a:r>
             <a:endParaRPr lang="en-US" dirty="0"/>
           </a:p>
@@ -2114,7 +2113,7 @@
           <a:p>
             <a:r>
               <a:rPr lang="en-US" dirty="0"/>
-              <a:t>The rational payoff begins. Manual workflow: search, copy-paste, draft, re-prompt, reformat, review, apply. All the steps they recognised in Slide 3. "1.5 hours of grunt work where you're the bottleneck at every step."</a:t>
+              <a:t>Chained workflow: Skills handle 1 hour 15 minutes of work. You spend 15 minutes on judgment — reviewing, deciding, approving. "Same tea presentation. The chain gets smarter every time. Your feedback becomes Skills."</a:t>
             </a:r>
             <a:endParaRPr lang="en-US" dirty="0"/>
           </a:p>
@@ -2202,7 +2201,7 @@
           <a:p>
             <a:r>
               <a:rPr lang="en-US" dirty="0"/>
-              <a:t>Chained workflow: Skills handle 1 hour 15 minutes of work. You spend 15 minutes on judgment — reviewing, deciding, approving. "Same tea presentation. The chain gets smarter every time. Your feedback becomes Skills."</a:t>
+              <a:t>Graduation moment. "You learned to whisper. You became a strategist. You let Claude operate. You orchestrated the brigade." This is the emotional payoff. Make it feel earned — they completed a 2-session AI Academy. Builder is still dimmed — that's the horizon for those who want to go further.</a:t>
             </a:r>
             <a:endParaRPr lang="en-US" dirty="0"/>
           </a:p>
@@ -2290,7 +2289,7 @@
           <a:p>
             <a:r>
               <a:rPr lang="en-US" dirty="0"/>
-              <a:t>Graduation moment. "You learned to whisper. You became a strategist. You let Claude operate. You orchestrated the brigade." This is the emotional payoff. Make it feel earned — they completed a 2-session AI Academy. Builder is still dimmed — that's the horizon for those who want to go further.</a:t>
+              <a:t>Final CTA. "Now go try it — one task, this week." Builder tease for the curious: "And if you want to go further — building integrations, connecting Claude to your actual systems, automating entire workflows — that's the Builder level. That's what's next." But don't oversell — most attendees won't go there, and that's fine.</a:t>
             </a:r>
             <a:endParaRPr lang="en-US" dirty="0"/>
           </a:p>
@@ -2314,94 +2313,6 @@
             <a:fld id="{F7021451-1387-4CA6-816F-3879F97B5CBC}" type="slidenum">
               <a:rPr lang="en-US"/>
               <a:t>28</a:t>
-            </a:fld>
-            <a:endParaRPr lang="en-US"/>
-          </a:p>
-        </p:txBody>
-      </p:sp>
-    </p:spTree>
-    <p:extLst>
-      <p:ext uri="{BB962C8B-B14F-4D97-AF65-F5344CB8AC3E}">
-        <p14:creationId xmlns:p14="http://schemas.microsoft.com/office/powerpoint/2010/main" val="1024086991"/>
-      </p:ext>
-    </p:extLst>
-  </p:cSld>
-  <p:clrMapOvr>
-    <a:masterClrMapping/>
-  </p:clrMapOvr>
-</p:notes>
-</file>
-
-<file path=ppt/notesSlides/notesSlide29.xml><?xml version="1.0" encoding="utf-8"?>
-<p:notes xmlns:a="http://schemas.openxmlformats.org/drawingml/2006/main" xmlns:r="http://schemas.openxmlformats.org/officeDocument/2006/relationships" xmlns:p="http://schemas.openxmlformats.org/presentationml/2006/main">
-  <p:cSld>
-    <p:spTree>
-      <p:nvGrpSpPr>
-        <p:cNvPr id="1" name=""/>
-        <p:cNvGrpSpPr/>
-        <p:nvPr/>
-      </p:nvGrpSpPr>
-      <p:grpSpPr>
-        <a:xfrm>
-          <a:off x="0" y="0"/>
-          <a:ext cx="0" cy="0"/>
-          <a:chOff x="0" y="0"/>
-          <a:chExt cx="0" cy="0"/>
-        </a:xfrm>
-      </p:grpSpPr>
-      <p:sp>
-        <p:nvSpPr>
-          <p:cNvPr id="2" name="Slide Image Placeholder 1"/>
-          <p:cNvSpPr>
-            <a:spLocks noGrp="1" noRot="1" noChangeAspect="1"/>
-          </p:cNvSpPr>
-          <p:nvPr>
-            <p:ph type="sldImg"/>
-          </p:nvPr>
-        </p:nvSpPr>
-        <p:spPr/>
-      </p:sp>
-      <p:sp>
-        <p:nvSpPr>
-          <p:cNvPr id="3" name="Notes Placeholder 2"/>
-          <p:cNvSpPr>
-            <a:spLocks noGrp="1"/>
-          </p:cNvSpPr>
-          <p:nvPr>
-            <p:ph type="body" idx="1"/>
-          </p:nvPr>
-        </p:nvSpPr>
-        <p:spPr/>
-        <p:txBody>
-          <a:bodyPr/>
-          <a:lstStyle/>
-          <a:p>
-            <a:r>
-              <a:rPr lang="en-US" dirty="0"/>
-              <a:t>Final CTA. "Now go try it — one task, this week." Builder tease for the curious: "And if you want to go further — building integrations, connecting Claude to your actual systems, automating entire workflows — that's the Builder level. That's what's next." But don't oversell — most attendees won't go there, and that's fine.</a:t>
-            </a:r>
-            <a:endParaRPr lang="en-US" dirty="0"/>
-          </a:p>
-        </p:txBody>
-      </p:sp>
-      <p:sp>
-        <p:nvSpPr>
-          <p:cNvPr id="4" name="Slide Number Placeholder 3"/>
-          <p:cNvSpPr>
-            <a:spLocks noGrp="1"/>
-          </p:cNvSpPr>
-          <p:nvPr>
-            <p:ph type="sldNum" sz="quarter" idx="10"/>
-          </p:nvPr>
-        </p:nvSpPr>
-        <p:spPr/>
-        <p:txBody>
-          <a:bodyPr/>
-          <a:lstStyle/>
-          <a:p>
-            <a:fld id="{F7021451-1387-4CA6-816F-3879F97B5CBC}" type="slidenum">
-              <a:rPr lang="en-US"/>
-              <a:t>29</a:t>
             </a:fld>
             <a:endParaRPr lang="en-US"/>
           </a:p>
@@ -7630,8 +7541,8 @@
         </p:nvSpPr>
         <p:spPr>
           <a:xfrm>
-            <a:off x="457200" y="1463040"/>
-            <a:ext cx="8229600" cy="1097280"/>
+            <a:off x="914400" y="914400"/>
+            <a:ext cx="7315200" cy="3291840"/>
           </a:xfrm>
           <a:prstGeom prst="rect">
             <a:avLst/>
@@ -7647,54 +7558,49 @@
               <a:buNone/>
             </a:pPr>
             <a:r>
-              <a:rPr lang="en-US" sz="5400" b="1" dirty="0">
-                <a:solidFill>
-                  <a:srgbClr val="FFFFFF"/>
+              <a:rPr lang="en-US" sz="2800" b="1" dirty="0">
+                <a:solidFill>
+                  <a:srgbClr val="635BFF"/>
                 </a:solidFill>
                 <a:latin typeface="Georgia" pitchFamily="34" charset="0"/>
                 <a:ea typeface="Georgia" pitchFamily="34" charset="-122"/>
                 <a:cs typeface="Georgia" pitchFamily="34" charset="-120"/>
               </a:rPr>
-              <a:t>Demo</a:t>
-            </a:r>
-            <a:endParaRPr lang="en-US" sz="5400" dirty="0"/>
-          </a:p>
-        </p:txBody>
-      </p:sp>
-      <p:sp>
-        <p:nvSpPr>
-          <p:cNvPr id="4" name="Text 2"/>
-          <p:cNvSpPr/>
-          <p:nvPr/>
-        </p:nvSpPr>
-        <p:spPr>
-          <a:xfrm>
-            <a:off x="914400" y="2651760"/>
-            <a:ext cx="7315200" cy="548640"/>
-          </a:xfrm>
-          <a:prstGeom prst="rect">
-            <a:avLst/>
-          </a:prstGeom>
-          <a:noFill/>
-          <a:ln/>
-        </p:spPr>
-        <p:txBody>
-          <a:bodyPr wrap="square" lIns="0" tIns="0" rIns="0" bIns="0" rtlCol="0" anchor="ctr"/>
-          <a:lstStyle/>
-          <a:p>
-            <a:pPr algn="ctr" indent="0" marL="0">
-              <a:buNone/>
-            </a:pPr>
-            <a:r>
-              <a:rPr lang="en-US" sz="2800" i="1" dirty="0">
+              <a:t>In Cowork:</a:t>
+            </a:r>
+            <a:endParaRPr lang="en-US" sz="2800" dirty="0"/>
+          </a:p>
+          <a:p>
+            <a:pPr algn="ctr" indent="0" marL="0">
+              <a:buNone/>
+            </a:pPr>
+            <a:r>
+              <a:rPr lang="en-US" sz="3600" b="1" dirty="0">
                 <a:solidFill>
                   <a:srgbClr val="635BFF"/>
+                </a:solidFill>
+                <a:latin typeface="Georgia" pitchFamily="34" charset="0"/>
+                <a:ea typeface="Georgia" pitchFamily="34" charset="-122"/>
+                <a:cs typeface="Georgia" pitchFamily="34" charset="-120"/>
+              </a:rPr>
+              <a:t>"Research [topic]"</a:t>
+            </a:r>
+            <a:endParaRPr lang="en-US" sz="2800" dirty="0"/>
+          </a:p>
+          <a:p>
+            <a:pPr algn="ctr" indent="0" marL="0">
+              <a:buNone/>
+            </a:pPr>
+            <a:r>
+              <a:rPr lang="en-US" sz="2200" i="1" dirty="0">
+                <a:solidFill>
+                  <a:srgbClr val="8B95A5"/>
                 </a:solidFill>
                 <a:latin typeface="Verdana" pitchFamily="34" charset="0"/>
                 <a:ea typeface="Verdana" pitchFamily="34" charset="-122"/>
                 <a:cs typeface="Verdana" pitchFamily="34" charset="-120"/>
               </a:rPr>
-              <a:t>Watch a 3-phase chain run live</a:t>
+              <a:t>Review the brief. Then follow the chain.</a:t>
             </a:r>
             <a:endParaRPr lang="en-US" sz="2800" dirty="0"/>
           </a:p>
@@ -7762,92 +7668,24 @@
         </p:nvSpPr>
         <p:spPr>
           <a:xfrm>
-            <a:off x="914400" y="914400"/>
-            <a:ext cx="7315200" cy="3291840"/>
-          </a:xfrm>
-          <a:prstGeom prst="rect">
-            <a:avLst/>
-          </a:prstGeom>
-          <a:noFill/>
-          <a:ln/>
-        </p:spPr>
-        <p:txBody>
-          <a:bodyPr wrap="square" lIns="0" tIns="0" rIns="0" bIns="0" rtlCol="0" anchor="ctr"/>
-          <a:lstStyle/>
-          <a:p>
-            <a:pPr algn="ctr" indent="0" marL="0">
-              <a:buNone/>
-            </a:pPr>
-            <a:r>
-              <a:rPr lang="en-US" sz="2800" b="1" dirty="0">
-                <a:solidFill>
-                  <a:srgbClr val="635BFF"/>
-                </a:solidFill>
-                <a:latin typeface="Georgia" pitchFamily="34" charset="0"/>
-                <a:ea typeface="Georgia" pitchFamily="34" charset="-122"/>
-                <a:cs typeface="Georgia" pitchFamily="34" charset="-120"/>
-              </a:rPr>
-              <a:t>Phase 1: New conversation</a:t>
-            </a:r>
-            <a:endParaRPr lang="en-US" sz="2800" dirty="0"/>
-          </a:p>
-          <a:p>
-            <a:pPr algn="ctr" indent="0" marL="0">
-              <a:buNone/>
-            </a:pPr>
-            <a:r>
-              <a:rPr lang="en-US" sz="2800" b="1" dirty="0">
-                <a:solidFill>
-                  <a:srgbClr val="635BFF"/>
-                </a:solidFill>
-                <a:latin typeface="Georgia" pitchFamily="34" charset="0"/>
-                <a:ea typeface="Georgia" pitchFamily="34" charset="-122"/>
-                <a:cs typeface="Georgia" pitchFamily="34" charset="-120"/>
-              </a:rPr>
-              <a:t>→ give it your task → save output</a:t>
-            </a:r>
-            <a:endParaRPr lang="en-US" sz="2800" dirty="0"/>
-          </a:p>
-          <a:p>
-            <a:pPr algn="ctr" indent="0" marL="0">
-              <a:buNone/>
-            </a:pPr>
-            <a:r>
-              <a:rPr lang="en-US" sz="2800" b="1" dirty="0">
-                <a:solidFill>
-                  <a:srgbClr val="635BFF"/>
-                </a:solidFill>
-                <a:latin typeface="Georgia" pitchFamily="34" charset="0"/>
-                <a:ea typeface="Georgia" pitchFamily="34" charset="-122"/>
-                <a:cs typeface="Georgia" pitchFamily="34" charset="-120"/>
-              </a:rPr>
-              <a:t>Phase 2: New conversation</a:t>
-            </a:r>
-            <a:endParaRPr lang="en-US" sz="2800" dirty="0"/>
-          </a:p>
-          <a:p>
-            <a:pPr algn="ctr" indent="0" marL="0">
-              <a:buNone/>
-            </a:pPr>
-            <a:r>
-              <a:rPr lang="en-US" sz="2800" b="1" dirty="0">
-                <a:solidFill>
-                  <a:srgbClr val="635BFF"/>
-                </a:solidFill>
-                <a:latin typeface="Georgia" pitchFamily="34" charset="0"/>
-                <a:ea typeface="Georgia" pitchFamily="34" charset="-122"/>
-                <a:cs typeface="Georgia" pitchFamily="34" charset="-120"/>
-              </a:rPr>
-              <a:t>→ paste Phase 1's output → draft</a:t>
-            </a:r>
-            <a:endParaRPr lang="en-US" sz="2800" dirty="0"/>
-          </a:p>
-          <a:p>
-            <a:pPr algn="ctr" indent="0" marL="0">
-              <a:buNone/>
-            </a:pPr>
-            <a:r>
-              <a:rPr lang="en-US" sz="2200" i="1" dirty="0">
+            <a:off x="1371600" y="731520"/>
+            <a:ext cx="6400800" cy="731520"/>
+          </a:xfrm>
+          <a:prstGeom prst="rect">
+            <a:avLst/>
+          </a:prstGeom>
+          <a:noFill/>
+          <a:ln/>
+        </p:spPr>
+        <p:txBody>
+          <a:bodyPr wrap="square" lIns="0" tIns="0" rIns="0" bIns="0" rtlCol="0" anchor="b"/>
+          <a:lstStyle/>
+          <a:p>
+            <a:pPr indent="0" marL="0">
+              <a:buNone/>
+            </a:pPr>
+            <a:r>
+              <a:rPr lang="en-US" sz="2800" dirty="0">
                 <a:solidFill>
                   <a:srgbClr val="8B95A5"/>
                 </a:solidFill>
@@ -7855,26 +7693,342 @@
                 <a:ea typeface="Verdana" pitchFamily="34" charset="-122"/>
                 <a:cs typeface="Verdana" pitchFamily="34" charset="-120"/>
               </a:rPr>
-              <a:t>How does this compare to one</a:t>
+              <a:t>[topic]/</a:t>
             </a:r>
             <a:endParaRPr lang="en-US" sz="2800" dirty="0"/>
           </a:p>
-          <a:p>
-            <a:pPr algn="ctr" indent="0" marL="0">
-              <a:buNone/>
-            </a:pPr>
-            <a:r>
-              <a:rPr lang="en-US" sz="2200" i="1" dirty="0">
-                <a:solidFill>
-                  <a:srgbClr val="8B95A5"/>
+        </p:txBody>
+      </p:sp>
+      <p:sp>
+        <p:nvSpPr>
+          <p:cNvPr id="4" name="Text 2"/>
+          <p:cNvSpPr/>
+          <p:nvPr/>
+        </p:nvSpPr>
+        <p:spPr>
+          <a:xfrm>
+            <a:off x="1828800" y="1645920"/>
+            <a:ext cx="3200400" cy="640080"/>
+          </a:xfrm>
+          <a:prstGeom prst="rect">
+            <a:avLst/>
+          </a:prstGeom>
+          <a:noFill/>
+          <a:ln/>
+        </p:spPr>
+        <p:txBody>
+          <a:bodyPr wrap="square" lIns="0" tIns="0" rIns="0" bIns="0" rtlCol="0" anchor="ctr"/>
+          <a:lstStyle/>
+          <a:p>
+            <a:pPr indent="0" marL="0">
+              <a:buNone/>
+            </a:pPr>
+            <a:r>
+              <a:rPr lang="en-US" sz="2600" b="1" dirty="0">
+                <a:solidFill>
+                  <a:srgbClr val="FFFFFF"/>
                 </a:solidFill>
                 <a:latin typeface="Verdana" pitchFamily="34" charset="0"/>
                 <a:ea typeface="Verdana" pitchFamily="34" charset="-122"/>
                 <a:cs typeface="Verdana" pitchFamily="34" charset="-120"/>
               </a:rPr>
-              <a:t>conversation doing everything?</a:t>
-            </a:r>
-            <a:endParaRPr lang="en-US" sz="2800" dirty="0"/>
+              <a:t>brief.md</a:t>
+            </a:r>
+            <a:endParaRPr lang="en-US" sz="2600" dirty="0"/>
+          </a:p>
+        </p:txBody>
+      </p:sp>
+      <p:sp>
+        <p:nvSpPr>
+          <p:cNvPr id="5" name="Text 3"/>
+          <p:cNvSpPr/>
+          <p:nvPr/>
+        </p:nvSpPr>
+        <p:spPr>
+          <a:xfrm>
+            <a:off x="5303520" y="1645920"/>
+            <a:ext cx="2286000" cy="640080"/>
+          </a:xfrm>
+          <a:prstGeom prst="rect">
+            <a:avLst/>
+          </a:prstGeom>
+          <a:noFill/>
+          <a:ln/>
+        </p:spPr>
+        <p:txBody>
+          <a:bodyPr wrap="square" lIns="0" tIns="0" rIns="0" bIns="0" rtlCol="0" anchor="ctr"/>
+          <a:lstStyle/>
+          <a:p>
+            <a:pPr indent="0" marL="0">
+              <a:buNone/>
+            </a:pPr>
+            <a:r>
+              <a:rPr lang="en-US" sz="1800" i="1" dirty="0">
+                <a:solidFill>
+                  <a:srgbClr val="635BFF"/>
+                </a:solidFill>
+                <a:latin typeface="Verdana" pitchFamily="34" charset="0"/>
+                <a:ea typeface="Verdana" pitchFamily="34" charset="-122"/>
+                <a:cs typeface="Verdana" pitchFamily="34" charset="-120"/>
+              </a:rPr>
+              <a:t>Research Skill</a:t>
+            </a:r>
+            <a:endParaRPr lang="en-US" sz="1800" dirty="0"/>
+          </a:p>
+        </p:txBody>
+      </p:sp>
+      <p:sp>
+        <p:nvSpPr>
+          <p:cNvPr id="6" name="Shape 4"/>
+          <p:cNvSpPr/>
+          <p:nvPr/>
+        </p:nvSpPr>
+        <p:spPr>
+          <a:xfrm>
+            <a:off x="1371600" y="1828800"/>
+            <a:ext cx="274320" cy="274320"/>
+          </a:xfrm>
+          <a:prstGeom prst="ellipse">
+            <a:avLst/>
+          </a:prstGeom>
+          <a:solidFill>
+            <a:srgbClr val="635BFF"/>
+          </a:solidFill>
+          <a:ln/>
+        </p:spPr>
+      </p:sp>
+      <p:sp>
+        <p:nvSpPr>
+          <p:cNvPr id="7" name="Text 5"/>
+          <p:cNvSpPr/>
+          <p:nvPr/>
+        </p:nvSpPr>
+        <p:spPr>
+          <a:xfrm>
+            <a:off x="1828800" y="2468880"/>
+            <a:ext cx="3200400" cy="640080"/>
+          </a:xfrm>
+          <a:prstGeom prst="rect">
+            <a:avLst/>
+          </a:prstGeom>
+          <a:noFill/>
+          <a:ln/>
+        </p:spPr>
+        <p:txBody>
+          <a:bodyPr wrap="square" lIns="0" tIns="0" rIns="0" bIns="0" rtlCol="0" anchor="ctr"/>
+          <a:lstStyle/>
+          <a:p>
+            <a:pPr indent="0" marL="0">
+              <a:buNone/>
+            </a:pPr>
+            <a:r>
+              <a:rPr lang="en-US" sz="2600" b="1" dirty="0">
+                <a:solidFill>
+                  <a:srgbClr val="FFFFFF"/>
+                </a:solidFill>
+                <a:latin typeface="Verdana" pitchFamily="34" charset="0"/>
+                <a:ea typeface="Verdana" pitchFamily="34" charset="-122"/>
+                <a:cs typeface="Verdana" pitchFamily="34" charset="-120"/>
+              </a:rPr>
+              <a:t>draft.md</a:t>
+            </a:r>
+            <a:endParaRPr lang="en-US" sz="2600" dirty="0"/>
+          </a:p>
+        </p:txBody>
+      </p:sp>
+      <p:sp>
+        <p:nvSpPr>
+          <p:cNvPr id="8" name="Text 6"/>
+          <p:cNvSpPr/>
+          <p:nvPr/>
+        </p:nvSpPr>
+        <p:spPr>
+          <a:xfrm>
+            <a:off x="5303520" y="2468880"/>
+            <a:ext cx="2286000" cy="640080"/>
+          </a:xfrm>
+          <a:prstGeom prst="rect">
+            <a:avLst/>
+          </a:prstGeom>
+          <a:noFill/>
+          <a:ln/>
+        </p:spPr>
+        <p:txBody>
+          <a:bodyPr wrap="square" lIns="0" tIns="0" rIns="0" bIns="0" rtlCol="0" anchor="ctr"/>
+          <a:lstStyle/>
+          <a:p>
+            <a:pPr indent="0" marL="0">
+              <a:buNone/>
+            </a:pPr>
+            <a:r>
+              <a:rPr lang="en-US" sz="1800" i="1" dirty="0">
+                <a:solidFill>
+                  <a:srgbClr val="635BFF"/>
+                </a:solidFill>
+                <a:latin typeface="Verdana" pitchFamily="34" charset="0"/>
+                <a:ea typeface="Verdana" pitchFamily="34" charset="-122"/>
+                <a:cs typeface="Verdana" pitchFamily="34" charset="-120"/>
+              </a:rPr>
+              <a:t>Draft Skill</a:t>
+            </a:r>
+            <a:endParaRPr lang="en-US" sz="1800" dirty="0"/>
+          </a:p>
+        </p:txBody>
+      </p:sp>
+      <p:sp>
+        <p:nvSpPr>
+          <p:cNvPr id="9" name="Shape 7"/>
+          <p:cNvSpPr/>
+          <p:nvPr/>
+        </p:nvSpPr>
+        <p:spPr>
+          <a:xfrm>
+            <a:off x="1371600" y="2651760"/>
+            <a:ext cx="274320" cy="274320"/>
+          </a:xfrm>
+          <a:prstGeom prst="ellipse">
+            <a:avLst/>
+          </a:prstGeom>
+          <a:solidFill>
+            <a:srgbClr val="635BFF"/>
+          </a:solidFill>
+          <a:ln/>
+        </p:spPr>
+      </p:sp>
+      <p:sp>
+        <p:nvSpPr>
+          <p:cNvPr id="10" name="Text 8"/>
+          <p:cNvSpPr/>
+          <p:nvPr/>
+        </p:nvSpPr>
+        <p:spPr>
+          <a:xfrm>
+            <a:off x="1828800" y="3291840"/>
+            <a:ext cx="3200400" cy="640080"/>
+          </a:xfrm>
+          <a:prstGeom prst="rect">
+            <a:avLst/>
+          </a:prstGeom>
+          <a:noFill/>
+          <a:ln/>
+        </p:spPr>
+        <p:txBody>
+          <a:bodyPr wrap="square" lIns="0" tIns="0" rIns="0" bIns="0" rtlCol="0" anchor="ctr"/>
+          <a:lstStyle/>
+          <a:p>
+            <a:pPr indent="0" marL="0">
+              <a:buNone/>
+            </a:pPr>
+            <a:r>
+              <a:rPr lang="en-US" sz="2600" b="1" dirty="0">
+                <a:solidFill>
+                  <a:srgbClr val="FFFFFF"/>
+                </a:solidFill>
+                <a:latin typeface="Verdana" pitchFamily="34" charset="0"/>
+                <a:ea typeface="Verdana" pitchFamily="34" charset="-122"/>
+                <a:cs typeface="Verdana" pitchFamily="34" charset="-120"/>
+              </a:rPr>
+              <a:t>review.md</a:t>
+            </a:r>
+            <a:endParaRPr lang="en-US" sz="2600" dirty="0"/>
+          </a:p>
+        </p:txBody>
+      </p:sp>
+      <p:sp>
+        <p:nvSpPr>
+          <p:cNvPr id="11" name="Text 9"/>
+          <p:cNvSpPr/>
+          <p:nvPr/>
+        </p:nvSpPr>
+        <p:spPr>
+          <a:xfrm>
+            <a:off x="5303520" y="3291840"/>
+            <a:ext cx="2286000" cy="640080"/>
+          </a:xfrm>
+          <a:prstGeom prst="rect">
+            <a:avLst/>
+          </a:prstGeom>
+          <a:noFill/>
+          <a:ln/>
+        </p:spPr>
+        <p:txBody>
+          <a:bodyPr wrap="square" lIns="0" tIns="0" rIns="0" bIns="0" rtlCol="0" anchor="ctr"/>
+          <a:lstStyle/>
+          <a:p>
+            <a:pPr indent="0" marL="0">
+              <a:buNone/>
+            </a:pPr>
+            <a:r>
+              <a:rPr lang="en-US" sz="1800" i="1" dirty="0">
+                <a:solidFill>
+                  <a:srgbClr val="635BFF"/>
+                </a:solidFill>
+                <a:latin typeface="Verdana" pitchFamily="34" charset="0"/>
+                <a:ea typeface="Verdana" pitchFamily="34" charset="-122"/>
+                <a:cs typeface="Verdana" pitchFamily="34" charset="-120"/>
+              </a:rPr>
+              <a:t>Review Skill</a:t>
+            </a:r>
+            <a:endParaRPr lang="en-US" sz="1800" dirty="0"/>
+          </a:p>
+        </p:txBody>
+      </p:sp>
+      <p:sp>
+        <p:nvSpPr>
+          <p:cNvPr id="12" name="Shape 10"/>
+          <p:cNvSpPr/>
+          <p:nvPr/>
+        </p:nvSpPr>
+        <p:spPr>
+          <a:xfrm>
+            <a:off x="1371600" y="3474720"/>
+            <a:ext cx="274320" cy="274320"/>
+          </a:xfrm>
+          <a:prstGeom prst="ellipse">
+            <a:avLst/>
+          </a:prstGeom>
+          <a:solidFill>
+            <a:srgbClr val="635BFF"/>
+          </a:solidFill>
+          <a:ln/>
+        </p:spPr>
+      </p:sp>
+      <p:sp>
+        <p:nvSpPr>
+          <p:cNvPr id="13" name="Text 11"/>
+          <p:cNvSpPr/>
+          <p:nvPr/>
+        </p:nvSpPr>
+        <p:spPr>
+          <a:xfrm>
+            <a:off x="1371600" y="4114800"/>
+            <a:ext cx="6400800" cy="548640"/>
+          </a:xfrm>
+          <a:prstGeom prst="rect">
+            <a:avLst/>
+          </a:prstGeom>
+          <a:noFill/>
+          <a:ln/>
+        </p:spPr>
+        <p:txBody>
+          <a:bodyPr wrap="square" lIns="0" tIns="0" rIns="0" bIns="0" rtlCol="0" anchor="t"/>
+          <a:lstStyle/>
+          <a:p>
+            <a:pPr indent="0" marL="0">
+              <a:buNone/>
+            </a:pPr>
+            <a:r>
+              <a:rPr lang="en-US" sz="1800" i="1" dirty="0">
+                <a:solidFill>
+                  <a:srgbClr val="8B95A5"/>
+                </a:solidFill>
+                <a:latin typeface="Verdana" pitchFamily="34" charset="0"/>
+                <a:ea typeface="Verdana" pitchFamily="34" charset="-122"/>
+                <a:cs typeface="Verdana" pitchFamily="34" charset="-120"/>
+              </a:rPr>
+              <a:t>draft.md never saw the raw sources. That's filtered context.</a:t>
+            </a:r>
+            <a:endParaRPr lang="en-US" sz="1800" dirty="0"/>
           </a:p>
         </p:txBody>
       </p:sp>
@@ -7940,17 +8094,17 @@
         </p:nvSpPr>
         <p:spPr>
           <a:xfrm>
-            <a:off x="457200" y="1097280"/>
-            <a:ext cx="3840480" cy="731520"/>
-          </a:xfrm>
-          <a:prstGeom prst="rect">
-            <a:avLst/>
-          </a:prstGeom>
-          <a:noFill/>
-          <a:ln/>
-        </p:spPr>
-        <p:txBody>
-          <a:bodyPr wrap="square" lIns="0" tIns="0" rIns="0" bIns="0" rtlCol="0" anchor="b"/>
+            <a:off x="914400" y="914400"/>
+            <a:ext cx="7315200" cy="3291840"/>
+          </a:xfrm>
+          <a:prstGeom prst="rect">
+            <a:avLst/>
+          </a:prstGeom>
+          <a:noFill/>
+          <a:ln/>
+        </p:spPr>
+        <p:txBody>
+          <a:bodyPr wrap="square" lIns="0" tIns="0" rIns="0" bIns="0" rtlCol="0" anchor="ctr"/>
           <a:lstStyle/>
           <a:p>
             <a:pPr algn="ctr" indent="0" marL="0">
@@ -7959,44 +8113,22 @@
             <a:r>
               <a:rPr lang="en-US" sz="2800" b="1" dirty="0">
                 <a:solidFill>
-                  <a:srgbClr val="8B95A5"/>
+                  <a:srgbClr val="635BFF"/>
                 </a:solidFill>
                 <a:latin typeface="Georgia" pitchFamily="34" charset="0"/>
                 <a:ea typeface="Georgia" pitchFamily="34" charset="-122"/>
                 <a:cs typeface="Georgia" pitchFamily="34" charset="-120"/>
               </a:rPr>
-              <a:t>Workshop 1</a:t>
+              <a:t>Go to Customize → Skills</a:t>
             </a:r>
             <a:endParaRPr lang="en-US" sz="2800" dirty="0"/>
           </a:p>
-        </p:txBody>
-      </p:sp>
-      <p:sp>
-        <p:nvSpPr>
-          <p:cNvPr id="4" name="Text 2"/>
-          <p:cNvSpPr/>
-          <p:nvPr/>
-        </p:nvSpPr>
-        <p:spPr>
-          <a:xfrm>
-            <a:off x="457200" y="2011680"/>
-            <a:ext cx="3840480" cy="548640"/>
-          </a:xfrm>
-          <a:prstGeom prst="rect">
-            <a:avLst/>
-          </a:prstGeom>
-          <a:noFill/>
-          <a:ln/>
-        </p:spPr>
-        <p:txBody>
-          <a:bodyPr wrap="square" lIns="0" tIns="0" rIns="0" bIns="0" rtlCol="0" anchor="t"/>
-          <a:lstStyle/>
-          <a:p>
-            <a:pPr algn="ctr" indent="0" marL="0">
-              <a:buNone/>
-            </a:pPr>
-            <a:r>
-              <a:rPr lang="en-US" sz="2000" i="1" dirty="0">
+          <a:p>
+            <a:pPr algn="ctr" indent="0" marL="0">
+              <a:buNone/>
+            </a:pPr>
+            <a:r>
+              <a:rPr lang="en-US" sz="2200" i="1" dirty="0">
                 <a:solidFill>
                   <a:srgbClr val="8B95A5"/>
                 </a:solidFill>
@@ -8004,149 +8136,43 @@
                 <a:ea typeface="Verdana" pitchFamily="34" charset="-122"/>
                 <a:cs typeface="Verdana" pitchFamily="34" charset="-120"/>
               </a:rPr>
-              <a:t>Your rules + Skills</a:t>
-            </a:r>
-            <a:endParaRPr lang="en-US" sz="2000" dirty="0"/>
-          </a:p>
-        </p:txBody>
-      </p:sp>
-      <p:sp>
-        <p:nvSpPr>
-          <p:cNvPr id="5" name="Shape 3"/>
-          <p:cNvSpPr/>
-          <p:nvPr/>
-        </p:nvSpPr>
-        <p:spPr>
-          <a:xfrm>
-            <a:off x="4572000" y="914400"/>
-            <a:ext cx="0" cy="2377440"/>
-          </a:xfrm>
-          <a:prstGeom prst="line">
-            <a:avLst/>
-          </a:prstGeom>
-          <a:noFill/>
-          <a:ln w="25400">
-            <a:solidFill>
-              <a:srgbClr val="635BFF"/>
-            </a:solidFill>
-            <a:prstDash val="solid"/>
-          </a:ln>
-        </p:spPr>
-      </p:sp>
-      <p:sp>
-        <p:nvSpPr>
-          <p:cNvPr id="6" name="Text 4"/>
-          <p:cNvSpPr/>
-          <p:nvPr/>
-        </p:nvSpPr>
-        <p:spPr>
-          <a:xfrm>
-            <a:off x="4846320" y="1097280"/>
-            <a:ext cx="3840480" cy="731520"/>
-          </a:xfrm>
-          <a:prstGeom prst="rect">
-            <a:avLst/>
-          </a:prstGeom>
-          <a:noFill/>
-          <a:ln/>
-        </p:spPr>
-        <p:txBody>
-          <a:bodyPr wrap="square" lIns="0" tIns="0" rIns="0" bIns="0" rtlCol="0" anchor="b"/>
-          <a:lstStyle/>
-          <a:p>
-            <a:pPr algn="ctr" indent="0" marL="0">
-              <a:buNone/>
-            </a:pPr>
-            <a:r>
-              <a:rPr lang="en-US" sz="2800" b="1" dirty="0">
-                <a:solidFill>
-                  <a:srgbClr val="FFFFFF"/>
+              <a:t>Click the Research Skill</a:t>
+            </a:r>
+            <a:endParaRPr lang="en-US" sz="2800" dirty="0"/>
+          </a:p>
+          <a:p>
+            <a:pPr algn="ctr" indent="0" marL="0">
+              <a:buNone/>
+            </a:pPr>
+            <a:r>
+              <a:rPr lang="en-US" sz="2200" i="1" dirty="0">
+                <a:solidFill>
+                  <a:srgbClr val="8B95A5"/>
+                </a:solidFill>
+                <a:latin typeface="Verdana" pitchFamily="34" charset="0"/>
+                <a:ea typeface="Verdana" pitchFamily="34" charset="-122"/>
+                <a:cs typeface="Verdana" pitchFamily="34" charset="-120"/>
+              </a:rPr>
+              <a:t>→ view its SKILL.md</a:t>
+            </a:r>
+            <a:endParaRPr lang="en-US" sz="2800" dirty="0"/>
+          </a:p>
+          <a:p>
+            <a:pPr algn="ctr" indent="0" marL="0">
+              <a:buNone/>
+            </a:pPr>
+            <a:r>
+              <a:rPr lang="en-US" sz="3600" b="1" dirty="0">
+                <a:solidFill>
+                  <a:srgbClr val="635BFF"/>
                 </a:solidFill>
                 <a:latin typeface="Georgia" pitchFamily="34" charset="0"/>
                 <a:ea typeface="Georgia" pitchFamily="34" charset="-122"/>
                 <a:cs typeface="Georgia" pitchFamily="34" charset="-120"/>
               </a:rPr>
-              <a:t>Workshop 2</a:t>
+              <a:t>What would you add or change?</a:t>
             </a:r>
             <a:endParaRPr lang="en-US" sz="2800" dirty="0"/>
-          </a:p>
-        </p:txBody>
-      </p:sp>
-      <p:sp>
-        <p:nvSpPr>
-          <p:cNvPr id="7" name="Text 5"/>
-          <p:cNvSpPr/>
-          <p:nvPr/>
-        </p:nvSpPr>
-        <p:spPr>
-          <a:xfrm>
-            <a:off x="4846320" y="2011680"/>
-            <a:ext cx="3840480" cy="548640"/>
-          </a:xfrm>
-          <a:prstGeom prst="rect">
-            <a:avLst/>
-          </a:prstGeom>
-          <a:noFill/>
-          <a:ln/>
-        </p:spPr>
-        <p:txBody>
-          <a:bodyPr wrap="square" lIns="0" tIns="0" rIns="0" bIns="0" rtlCol="0" anchor="t"/>
-          <a:lstStyle/>
-          <a:p>
-            <a:pPr algn="ctr" indent="0" marL="0">
-              <a:buNone/>
-            </a:pPr>
-            <a:r>
-              <a:rPr lang="en-US" sz="2000" i="1" dirty="0">
-                <a:solidFill>
-                  <a:srgbClr val="635BFF"/>
-                </a:solidFill>
-                <a:latin typeface="Verdana" pitchFamily="34" charset="0"/>
-                <a:ea typeface="Verdana" pitchFamily="34" charset="-122"/>
-                <a:cs typeface="Verdana" pitchFamily="34" charset="-120"/>
-              </a:rPr>
-              <a:t>Each step gets its own Skill</a:t>
-            </a:r>
-            <a:endParaRPr lang="en-US" sz="2000" dirty="0"/>
-          </a:p>
-        </p:txBody>
-      </p:sp>
-      <p:sp>
-        <p:nvSpPr>
-          <p:cNvPr id="8" name="Text 6"/>
-          <p:cNvSpPr/>
-          <p:nvPr/>
-        </p:nvSpPr>
-        <p:spPr>
-          <a:xfrm>
-            <a:off x="914400" y="3474720"/>
-            <a:ext cx="7315200" cy="548640"/>
-          </a:xfrm>
-          <a:prstGeom prst="rect">
-            <a:avLst/>
-          </a:prstGeom>
-          <a:noFill/>
-          <a:ln/>
-        </p:spPr>
-        <p:txBody>
-          <a:bodyPr wrap="square" lIns="0" tIns="0" rIns="0" bIns="0" rtlCol="0" anchor="ctr"/>
-          <a:lstStyle/>
-          <a:p>
-            <a:pPr algn="ctr" indent="0" marL="0">
-              <a:buNone/>
-            </a:pPr>
-            <a:r>
-              <a:rPr lang="en-US" sz="2000" i="1" dirty="0">
-                <a:solidFill>
-                  <a:srgbClr val="8B95A5"/>
-                </a:solidFill>
-                <a:latin typeface="Verdana" pitchFamily="34" charset="0"/>
-                <a:ea typeface="Verdana" pitchFamily="34" charset="-122"/>
-                <a:cs typeface="Verdana" pitchFamily="34" charset="-120"/>
-              </a:rPr>
-              <a:t>Same concept. Now each agent in the chain gets its own playbook.</a:t>
-            </a:r>
-            <a:endParaRPr lang="en-US" sz="2000" dirty="0"/>
           </a:p>
         </p:txBody>
       </p:sp>
@@ -8212,8 +8238,8 @@
         </p:nvSpPr>
         <p:spPr>
           <a:xfrm>
-            <a:off x="914400" y="914400"/>
-            <a:ext cx="7315200" cy="3291840"/>
+            <a:off x="914400" y="1097280"/>
+            <a:ext cx="7315200" cy="2560320"/>
           </a:xfrm>
           <a:prstGeom prst="rect">
             <a:avLst/>
@@ -8229,68 +8255,34 @@
               <a:buNone/>
             </a:pPr>
             <a:r>
-              <a:rPr lang="en-US" sz="2800" b="1" dirty="0">
-                <a:solidFill>
-                  <a:srgbClr val="635BFF"/>
+              <a:rPr lang="en-US" sz="4400" b="1" dirty="0">
+                <a:solidFill>
+                  <a:srgbClr val="FFFFFF"/>
                 </a:solidFill>
                 <a:latin typeface="Georgia" pitchFamily="34" charset="0"/>
                 <a:ea typeface="Georgia" pitchFamily="34" charset="-122"/>
                 <a:cs typeface="Georgia" pitchFamily="34" charset="-120"/>
               </a:rPr>
-              <a:t>Go to Customize → Skills</a:t>
-            </a:r>
-            <a:endParaRPr lang="en-US" sz="2800" dirty="0"/>
-          </a:p>
-          <a:p>
-            <a:pPr algn="ctr" indent="0" marL="0">
-              <a:buNone/>
-            </a:pPr>
-            <a:r>
-              <a:rPr lang="en-US" sz="2200" i="1" dirty="0">
-                <a:solidFill>
-                  <a:srgbClr val="8B95A5"/>
-                </a:solidFill>
-                <a:latin typeface="Verdana" pitchFamily="34" charset="0"/>
-                <a:ea typeface="Verdana" pitchFamily="34" charset="-122"/>
-                <a:cs typeface="Verdana" pitchFamily="34" charset="-120"/>
-              </a:rPr>
-              <a:t>Click the Research Skill</a:t>
-            </a:r>
-            <a:endParaRPr lang="en-US" sz="2800" dirty="0"/>
-          </a:p>
-          <a:p>
-            <a:pPr algn="ctr" indent="0" marL="0">
-              <a:buNone/>
-            </a:pPr>
-            <a:r>
-              <a:rPr lang="en-US" sz="2200" i="1" dirty="0">
-                <a:solidFill>
-                  <a:srgbClr val="8B95A5"/>
-                </a:solidFill>
-                <a:latin typeface="Verdana" pitchFamily="34" charset="0"/>
-                <a:ea typeface="Verdana" pitchFamily="34" charset="-122"/>
-                <a:cs typeface="Verdana" pitchFamily="34" charset="-120"/>
-              </a:rPr>
-              <a:t>→ view its SKILL.md</a:t>
-            </a:r>
-            <a:endParaRPr lang="en-US" sz="2800" dirty="0"/>
-          </a:p>
-          <a:p>
-            <a:pPr algn="ctr" indent="0" marL="0">
-              <a:buNone/>
-            </a:pPr>
-            <a:r>
-              <a:rPr lang="en-US" sz="3600" b="1" dirty="0">
-                <a:solidFill>
-                  <a:srgbClr val="635BFF"/>
+              <a:t>Claude won't remember.</a:t>
+            </a:r>
+            <a:endParaRPr lang="en-US" sz="4400" dirty="0"/>
+          </a:p>
+          <a:p>
+            <a:pPr algn="ctr" indent="0" marL="0">
+              <a:buNone/>
+            </a:pPr>
+            <a:r>
+              <a:rPr lang="en-US" sz="4400" b="1" dirty="0">
+                <a:solidFill>
+                  <a:srgbClr val="FFFFFF"/>
                 </a:solidFill>
                 <a:latin typeface="Georgia" pitchFamily="34" charset="0"/>
                 <a:ea typeface="Georgia" pitchFamily="34" charset="-122"/>
                 <a:cs typeface="Georgia" pitchFamily="34" charset="-120"/>
               </a:rPr>
-              <a:t>What would you add or change?</a:t>
-            </a:r>
-            <a:endParaRPr lang="en-US" sz="2800" dirty="0"/>
+              <a:t>But the Skill will.</a:t>
+            </a:r>
+            <a:endParaRPr lang="en-US" sz="4400" dirty="0"/>
           </a:p>
         </p:txBody>
       </p:sp>
@@ -8356,51 +8348,73 @@
         </p:nvSpPr>
         <p:spPr>
           <a:xfrm>
-            <a:off x="914400" y="1097280"/>
-            <a:ext cx="7315200" cy="2560320"/>
-          </a:xfrm>
-          <a:prstGeom prst="rect">
-            <a:avLst/>
-          </a:prstGeom>
-          <a:noFill/>
-          <a:ln/>
-        </p:spPr>
-        <p:txBody>
-          <a:bodyPr wrap="square" lIns="0" tIns="0" rIns="0" bIns="0" rtlCol="0" anchor="ctr"/>
-          <a:lstStyle/>
-          <a:p>
-            <a:pPr algn="ctr" indent="0" marL="0">
-              <a:buNone/>
-            </a:pPr>
-            <a:r>
-              <a:rPr lang="en-US" sz="4400" b="1" dirty="0">
-                <a:solidFill>
-                  <a:srgbClr val="FFFFFF"/>
+            <a:off x="457200" y="914400"/>
+            <a:ext cx="8229600" cy="2286000"/>
+          </a:xfrm>
+          <a:prstGeom prst="rect">
+            <a:avLst/>
+          </a:prstGeom>
+          <a:noFill/>
+          <a:ln/>
+        </p:spPr>
+        <p:txBody>
+          <a:bodyPr wrap="square" lIns="0" tIns="0" rIns="0" bIns="0" rtlCol="0" anchor="b"/>
+          <a:lstStyle/>
+          <a:p>
+            <a:pPr algn="ctr" indent="0" marL="0">
+              <a:buNone/>
+            </a:pPr>
+            <a:r>
+              <a:rPr lang="en-US" sz="12000" b="1" dirty="0">
+                <a:solidFill>
+                  <a:srgbClr val="FF6B8A"/>
                 </a:solidFill>
                 <a:latin typeface="Georgia" pitchFamily="34" charset="0"/>
                 <a:ea typeface="Georgia" pitchFamily="34" charset="-122"/>
                 <a:cs typeface="Georgia" pitchFamily="34" charset="-120"/>
               </a:rPr>
-              <a:t>Claude won't remember.</a:t>
-            </a:r>
-            <a:endParaRPr lang="en-US" sz="4400" dirty="0"/>
-          </a:p>
-          <a:p>
-            <a:pPr algn="ctr" indent="0" marL="0">
-              <a:buNone/>
-            </a:pPr>
-            <a:r>
-              <a:rPr lang="en-US" sz="4400" b="1" dirty="0">
-                <a:solidFill>
-                  <a:srgbClr val="FFFFFF"/>
-                </a:solidFill>
-                <a:latin typeface="Georgia" pitchFamily="34" charset="0"/>
-                <a:ea typeface="Georgia" pitchFamily="34" charset="-122"/>
-                <a:cs typeface="Georgia" pitchFamily="34" charset="-120"/>
-              </a:rPr>
-              <a:t>But the Skill will.</a:t>
-            </a:r>
-            <a:endParaRPr lang="en-US" sz="4400" dirty="0"/>
+              <a:t>1.5 hrs</a:t>
+            </a:r>
+            <a:endParaRPr lang="en-US" sz="12000" dirty="0"/>
+          </a:p>
+        </p:txBody>
+      </p:sp>
+      <p:sp>
+        <p:nvSpPr>
+          <p:cNvPr id="4" name="Text 2"/>
+          <p:cNvSpPr/>
+          <p:nvPr/>
+        </p:nvSpPr>
+        <p:spPr>
+          <a:xfrm>
+            <a:off x="1371600" y="3291840"/>
+            <a:ext cx="6400800" cy="731520"/>
+          </a:xfrm>
+          <a:prstGeom prst="rect">
+            <a:avLst/>
+          </a:prstGeom>
+          <a:noFill/>
+          <a:ln/>
+        </p:spPr>
+        <p:txBody>
+          <a:bodyPr wrap="square" lIns="0" tIns="0" rIns="0" bIns="0" rtlCol="0" anchor="t"/>
+          <a:lstStyle/>
+          <a:p>
+            <a:pPr algn="ctr" indent="0" marL="0">
+              <a:buNone/>
+            </a:pPr>
+            <a:r>
+              <a:rPr lang="en-US" sz="2800" dirty="0">
+                <a:solidFill>
+                  <a:srgbClr val="8B95A5"/>
+                </a:solidFill>
+                <a:latin typeface="Verdana" pitchFamily="34" charset="0"/>
+                <a:ea typeface="Verdana" pitchFamily="34" charset="-122"/>
+                <a:cs typeface="Verdana" pitchFamily="34" charset="-120"/>
+              </a:rPr>
+              <a:t>of you being the bottleneck</a:t>
+            </a:r>
+            <a:endParaRPr lang="en-US" sz="2800" dirty="0"/>
           </a:p>
         </p:txBody>
       </p:sp>
@@ -8485,13 +8499,13 @@
             <a:r>
               <a:rPr lang="en-US" sz="12000" b="1" dirty="0">
                 <a:solidFill>
-                  <a:srgbClr val="FF6B8A"/>
+                  <a:srgbClr val="09825D"/>
                 </a:solidFill>
                 <a:latin typeface="Georgia" pitchFamily="34" charset="0"/>
                 <a:ea typeface="Georgia" pitchFamily="34" charset="-122"/>
                 <a:cs typeface="Georgia" pitchFamily="34" charset="-120"/>
               </a:rPr>
-              <a:t>1.5 hrs</a:t>
+              <a:t>15 min</a:t>
             </a:r>
             <a:endParaRPr lang="en-US" sz="12000" dirty="0"/>
           </a:p>
@@ -8530,7 +8544,7 @@
                 <a:ea typeface="Verdana" pitchFamily="34" charset="-122"/>
                 <a:cs typeface="Verdana" pitchFamily="34" charset="-120"/>
               </a:rPr>
-              <a:t>of you being the bottleneck</a:t>
+              <a:t>of judgment — the part only humans can do</a:t>
             </a:r>
             <a:endParaRPr lang="en-US" sz="2800" dirty="0"/>
           </a:p>
@@ -8592,79 +8606,771 @@
       </p:sp>
       <p:sp>
         <p:nvSpPr>
-          <p:cNvPr id="3" name="Text 1"/>
-          <p:cNvSpPr/>
-          <p:nvPr/>
-        </p:nvSpPr>
-        <p:spPr>
-          <a:xfrm>
-            <a:off x="457200" y="914400"/>
-            <a:ext cx="8229600" cy="2286000"/>
-          </a:xfrm>
-          <a:prstGeom prst="rect">
-            <a:avLst/>
-          </a:prstGeom>
-          <a:noFill/>
-          <a:ln/>
-        </p:spPr>
-        <p:txBody>
-          <a:bodyPr wrap="square" lIns="0" tIns="0" rIns="0" bIns="0" rtlCol="0" anchor="b"/>
-          <a:lstStyle/>
-          <a:p>
-            <a:pPr algn="ctr" indent="0" marL="0">
-              <a:buNone/>
-            </a:pPr>
-            <a:r>
-              <a:rPr lang="en-US" sz="12000" b="1" dirty="0">
-                <a:solidFill>
-                  <a:srgbClr val="09825D"/>
+          <p:cNvPr id="3" name="Shape 1"/>
+          <p:cNvSpPr/>
+          <p:nvPr/>
+        </p:nvSpPr>
+        <p:spPr>
+          <a:xfrm>
+            <a:off x="192024" y="2011680"/>
+            <a:ext cx="1188720" cy="640080"/>
+          </a:xfrm>
+          <a:prstGeom prst="roundRect">
+            <a:avLst>
+              <a:gd name="adj" fmla="val 11429"/>
+            </a:avLst>
+          </a:prstGeom>
+          <a:solidFill>
+            <a:srgbClr val="0A2540">
+              <a:alpha val="50000"/>
+            </a:srgbClr>
+          </a:solidFill>
+          <a:ln w="19050">
+            <a:solidFill>
+              <a:srgbClr val="8B95A5"/>
+            </a:solidFill>
+            <a:prstDash val="solid"/>
+          </a:ln>
+        </p:spPr>
+      </p:sp>
+      <p:sp>
+        <p:nvSpPr>
+          <p:cNvPr id="4" name="Text 2"/>
+          <p:cNvSpPr/>
+          <p:nvPr/>
+        </p:nvSpPr>
+        <p:spPr>
+          <a:xfrm>
+            <a:off x="192024" y="2011680"/>
+            <a:ext cx="1188720" cy="640080"/>
+          </a:xfrm>
+          <a:prstGeom prst="rect">
+            <a:avLst/>
+          </a:prstGeom>
+          <a:noFill/>
+          <a:ln/>
+        </p:spPr>
+        <p:txBody>
+          <a:bodyPr wrap="square" lIns="0" tIns="0" rIns="0" bIns="0" rtlCol="0" anchor="ctr">
+            <a:normAutofit/>
+          </a:bodyPr>
+          <a:lstStyle/>
+          <a:p>
+            <a:pPr algn="ctr" indent="0" marL="0">
+              <a:buNone/>
+            </a:pPr>
+            <a:r>
+              <a:rPr lang="en-US" sz="1100" b="1" dirty="0">
+                <a:solidFill>
+                  <a:srgbClr val="8B95A5"/>
+                </a:solidFill>
+                <a:latin typeface="Verdana" pitchFamily="34" charset="0"/>
+                <a:ea typeface="Verdana" pitchFamily="34" charset="-122"/>
+                <a:cs typeface="Verdana" pitchFamily="34" charset="-120"/>
+              </a:rPr>
+              <a:t>Skeptic</a:t>
+            </a:r>
+            <a:endParaRPr lang="en-US" sz="1100" dirty="0"/>
+          </a:p>
+        </p:txBody>
+      </p:sp>
+      <p:sp>
+        <p:nvSpPr>
+          <p:cNvPr id="5" name="Text 3"/>
+          <p:cNvSpPr/>
+          <p:nvPr/>
+        </p:nvSpPr>
+        <p:spPr>
+          <a:xfrm>
+            <a:off x="1380744" y="2011680"/>
+            <a:ext cx="73152" cy="640080"/>
+          </a:xfrm>
+          <a:prstGeom prst="rect">
+            <a:avLst/>
+          </a:prstGeom>
+          <a:noFill/>
+          <a:ln/>
+        </p:spPr>
+        <p:txBody>
+          <a:bodyPr wrap="square" lIns="0" tIns="0" rIns="0" bIns="0" rtlCol="0" anchor="ctr"/>
+          <a:lstStyle/>
+          <a:p>
+            <a:pPr algn="ctr" indent="0" marL="0">
+              <a:buNone/>
+            </a:pPr>
+            <a:r>
+              <a:rPr lang="en-US" sz="1100" dirty="0">
+                <a:solidFill>
+                  <a:srgbClr val="8B95A5"/>
+                </a:solidFill>
+                <a:latin typeface="Verdana" pitchFamily="34" charset="0"/>
+                <a:ea typeface="Verdana" pitchFamily="34" charset="-122"/>
+                <a:cs typeface="Verdana" pitchFamily="34" charset="-120"/>
+              </a:rPr>
+              <a:t>→</a:t>
+            </a:r>
+            <a:endParaRPr lang="en-US" sz="1100" dirty="0"/>
+          </a:p>
+        </p:txBody>
+      </p:sp>
+      <p:sp>
+        <p:nvSpPr>
+          <p:cNvPr id="6" name="Shape 4"/>
+          <p:cNvSpPr/>
+          <p:nvPr/>
+        </p:nvSpPr>
+        <p:spPr>
+          <a:xfrm>
+            <a:off x="1453896" y="2011680"/>
+            <a:ext cx="1188720" cy="640080"/>
+          </a:xfrm>
+          <a:prstGeom prst="roundRect">
+            <a:avLst>
+              <a:gd name="adj" fmla="val 11429"/>
+            </a:avLst>
+          </a:prstGeom>
+          <a:solidFill>
+            <a:srgbClr val="635BFF"/>
+          </a:solidFill>
+          <a:ln w="19050">
+            <a:solidFill>
+              <a:srgbClr val="635BFF"/>
+            </a:solidFill>
+            <a:prstDash val="solid"/>
+          </a:ln>
+        </p:spPr>
+      </p:sp>
+      <p:sp>
+        <p:nvSpPr>
+          <p:cNvPr id="7" name="Text 5"/>
+          <p:cNvSpPr/>
+          <p:nvPr/>
+        </p:nvSpPr>
+        <p:spPr>
+          <a:xfrm>
+            <a:off x="1453896" y="2011680"/>
+            <a:ext cx="1188720" cy="640080"/>
+          </a:xfrm>
+          <a:prstGeom prst="rect">
+            <a:avLst/>
+          </a:prstGeom>
+          <a:noFill/>
+          <a:ln/>
+        </p:spPr>
+        <p:txBody>
+          <a:bodyPr wrap="square" lIns="0" tIns="0" rIns="0" bIns="0" rtlCol="0" anchor="ctr">
+            <a:normAutofit/>
+          </a:bodyPr>
+          <a:lstStyle/>
+          <a:p>
+            <a:pPr algn="ctr" indent="0" marL="0">
+              <a:buNone/>
+            </a:pPr>
+            <a:r>
+              <a:rPr lang="en-US" sz="1100" b="1" dirty="0">
+                <a:solidFill>
+                  <a:srgbClr val="FFFFFF"/>
+                </a:solidFill>
+                <a:latin typeface="Verdana" pitchFamily="34" charset="0"/>
+                <a:ea typeface="Verdana" pitchFamily="34" charset="-122"/>
+                <a:cs typeface="Verdana" pitchFamily="34" charset="-120"/>
+              </a:rPr>
+              <a:t>Explorer</a:t>
+            </a:r>
+            <a:endParaRPr lang="en-US" sz="1100" dirty="0"/>
+          </a:p>
+        </p:txBody>
+      </p:sp>
+      <p:sp>
+        <p:nvSpPr>
+          <p:cNvPr id="8" name="Text 6"/>
+          <p:cNvSpPr/>
+          <p:nvPr/>
+        </p:nvSpPr>
+        <p:spPr>
+          <a:xfrm>
+            <a:off x="2642616" y="2011680"/>
+            <a:ext cx="73152" cy="640080"/>
+          </a:xfrm>
+          <a:prstGeom prst="rect">
+            <a:avLst/>
+          </a:prstGeom>
+          <a:noFill/>
+          <a:ln/>
+        </p:spPr>
+        <p:txBody>
+          <a:bodyPr wrap="square" lIns="0" tIns="0" rIns="0" bIns="0" rtlCol="0" anchor="ctr"/>
+          <a:lstStyle/>
+          <a:p>
+            <a:pPr algn="ctr" indent="0" marL="0">
+              <a:buNone/>
+            </a:pPr>
+            <a:r>
+              <a:rPr lang="en-US" sz="1100" dirty="0">
+                <a:solidFill>
+                  <a:srgbClr val="8B95A5"/>
+                </a:solidFill>
+                <a:latin typeface="Verdana" pitchFamily="34" charset="0"/>
+                <a:ea typeface="Verdana" pitchFamily="34" charset="-122"/>
+                <a:cs typeface="Verdana" pitchFamily="34" charset="-120"/>
+              </a:rPr>
+              <a:t>→</a:t>
+            </a:r>
+            <a:endParaRPr lang="en-US" sz="1100" dirty="0"/>
+          </a:p>
+        </p:txBody>
+      </p:sp>
+      <p:sp>
+        <p:nvSpPr>
+          <p:cNvPr id="9" name="Shape 7"/>
+          <p:cNvSpPr/>
+          <p:nvPr/>
+        </p:nvSpPr>
+        <p:spPr>
+          <a:xfrm>
+            <a:off x="2715768" y="2011680"/>
+            <a:ext cx="1188720" cy="640080"/>
+          </a:xfrm>
+          <a:prstGeom prst="roundRect">
+            <a:avLst>
+              <a:gd name="adj" fmla="val 11429"/>
+            </a:avLst>
+          </a:prstGeom>
+          <a:solidFill>
+            <a:srgbClr val="635BFF"/>
+          </a:solidFill>
+          <a:ln w="19050">
+            <a:solidFill>
+              <a:srgbClr val="635BFF"/>
+            </a:solidFill>
+            <a:prstDash val="solid"/>
+          </a:ln>
+        </p:spPr>
+      </p:sp>
+      <p:sp>
+        <p:nvSpPr>
+          <p:cNvPr id="10" name="Text 8"/>
+          <p:cNvSpPr/>
+          <p:nvPr/>
+        </p:nvSpPr>
+        <p:spPr>
+          <a:xfrm>
+            <a:off x="2715768" y="2011680"/>
+            <a:ext cx="1188720" cy="640080"/>
+          </a:xfrm>
+          <a:prstGeom prst="rect">
+            <a:avLst/>
+          </a:prstGeom>
+          <a:noFill/>
+          <a:ln/>
+        </p:spPr>
+        <p:txBody>
+          <a:bodyPr wrap="square" lIns="0" tIns="0" rIns="0" bIns="0" rtlCol="0" anchor="ctr">
+            <a:normAutofit/>
+          </a:bodyPr>
+          <a:lstStyle/>
+          <a:p>
+            <a:pPr algn="ctr" indent="0" marL="0">
+              <a:buNone/>
+            </a:pPr>
+            <a:r>
+              <a:rPr lang="en-US" sz="1100" b="1" dirty="0">
+                <a:solidFill>
+                  <a:srgbClr val="FFFFFF"/>
+                </a:solidFill>
+                <a:latin typeface="Verdana" pitchFamily="34" charset="0"/>
+                <a:ea typeface="Verdana" pitchFamily="34" charset="-122"/>
+                <a:cs typeface="Verdana" pitchFamily="34" charset="-120"/>
+              </a:rPr>
+              <a:t>Whisperer</a:t>
+            </a:r>
+            <a:endParaRPr lang="en-US" sz="1100" dirty="0"/>
+          </a:p>
+        </p:txBody>
+      </p:sp>
+      <p:sp>
+        <p:nvSpPr>
+          <p:cNvPr id="11" name="Text 9"/>
+          <p:cNvSpPr/>
+          <p:nvPr/>
+        </p:nvSpPr>
+        <p:spPr>
+          <a:xfrm>
+            <a:off x="3904488" y="2011680"/>
+            <a:ext cx="73152" cy="640080"/>
+          </a:xfrm>
+          <a:prstGeom prst="rect">
+            <a:avLst/>
+          </a:prstGeom>
+          <a:noFill/>
+          <a:ln/>
+        </p:spPr>
+        <p:txBody>
+          <a:bodyPr wrap="square" lIns="0" tIns="0" rIns="0" bIns="0" rtlCol="0" anchor="ctr"/>
+          <a:lstStyle/>
+          <a:p>
+            <a:pPr algn="ctr" indent="0" marL="0">
+              <a:buNone/>
+            </a:pPr>
+            <a:r>
+              <a:rPr lang="en-US" sz="1100" dirty="0">
+                <a:solidFill>
+                  <a:srgbClr val="8B95A5"/>
+                </a:solidFill>
+                <a:latin typeface="Verdana" pitchFamily="34" charset="0"/>
+                <a:ea typeface="Verdana" pitchFamily="34" charset="-122"/>
+                <a:cs typeface="Verdana" pitchFamily="34" charset="-120"/>
+              </a:rPr>
+              <a:t>→</a:t>
+            </a:r>
+            <a:endParaRPr lang="en-US" sz="1100" dirty="0"/>
+          </a:p>
+        </p:txBody>
+      </p:sp>
+      <p:sp>
+        <p:nvSpPr>
+          <p:cNvPr id="12" name="Shape 10"/>
+          <p:cNvSpPr/>
+          <p:nvPr/>
+        </p:nvSpPr>
+        <p:spPr>
+          <a:xfrm>
+            <a:off x="3977640" y="2011680"/>
+            <a:ext cx="1188720" cy="640080"/>
+          </a:xfrm>
+          <a:prstGeom prst="roundRect">
+            <a:avLst>
+              <a:gd name="adj" fmla="val 11429"/>
+            </a:avLst>
+          </a:prstGeom>
+          <a:solidFill>
+            <a:srgbClr val="635BFF"/>
+          </a:solidFill>
+          <a:ln w="19050">
+            <a:solidFill>
+              <a:srgbClr val="635BFF"/>
+            </a:solidFill>
+            <a:prstDash val="solid"/>
+          </a:ln>
+        </p:spPr>
+      </p:sp>
+      <p:sp>
+        <p:nvSpPr>
+          <p:cNvPr id="13" name="Text 11"/>
+          <p:cNvSpPr/>
+          <p:nvPr/>
+        </p:nvSpPr>
+        <p:spPr>
+          <a:xfrm>
+            <a:off x="3977640" y="2011680"/>
+            <a:ext cx="1188720" cy="640080"/>
+          </a:xfrm>
+          <a:prstGeom prst="rect">
+            <a:avLst/>
+          </a:prstGeom>
+          <a:noFill/>
+          <a:ln/>
+        </p:spPr>
+        <p:txBody>
+          <a:bodyPr wrap="square" lIns="0" tIns="0" rIns="0" bIns="0" rtlCol="0" anchor="ctr">
+            <a:normAutofit/>
+          </a:bodyPr>
+          <a:lstStyle/>
+          <a:p>
+            <a:pPr algn="ctr" indent="0" marL="0">
+              <a:buNone/>
+            </a:pPr>
+            <a:r>
+              <a:rPr lang="en-US" sz="1100" b="1" dirty="0">
+                <a:solidFill>
+                  <a:srgbClr val="FFFFFF"/>
+                </a:solidFill>
+                <a:latin typeface="Verdana" pitchFamily="34" charset="0"/>
+                <a:ea typeface="Verdana" pitchFamily="34" charset="-122"/>
+                <a:cs typeface="Verdana" pitchFamily="34" charset="-120"/>
+              </a:rPr>
+              <a:t>Strategist</a:t>
+            </a:r>
+            <a:endParaRPr lang="en-US" sz="1100" dirty="0"/>
+          </a:p>
+        </p:txBody>
+      </p:sp>
+      <p:sp>
+        <p:nvSpPr>
+          <p:cNvPr id="14" name="Text 12"/>
+          <p:cNvSpPr/>
+          <p:nvPr/>
+        </p:nvSpPr>
+        <p:spPr>
+          <a:xfrm>
+            <a:off x="5166360" y="2011680"/>
+            <a:ext cx="73152" cy="640080"/>
+          </a:xfrm>
+          <a:prstGeom prst="rect">
+            <a:avLst/>
+          </a:prstGeom>
+          <a:noFill/>
+          <a:ln/>
+        </p:spPr>
+        <p:txBody>
+          <a:bodyPr wrap="square" lIns="0" tIns="0" rIns="0" bIns="0" rtlCol="0" anchor="ctr"/>
+          <a:lstStyle/>
+          <a:p>
+            <a:pPr algn="ctr" indent="0" marL="0">
+              <a:buNone/>
+            </a:pPr>
+            <a:r>
+              <a:rPr lang="en-US" sz="1100" dirty="0">
+                <a:solidFill>
+                  <a:srgbClr val="8B95A5"/>
+                </a:solidFill>
+                <a:latin typeface="Verdana" pitchFamily="34" charset="0"/>
+                <a:ea typeface="Verdana" pitchFamily="34" charset="-122"/>
+                <a:cs typeface="Verdana" pitchFamily="34" charset="-120"/>
+              </a:rPr>
+              <a:t>→</a:t>
+            </a:r>
+            <a:endParaRPr lang="en-US" sz="1100" dirty="0"/>
+          </a:p>
+        </p:txBody>
+      </p:sp>
+      <p:sp>
+        <p:nvSpPr>
+          <p:cNvPr id="15" name="Shape 13"/>
+          <p:cNvSpPr/>
+          <p:nvPr/>
+        </p:nvSpPr>
+        <p:spPr>
+          <a:xfrm>
+            <a:off x="5239512" y="2011680"/>
+            <a:ext cx="1188720" cy="640080"/>
+          </a:xfrm>
+          <a:prstGeom prst="roundRect">
+            <a:avLst>
+              <a:gd name="adj" fmla="val 11429"/>
+            </a:avLst>
+          </a:prstGeom>
+          <a:solidFill>
+            <a:srgbClr val="635BFF"/>
+          </a:solidFill>
+          <a:ln w="19050">
+            <a:solidFill>
+              <a:srgbClr val="635BFF"/>
+            </a:solidFill>
+            <a:prstDash val="solid"/>
+          </a:ln>
+        </p:spPr>
+      </p:sp>
+      <p:sp>
+        <p:nvSpPr>
+          <p:cNvPr id="16" name="Text 14"/>
+          <p:cNvSpPr/>
+          <p:nvPr/>
+        </p:nvSpPr>
+        <p:spPr>
+          <a:xfrm>
+            <a:off x="5239512" y="2011680"/>
+            <a:ext cx="1188720" cy="640080"/>
+          </a:xfrm>
+          <a:prstGeom prst="rect">
+            <a:avLst/>
+          </a:prstGeom>
+          <a:noFill/>
+          <a:ln/>
+        </p:spPr>
+        <p:txBody>
+          <a:bodyPr wrap="square" lIns="0" tIns="0" rIns="0" bIns="0" rtlCol="0" anchor="ctr">
+            <a:normAutofit/>
+          </a:bodyPr>
+          <a:lstStyle/>
+          <a:p>
+            <a:pPr algn="ctr" indent="0" marL="0">
+              <a:buNone/>
+            </a:pPr>
+            <a:r>
+              <a:rPr lang="en-US" sz="1100" b="1" dirty="0">
+                <a:solidFill>
+                  <a:srgbClr val="FFFFFF"/>
+                </a:solidFill>
+                <a:latin typeface="Verdana" pitchFamily="34" charset="0"/>
+                <a:ea typeface="Verdana" pitchFamily="34" charset="-122"/>
+                <a:cs typeface="Verdana" pitchFamily="34" charset="-120"/>
+              </a:rPr>
+              <a:t>Operator</a:t>
+            </a:r>
+            <a:endParaRPr lang="en-US" sz="1100" dirty="0"/>
+          </a:p>
+        </p:txBody>
+      </p:sp>
+      <p:sp>
+        <p:nvSpPr>
+          <p:cNvPr id="17" name="Text 15"/>
+          <p:cNvSpPr/>
+          <p:nvPr/>
+        </p:nvSpPr>
+        <p:spPr>
+          <a:xfrm>
+            <a:off x="6428232" y="2011680"/>
+            <a:ext cx="73152" cy="640080"/>
+          </a:xfrm>
+          <a:prstGeom prst="rect">
+            <a:avLst/>
+          </a:prstGeom>
+          <a:noFill/>
+          <a:ln/>
+        </p:spPr>
+        <p:txBody>
+          <a:bodyPr wrap="square" lIns="0" tIns="0" rIns="0" bIns="0" rtlCol="0" anchor="ctr"/>
+          <a:lstStyle/>
+          <a:p>
+            <a:pPr algn="ctr" indent="0" marL="0">
+              <a:buNone/>
+            </a:pPr>
+            <a:r>
+              <a:rPr lang="en-US" sz="1100" dirty="0">
+                <a:solidFill>
+                  <a:srgbClr val="8B95A5"/>
+                </a:solidFill>
+                <a:latin typeface="Verdana" pitchFamily="34" charset="0"/>
+                <a:ea typeface="Verdana" pitchFamily="34" charset="-122"/>
+                <a:cs typeface="Verdana" pitchFamily="34" charset="-120"/>
+              </a:rPr>
+              <a:t>→</a:t>
+            </a:r>
+            <a:endParaRPr lang="en-US" sz="1100" dirty="0"/>
+          </a:p>
+        </p:txBody>
+      </p:sp>
+      <p:sp>
+        <p:nvSpPr>
+          <p:cNvPr id="18" name="Shape 16"/>
+          <p:cNvSpPr/>
+          <p:nvPr/>
+        </p:nvSpPr>
+        <p:spPr>
+          <a:xfrm>
+            <a:off x="6501384" y="2011680"/>
+            <a:ext cx="1188720" cy="640080"/>
+          </a:xfrm>
+          <a:prstGeom prst="roundRect">
+            <a:avLst>
+              <a:gd name="adj" fmla="val 11429"/>
+            </a:avLst>
+          </a:prstGeom>
+          <a:solidFill>
+            <a:srgbClr val="635BFF"/>
+          </a:solidFill>
+          <a:ln w="19050">
+            <a:solidFill>
+              <a:srgbClr val="635BFF"/>
+            </a:solidFill>
+            <a:prstDash val="solid"/>
+          </a:ln>
+        </p:spPr>
+      </p:sp>
+      <p:sp>
+        <p:nvSpPr>
+          <p:cNvPr id="19" name="Text 17"/>
+          <p:cNvSpPr/>
+          <p:nvPr/>
+        </p:nvSpPr>
+        <p:spPr>
+          <a:xfrm>
+            <a:off x="6501384" y="2011680"/>
+            <a:ext cx="1188720" cy="640080"/>
+          </a:xfrm>
+          <a:prstGeom prst="rect">
+            <a:avLst/>
+          </a:prstGeom>
+          <a:noFill/>
+          <a:ln/>
+        </p:spPr>
+        <p:txBody>
+          <a:bodyPr wrap="square" lIns="0" tIns="0" rIns="0" bIns="0" rtlCol="0" anchor="ctr">
+            <a:normAutofit/>
+          </a:bodyPr>
+          <a:lstStyle/>
+          <a:p>
+            <a:pPr algn="ctr" indent="0" marL="0">
+              <a:buNone/>
+            </a:pPr>
+            <a:r>
+              <a:rPr lang="en-US" sz="1100" b="1" dirty="0">
+                <a:solidFill>
+                  <a:srgbClr val="FFFFFF"/>
+                </a:solidFill>
+                <a:latin typeface="Verdana" pitchFamily="34" charset="0"/>
+                <a:ea typeface="Verdana" pitchFamily="34" charset="-122"/>
+                <a:cs typeface="Verdana" pitchFamily="34" charset="-120"/>
+              </a:rPr>
+              <a:t>Orchestrator</a:t>
+            </a:r>
+            <a:endParaRPr lang="en-US" sz="1100" dirty="0"/>
+          </a:p>
+        </p:txBody>
+      </p:sp>
+      <p:sp>
+        <p:nvSpPr>
+          <p:cNvPr id="20" name="Text 18"/>
+          <p:cNvSpPr/>
+          <p:nvPr/>
+        </p:nvSpPr>
+        <p:spPr>
+          <a:xfrm>
+            <a:off x="7690104" y="2011680"/>
+            <a:ext cx="73152" cy="640080"/>
+          </a:xfrm>
+          <a:prstGeom prst="rect">
+            <a:avLst/>
+          </a:prstGeom>
+          <a:noFill/>
+          <a:ln/>
+        </p:spPr>
+        <p:txBody>
+          <a:bodyPr wrap="square" lIns="0" tIns="0" rIns="0" bIns="0" rtlCol="0" anchor="ctr"/>
+          <a:lstStyle/>
+          <a:p>
+            <a:pPr algn="ctr" indent="0" marL="0">
+              <a:buNone/>
+            </a:pPr>
+            <a:r>
+              <a:rPr lang="en-US" sz="1100" dirty="0">
+                <a:solidFill>
+                  <a:srgbClr val="8B95A5"/>
+                </a:solidFill>
+                <a:latin typeface="Verdana" pitchFamily="34" charset="0"/>
+                <a:ea typeface="Verdana" pitchFamily="34" charset="-122"/>
+                <a:cs typeface="Verdana" pitchFamily="34" charset="-120"/>
+              </a:rPr>
+              <a:t>→</a:t>
+            </a:r>
+            <a:endParaRPr lang="en-US" sz="1100" dirty="0"/>
+          </a:p>
+        </p:txBody>
+      </p:sp>
+      <p:sp>
+        <p:nvSpPr>
+          <p:cNvPr id="21" name="Shape 19"/>
+          <p:cNvSpPr/>
+          <p:nvPr/>
+        </p:nvSpPr>
+        <p:spPr>
+          <a:xfrm>
+            <a:off x="7763256" y="2011680"/>
+            <a:ext cx="1188720" cy="640080"/>
+          </a:xfrm>
+          <a:prstGeom prst="roundRect">
+            <a:avLst>
+              <a:gd name="adj" fmla="val 11429"/>
+            </a:avLst>
+          </a:prstGeom>
+          <a:solidFill>
+            <a:srgbClr val="0A2540">
+              <a:alpha val="50000"/>
+            </a:srgbClr>
+          </a:solidFill>
+          <a:ln w="19050">
+            <a:solidFill>
+              <a:srgbClr val="8B95A5"/>
+            </a:solidFill>
+            <a:prstDash val="dash"/>
+          </a:ln>
+        </p:spPr>
+      </p:sp>
+      <p:sp>
+        <p:nvSpPr>
+          <p:cNvPr id="22" name="Text 20"/>
+          <p:cNvSpPr/>
+          <p:nvPr/>
+        </p:nvSpPr>
+        <p:spPr>
+          <a:xfrm>
+            <a:off x="7763256" y="2011680"/>
+            <a:ext cx="1188720" cy="640080"/>
+          </a:xfrm>
+          <a:prstGeom prst="rect">
+            <a:avLst/>
+          </a:prstGeom>
+          <a:noFill/>
+          <a:ln/>
+        </p:spPr>
+        <p:txBody>
+          <a:bodyPr wrap="square" lIns="0" tIns="0" rIns="0" bIns="0" rtlCol="0" anchor="ctr">
+            <a:normAutofit/>
+          </a:bodyPr>
+          <a:lstStyle/>
+          <a:p>
+            <a:pPr algn="ctr" indent="0" marL="0">
+              <a:buNone/>
+            </a:pPr>
+            <a:r>
+              <a:rPr lang="en-US" sz="1100" b="1" dirty="0">
+                <a:solidFill>
+                  <a:srgbClr val="8B95A5"/>
+                </a:solidFill>
+                <a:latin typeface="Verdana" pitchFamily="34" charset="0"/>
+                <a:ea typeface="Verdana" pitchFamily="34" charset="-122"/>
+                <a:cs typeface="Verdana" pitchFamily="34" charset="-120"/>
+              </a:rPr>
+              <a:t>Builder</a:t>
+            </a:r>
+            <a:endParaRPr lang="en-US" sz="1100" dirty="0"/>
+          </a:p>
+        </p:txBody>
+      </p:sp>
+      <p:sp>
+        <p:nvSpPr>
+          <p:cNvPr id="23" name="Text 21"/>
+          <p:cNvSpPr/>
+          <p:nvPr/>
+        </p:nvSpPr>
+        <p:spPr>
+          <a:xfrm>
+            <a:off x="914400" y="3108960"/>
+            <a:ext cx="7315200" cy="548640"/>
+          </a:xfrm>
+          <a:prstGeom prst="rect">
+            <a:avLst/>
+          </a:prstGeom>
+          <a:noFill/>
+          <a:ln/>
+        </p:spPr>
+        <p:txBody>
+          <a:bodyPr wrap="square" lIns="0" tIns="0" rIns="0" bIns="0" rtlCol="0" anchor="ctr"/>
+          <a:lstStyle/>
+          <a:p>
+            <a:pPr algn="ctr" indent="0" marL="0">
+              <a:buNone/>
+            </a:pPr>
+            <a:r>
+              <a:rPr lang="en-US" sz="2400" b="1" dirty="0">
+                <a:solidFill>
+                  <a:srgbClr val="635BFF"/>
                 </a:solidFill>
                 <a:latin typeface="Georgia" pitchFamily="34" charset="0"/>
                 <a:ea typeface="Georgia" pitchFamily="34" charset="-122"/>
                 <a:cs typeface="Georgia" pitchFamily="34" charset="-120"/>
               </a:rPr>
-              <a:t>15 min</a:t>
-            </a:r>
-            <a:endParaRPr lang="en-US" sz="12000" dirty="0"/>
-          </a:p>
-        </p:txBody>
-      </p:sp>
-      <p:sp>
-        <p:nvSpPr>
-          <p:cNvPr id="4" name="Text 2"/>
-          <p:cNvSpPr/>
-          <p:nvPr/>
-        </p:nvSpPr>
-        <p:spPr>
-          <a:xfrm>
-            <a:off x="1371600" y="3291840"/>
-            <a:ext cx="6400800" cy="731520"/>
-          </a:xfrm>
-          <a:prstGeom prst="rect">
-            <a:avLst/>
-          </a:prstGeom>
-          <a:noFill/>
-          <a:ln/>
-        </p:spPr>
-        <p:txBody>
-          <a:bodyPr wrap="square" lIns="0" tIns="0" rIns="0" bIns="0" rtlCol="0" anchor="t"/>
-          <a:lstStyle/>
-          <a:p>
-            <a:pPr algn="ctr" indent="0" marL="0">
-              <a:buNone/>
-            </a:pPr>
-            <a:r>
-              <a:rPr lang="en-US" sz="2800" dirty="0">
-                <a:solidFill>
-                  <a:srgbClr val="8B95A5"/>
-                </a:solidFill>
-                <a:latin typeface="Verdana" pitchFamily="34" charset="0"/>
-                <a:ea typeface="Verdana" pitchFamily="34" charset="-122"/>
-                <a:cs typeface="Verdana" pitchFamily="34" charset="-120"/>
-              </a:rPr>
-              <a:t>of judgment — the part only humans can do</a:t>
-            </a:r>
-            <a:endParaRPr lang="en-US" sz="2800" dirty="0"/>
+              <a:t>You started as an Explorer.</a:t>
+            </a:r>
+            <a:endParaRPr lang="en-US" sz="2400" dirty="0"/>
+          </a:p>
+          <a:p>
+            <a:pPr algn="ctr" indent="0" marL="0">
+              <a:buNone/>
+            </a:pPr>
+            <a:r>
+              <a:rPr lang="en-US" sz="2400" b="1" dirty="0">
+                <a:solidFill>
+                  <a:srgbClr val="635BFF"/>
+                </a:solidFill>
+                <a:latin typeface="Georgia" pitchFamily="34" charset="0"/>
+                <a:ea typeface="Georgia" pitchFamily="34" charset="-122"/>
+                <a:cs typeface="Georgia" pitchFamily="34" charset="-120"/>
+              </a:rPr>
+              <a:t>You’re now an Orchestrator.</a:t>
+            </a:r>
+            <a:endParaRPr lang="en-US" sz="2400" dirty="0"/>
           </a:p>
         </p:txBody>
       </p:sp>
@@ -8679,830 +9385,6 @@
 <file path=ppt/slides/slide28.xml><?xml version="1.0" encoding="utf-8"?>
 <p:sld xmlns:a="http://schemas.openxmlformats.org/drawingml/2006/main" xmlns:r="http://schemas.openxmlformats.org/officeDocument/2006/relationships" xmlns:p="http://schemas.openxmlformats.org/presentationml/2006/main">
   <p:cSld name="Slide 28">
-    <p:bg>
-      <p:bgPr>
-        <a:solidFill>
-          <a:srgbClr val="0A2540"/>
-        </a:solidFill>
-      </p:bgPr>
-    </p:bg>
-    <p:spTree>
-      <p:nvGrpSpPr>
-        <p:cNvPr id="1" name=""/>
-        <p:cNvGrpSpPr/>
-        <p:nvPr/>
-      </p:nvGrpSpPr>
-      <p:grpSpPr>
-        <a:xfrm>
-          <a:off x="0" y="0"/>
-          <a:ext cx="0" cy="0"/>
-          <a:chOff x="0" y="0"/>
-          <a:chExt cx="0" cy="0"/>
-        </a:xfrm>
-      </p:grpSpPr>
-      <p:sp>
-        <p:nvSpPr>
-          <p:cNvPr id="2" name="Shape 0"/>
-          <p:cNvSpPr/>
-          <p:nvPr/>
-        </p:nvSpPr>
-        <p:spPr>
-          <a:xfrm>
-            <a:off x="4572000" y="2286000"/>
-            <a:ext cx="7315200" cy="5486400"/>
-          </a:xfrm>
-          <a:prstGeom prst="ellipse">
-            <a:avLst/>
-          </a:prstGeom>
-          <a:solidFill>
-            <a:srgbClr val="635BFF">
-              <a:alpha val="4000"/>
-            </a:srgbClr>
-          </a:solidFill>
-          <a:ln/>
-        </p:spPr>
-      </p:sp>
-      <p:sp>
-        <p:nvSpPr>
-          <p:cNvPr id="3" name="Shape 1"/>
-          <p:cNvSpPr/>
-          <p:nvPr/>
-        </p:nvSpPr>
-        <p:spPr>
-          <a:xfrm>
-            <a:off x="192024" y="2011680"/>
-            <a:ext cx="1188720" cy="640080"/>
-          </a:xfrm>
-          <a:prstGeom prst="roundRect">
-            <a:avLst>
-              <a:gd name="adj" fmla="val 11429"/>
-            </a:avLst>
-          </a:prstGeom>
-          <a:solidFill>
-            <a:srgbClr val="0A2540">
-              <a:alpha val="50000"/>
-            </a:srgbClr>
-          </a:solidFill>
-          <a:ln w="19050">
-            <a:solidFill>
-              <a:srgbClr val="8B95A5"/>
-            </a:solidFill>
-            <a:prstDash val="solid"/>
-          </a:ln>
-        </p:spPr>
-      </p:sp>
-      <p:sp>
-        <p:nvSpPr>
-          <p:cNvPr id="4" name="Text 2"/>
-          <p:cNvSpPr/>
-          <p:nvPr/>
-        </p:nvSpPr>
-        <p:spPr>
-          <a:xfrm>
-            <a:off x="192024" y="2011680"/>
-            <a:ext cx="1188720" cy="640080"/>
-          </a:xfrm>
-          <a:prstGeom prst="rect">
-            <a:avLst/>
-          </a:prstGeom>
-          <a:noFill/>
-          <a:ln/>
-        </p:spPr>
-        <p:txBody>
-          <a:bodyPr wrap="square" lIns="0" tIns="0" rIns="0" bIns="0" rtlCol="0" anchor="ctr">
-            <a:normAutofit/>
-          </a:bodyPr>
-          <a:lstStyle/>
-          <a:p>
-            <a:pPr algn="ctr" indent="0" marL="0">
-              <a:buNone/>
-            </a:pPr>
-            <a:r>
-              <a:rPr lang="en-US" sz="1100" b="1" dirty="0">
-                <a:solidFill>
-                  <a:srgbClr val="8B95A5"/>
-                </a:solidFill>
-                <a:latin typeface="Verdana" pitchFamily="34" charset="0"/>
-                <a:ea typeface="Verdana" pitchFamily="34" charset="-122"/>
-                <a:cs typeface="Verdana" pitchFamily="34" charset="-120"/>
-              </a:rPr>
-              <a:t>Skeptic</a:t>
-            </a:r>
-            <a:endParaRPr lang="en-US" sz="1100" dirty="0"/>
-          </a:p>
-        </p:txBody>
-      </p:sp>
-      <p:sp>
-        <p:nvSpPr>
-          <p:cNvPr id="5" name="Text 3"/>
-          <p:cNvSpPr/>
-          <p:nvPr/>
-        </p:nvSpPr>
-        <p:spPr>
-          <a:xfrm>
-            <a:off x="1380744" y="2011680"/>
-            <a:ext cx="73152" cy="640080"/>
-          </a:xfrm>
-          <a:prstGeom prst="rect">
-            <a:avLst/>
-          </a:prstGeom>
-          <a:noFill/>
-          <a:ln/>
-        </p:spPr>
-        <p:txBody>
-          <a:bodyPr wrap="square" lIns="0" tIns="0" rIns="0" bIns="0" rtlCol="0" anchor="ctr"/>
-          <a:lstStyle/>
-          <a:p>
-            <a:pPr algn="ctr" indent="0" marL="0">
-              <a:buNone/>
-            </a:pPr>
-            <a:r>
-              <a:rPr lang="en-US" sz="1100" dirty="0">
-                <a:solidFill>
-                  <a:srgbClr val="8B95A5"/>
-                </a:solidFill>
-                <a:latin typeface="Verdana" pitchFamily="34" charset="0"/>
-                <a:ea typeface="Verdana" pitchFamily="34" charset="-122"/>
-                <a:cs typeface="Verdana" pitchFamily="34" charset="-120"/>
-              </a:rPr>
-              <a:t>→</a:t>
-            </a:r>
-            <a:endParaRPr lang="en-US" sz="1100" dirty="0"/>
-          </a:p>
-        </p:txBody>
-      </p:sp>
-      <p:sp>
-        <p:nvSpPr>
-          <p:cNvPr id="6" name="Shape 4"/>
-          <p:cNvSpPr/>
-          <p:nvPr/>
-        </p:nvSpPr>
-        <p:spPr>
-          <a:xfrm>
-            <a:off x="1453896" y="2011680"/>
-            <a:ext cx="1188720" cy="640080"/>
-          </a:xfrm>
-          <a:prstGeom prst="roundRect">
-            <a:avLst>
-              <a:gd name="adj" fmla="val 11429"/>
-            </a:avLst>
-          </a:prstGeom>
-          <a:solidFill>
-            <a:srgbClr val="635BFF"/>
-          </a:solidFill>
-          <a:ln w="19050">
-            <a:solidFill>
-              <a:srgbClr val="635BFF"/>
-            </a:solidFill>
-            <a:prstDash val="solid"/>
-          </a:ln>
-        </p:spPr>
-      </p:sp>
-      <p:sp>
-        <p:nvSpPr>
-          <p:cNvPr id="7" name="Text 5"/>
-          <p:cNvSpPr/>
-          <p:nvPr/>
-        </p:nvSpPr>
-        <p:spPr>
-          <a:xfrm>
-            <a:off x="1453896" y="2011680"/>
-            <a:ext cx="1188720" cy="640080"/>
-          </a:xfrm>
-          <a:prstGeom prst="rect">
-            <a:avLst/>
-          </a:prstGeom>
-          <a:noFill/>
-          <a:ln/>
-        </p:spPr>
-        <p:txBody>
-          <a:bodyPr wrap="square" lIns="0" tIns="0" rIns="0" bIns="0" rtlCol="0" anchor="ctr">
-            <a:normAutofit/>
-          </a:bodyPr>
-          <a:lstStyle/>
-          <a:p>
-            <a:pPr algn="ctr" indent="0" marL="0">
-              <a:buNone/>
-            </a:pPr>
-            <a:r>
-              <a:rPr lang="en-US" sz="1100" b="1" dirty="0">
-                <a:solidFill>
-                  <a:srgbClr val="FFFFFF"/>
-                </a:solidFill>
-                <a:latin typeface="Verdana" pitchFamily="34" charset="0"/>
-                <a:ea typeface="Verdana" pitchFamily="34" charset="-122"/>
-                <a:cs typeface="Verdana" pitchFamily="34" charset="-120"/>
-              </a:rPr>
-              <a:t>Explorer</a:t>
-            </a:r>
-            <a:endParaRPr lang="en-US" sz="1100" dirty="0"/>
-          </a:p>
-        </p:txBody>
-      </p:sp>
-      <p:sp>
-        <p:nvSpPr>
-          <p:cNvPr id="8" name="Text 6"/>
-          <p:cNvSpPr/>
-          <p:nvPr/>
-        </p:nvSpPr>
-        <p:spPr>
-          <a:xfrm>
-            <a:off x="2642616" y="2011680"/>
-            <a:ext cx="73152" cy="640080"/>
-          </a:xfrm>
-          <a:prstGeom prst="rect">
-            <a:avLst/>
-          </a:prstGeom>
-          <a:noFill/>
-          <a:ln/>
-        </p:spPr>
-        <p:txBody>
-          <a:bodyPr wrap="square" lIns="0" tIns="0" rIns="0" bIns="0" rtlCol="0" anchor="ctr"/>
-          <a:lstStyle/>
-          <a:p>
-            <a:pPr algn="ctr" indent="0" marL="0">
-              <a:buNone/>
-            </a:pPr>
-            <a:r>
-              <a:rPr lang="en-US" sz="1100" dirty="0">
-                <a:solidFill>
-                  <a:srgbClr val="8B95A5"/>
-                </a:solidFill>
-                <a:latin typeface="Verdana" pitchFamily="34" charset="0"/>
-                <a:ea typeface="Verdana" pitchFamily="34" charset="-122"/>
-                <a:cs typeface="Verdana" pitchFamily="34" charset="-120"/>
-              </a:rPr>
-              <a:t>→</a:t>
-            </a:r>
-            <a:endParaRPr lang="en-US" sz="1100" dirty="0"/>
-          </a:p>
-        </p:txBody>
-      </p:sp>
-      <p:sp>
-        <p:nvSpPr>
-          <p:cNvPr id="9" name="Shape 7"/>
-          <p:cNvSpPr/>
-          <p:nvPr/>
-        </p:nvSpPr>
-        <p:spPr>
-          <a:xfrm>
-            <a:off x="2715768" y="2011680"/>
-            <a:ext cx="1188720" cy="640080"/>
-          </a:xfrm>
-          <a:prstGeom prst="roundRect">
-            <a:avLst>
-              <a:gd name="adj" fmla="val 11429"/>
-            </a:avLst>
-          </a:prstGeom>
-          <a:solidFill>
-            <a:srgbClr val="635BFF"/>
-          </a:solidFill>
-          <a:ln w="19050">
-            <a:solidFill>
-              <a:srgbClr val="635BFF"/>
-            </a:solidFill>
-            <a:prstDash val="solid"/>
-          </a:ln>
-        </p:spPr>
-      </p:sp>
-      <p:sp>
-        <p:nvSpPr>
-          <p:cNvPr id="10" name="Text 8"/>
-          <p:cNvSpPr/>
-          <p:nvPr/>
-        </p:nvSpPr>
-        <p:spPr>
-          <a:xfrm>
-            <a:off x="2715768" y="2011680"/>
-            <a:ext cx="1188720" cy="640080"/>
-          </a:xfrm>
-          <a:prstGeom prst="rect">
-            <a:avLst/>
-          </a:prstGeom>
-          <a:noFill/>
-          <a:ln/>
-        </p:spPr>
-        <p:txBody>
-          <a:bodyPr wrap="square" lIns="0" tIns="0" rIns="0" bIns="0" rtlCol="0" anchor="ctr">
-            <a:normAutofit/>
-          </a:bodyPr>
-          <a:lstStyle/>
-          <a:p>
-            <a:pPr algn="ctr" indent="0" marL="0">
-              <a:buNone/>
-            </a:pPr>
-            <a:r>
-              <a:rPr lang="en-US" sz="1100" b="1" dirty="0">
-                <a:solidFill>
-                  <a:srgbClr val="FFFFFF"/>
-                </a:solidFill>
-                <a:latin typeface="Verdana" pitchFamily="34" charset="0"/>
-                <a:ea typeface="Verdana" pitchFamily="34" charset="-122"/>
-                <a:cs typeface="Verdana" pitchFamily="34" charset="-120"/>
-              </a:rPr>
-              <a:t>Whisperer</a:t>
-            </a:r>
-            <a:endParaRPr lang="en-US" sz="1100" dirty="0"/>
-          </a:p>
-        </p:txBody>
-      </p:sp>
-      <p:sp>
-        <p:nvSpPr>
-          <p:cNvPr id="11" name="Text 9"/>
-          <p:cNvSpPr/>
-          <p:nvPr/>
-        </p:nvSpPr>
-        <p:spPr>
-          <a:xfrm>
-            <a:off x="3904488" y="2011680"/>
-            <a:ext cx="73152" cy="640080"/>
-          </a:xfrm>
-          <a:prstGeom prst="rect">
-            <a:avLst/>
-          </a:prstGeom>
-          <a:noFill/>
-          <a:ln/>
-        </p:spPr>
-        <p:txBody>
-          <a:bodyPr wrap="square" lIns="0" tIns="0" rIns="0" bIns="0" rtlCol="0" anchor="ctr"/>
-          <a:lstStyle/>
-          <a:p>
-            <a:pPr algn="ctr" indent="0" marL="0">
-              <a:buNone/>
-            </a:pPr>
-            <a:r>
-              <a:rPr lang="en-US" sz="1100" dirty="0">
-                <a:solidFill>
-                  <a:srgbClr val="8B95A5"/>
-                </a:solidFill>
-                <a:latin typeface="Verdana" pitchFamily="34" charset="0"/>
-                <a:ea typeface="Verdana" pitchFamily="34" charset="-122"/>
-                <a:cs typeface="Verdana" pitchFamily="34" charset="-120"/>
-              </a:rPr>
-              <a:t>→</a:t>
-            </a:r>
-            <a:endParaRPr lang="en-US" sz="1100" dirty="0"/>
-          </a:p>
-        </p:txBody>
-      </p:sp>
-      <p:sp>
-        <p:nvSpPr>
-          <p:cNvPr id="12" name="Shape 10"/>
-          <p:cNvSpPr/>
-          <p:nvPr/>
-        </p:nvSpPr>
-        <p:spPr>
-          <a:xfrm>
-            <a:off x="3977640" y="2011680"/>
-            <a:ext cx="1188720" cy="640080"/>
-          </a:xfrm>
-          <a:prstGeom prst="roundRect">
-            <a:avLst>
-              <a:gd name="adj" fmla="val 11429"/>
-            </a:avLst>
-          </a:prstGeom>
-          <a:solidFill>
-            <a:srgbClr val="635BFF"/>
-          </a:solidFill>
-          <a:ln w="19050">
-            <a:solidFill>
-              <a:srgbClr val="635BFF"/>
-            </a:solidFill>
-            <a:prstDash val="solid"/>
-          </a:ln>
-        </p:spPr>
-      </p:sp>
-      <p:sp>
-        <p:nvSpPr>
-          <p:cNvPr id="13" name="Text 11"/>
-          <p:cNvSpPr/>
-          <p:nvPr/>
-        </p:nvSpPr>
-        <p:spPr>
-          <a:xfrm>
-            <a:off x="3977640" y="2011680"/>
-            <a:ext cx="1188720" cy="640080"/>
-          </a:xfrm>
-          <a:prstGeom prst="rect">
-            <a:avLst/>
-          </a:prstGeom>
-          <a:noFill/>
-          <a:ln/>
-        </p:spPr>
-        <p:txBody>
-          <a:bodyPr wrap="square" lIns="0" tIns="0" rIns="0" bIns="0" rtlCol="0" anchor="ctr">
-            <a:normAutofit/>
-          </a:bodyPr>
-          <a:lstStyle/>
-          <a:p>
-            <a:pPr algn="ctr" indent="0" marL="0">
-              <a:buNone/>
-            </a:pPr>
-            <a:r>
-              <a:rPr lang="en-US" sz="1100" b="1" dirty="0">
-                <a:solidFill>
-                  <a:srgbClr val="FFFFFF"/>
-                </a:solidFill>
-                <a:latin typeface="Verdana" pitchFamily="34" charset="0"/>
-                <a:ea typeface="Verdana" pitchFamily="34" charset="-122"/>
-                <a:cs typeface="Verdana" pitchFamily="34" charset="-120"/>
-              </a:rPr>
-              <a:t>Strategist</a:t>
-            </a:r>
-            <a:endParaRPr lang="en-US" sz="1100" dirty="0"/>
-          </a:p>
-        </p:txBody>
-      </p:sp>
-      <p:sp>
-        <p:nvSpPr>
-          <p:cNvPr id="14" name="Text 12"/>
-          <p:cNvSpPr/>
-          <p:nvPr/>
-        </p:nvSpPr>
-        <p:spPr>
-          <a:xfrm>
-            <a:off x="5166360" y="2011680"/>
-            <a:ext cx="73152" cy="640080"/>
-          </a:xfrm>
-          <a:prstGeom prst="rect">
-            <a:avLst/>
-          </a:prstGeom>
-          <a:noFill/>
-          <a:ln/>
-        </p:spPr>
-        <p:txBody>
-          <a:bodyPr wrap="square" lIns="0" tIns="0" rIns="0" bIns="0" rtlCol="0" anchor="ctr"/>
-          <a:lstStyle/>
-          <a:p>
-            <a:pPr algn="ctr" indent="0" marL="0">
-              <a:buNone/>
-            </a:pPr>
-            <a:r>
-              <a:rPr lang="en-US" sz="1100" dirty="0">
-                <a:solidFill>
-                  <a:srgbClr val="8B95A5"/>
-                </a:solidFill>
-                <a:latin typeface="Verdana" pitchFamily="34" charset="0"/>
-                <a:ea typeface="Verdana" pitchFamily="34" charset="-122"/>
-                <a:cs typeface="Verdana" pitchFamily="34" charset="-120"/>
-              </a:rPr>
-              <a:t>→</a:t>
-            </a:r>
-            <a:endParaRPr lang="en-US" sz="1100" dirty="0"/>
-          </a:p>
-        </p:txBody>
-      </p:sp>
-      <p:sp>
-        <p:nvSpPr>
-          <p:cNvPr id="15" name="Shape 13"/>
-          <p:cNvSpPr/>
-          <p:nvPr/>
-        </p:nvSpPr>
-        <p:spPr>
-          <a:xfrm>
-            <a:off x="5239512" y="2011680"/>
-            <a:ext cx="1188720" cy="640080"/>
-          </a:xfrm>
-          <a:prstGeom prst="roundRect">
-            <a:avLst>
-              <a:gd name="adj" fmla="val 11429"/>
-            </a:avLst>
-          </a:prstGeom>
-          <a:solidFill>
-            <a:srgbClr val="635BFF"/>
-          </a:solidFill>
-          <a:ln w="19050">
-            <a:solidFill>
-              <a:srgbClr val="635BFF"/>
-            </a:solidFill>
-            <a:prstDash val="solid"/>
-          </a:ln>
-        </p:spPr>
-      </p:sp>
-      <p:sp>
-        <p:nvSpPr>
-          <p:cNvPr id="16" name="Text 14"/>
-          <p:cNvSpPr/>
-          <p:nvPr/>
-        </p:nvSpPr>
-        <p:spPr>
-          <a:xfrm>
-            <a:off x="5239512" y="2011680"/>
-            <a:ext cx="1188720" cy="640080"/>
-          </a:xfrm>
-          <a:prstGeom prst="rect">
-            <a:avLst/>
-          </a:prstGeom>
-          <a:noFill/>
-          <a:ln/>
-        </p:spPr>
-        <p:txBody>
-          <a:bodyPr wrap="square" lIns="0" tIns="0" rIns="0" bIns="0" rtlCol="0" anchor="ctr">
-            <a:normAutofit/>
-          </a:bodyPr>
-          <a:lstStyle/>
-          <a:p>
-            <a:pPr algn="ctr" indent="0" marL="0">
-              <a:buNone/>
-            </a:pPr>
-            <a:r>
-              <a:rPr lang="en-US" sz="1100" b="1" dirty="0">
-                <a:solidFill>
-                  <a:srgbClr val="FFFFFF"/>
-                </a:solidFill>
-                <a:latin typeface="Verdana" pitchFamily="34" charset="0"/>
-                <a:ea typeface="Verdana" pitchFamily="34" charset="-122"/>
-                <a:cs typeface="Verdana" pitchFamily="34" charset="-120"/>
-              </a:rPr>
-              <a:t>Operator</a:t>
-            </a:r>
-            <a:endParaRPr lang="en-US" sz="1100" dirty="0"/>
-          </a:p>
-        </p:txBody>
-      </p:sp>
-      <p:sp>
-        <p:nvSpPr>
-          <p:cNvPr id="17" name="Text 15"/>
-          <p:cNvSpPr/>
-          <p:nvPr/>
-        </p:nvSpPr>
-        <p:spPr>
-          <a:xfrm>
-            <a:off x="6428232" y="2011680"/>
-            <a:ext cx="73152" cy="640080"/>
-          </a:xfrm>
-          <a:prstGeom prst="rect">
-            <a:avLst/>
-          </a:prstGeom>
-          <a:noFill/>
-          <a:ln/>
-        </p:spPr>
-        <p:txBody>
-          <a:bodyPr wrap="square" lIns="0" tIns="0" rIns="0" bIns="0" rtlCol="0" anchor="ctr"/>
-          <a:lstStyle/>
-          <a:p>
-            <a:pPr algn="ctr" indent="0" marL="0">
-              <a:buNone/>
-            </a:pPr>
-            <a:r>
-              <a:rPr lang="en-US" sz="1100" dirty="0">
-                <a:solidFill>
-                  <a:srgbClr val="8B95A5"/>
-                </a:solidFill>
-                <a:latin typeface="Verdana" pitchFamily="34" charset="0"/>
-                <a:ea typeface="Verdana" pitchFamily="34" charset="-122"/>
-                <a:cs typeface="Verdana" pitchFamily="34" charset="-120"/>
-              </a:rPr>
-              <a:t>→</a:t>
-            </a:r>
-            <a:endParaRPr lang="en-US" sz="1100" dirty="0"/>
-          </a:p>
-        </p:txBody>
-      </p:sp>
-      <p:sp>
-        <p:nvSpPr>
-          <p:cNvPr id="18" name="Shape 16"/>
-          <p:cNvSpPr/>
-          <p:nvPr/>
-        </p:nvSpPr>
-        <p:spPr>
-          <a:xfrm>
-            <a:off x="6501384" y="2011680"/>
-            <a:ext cx="1188720" cy="640080"/>
-          </a:xfrm>
-          <a:prstGeom prst="roundRect">
-            <a:avLst>
-              <a:gd name="adj" fmla="val 11429"/>
-            </a:avLst>
-          </a:prstGeom>
-          <a:solidFill>
-            <a:srgbClr val="635BFF"/>
-          </a:solidFill>
-          <a:ln w="19050">
-            <a:solidFill>
-              <a:srgbClr val="635BFF"/>
-            </a:solidFill>
-            <a:prstDash val="solid"/>
-          </a:ln>
-        </p:spPr>
-      </p:sp>
-      <p:sp>
-        <p:nvSpPr>
-          <p:cNvPr id="19" name="Text 17"/>
-          <p:cNvSpPr/>
-          <p:nvPr/>
-        </p:nvSpPr>
-        <p:spPr>
-          <a:xfrm>
-            <a:off x="6501384" y="2011680"/>
-            <a:ext cx="1188720" cy="640080"/>
-          </a:xfrm>
-          <a:prstGeom prst="rect">
-            <a:avLst/>
-          </a:prstGeom>
-          <a:noFill/>
-          <a:ln/>
-        </p:spPr>
-        <p:txBody>
-          <a:bodyPr wrap="square" lIns="0" tIns="0" rIns="0" bIns="0" rtlCol="0" anchor="ctr">
-            <a:normAutofit/>
-          </a:bodyPr>
-          <a:lstStyle/>
-          <a:p>
-            <a:pPr algn="ctr" indent="0" marL="0">
-              <a:buNone/>
-            </a:pPr>
-            <a:r>
-              <a:rPr lang="en-US" sz="1100" b="1" dirty="0">
-                <a:solidFill>
-                  <a:srgbClr val="FFFFFF"/>
-                </a:solidFill>
-                <a:latin typeface="Verdana" pitchFamily="34" charset="0"/>
-                <a:ea typeface="Verdana" pitchFamily="34" charset="-122"/>
-                <a:cs typeface="Verdana" pitchFamily="34" charset="-120"/>
-              </a:rPr>
-              <a:t>Orchestrator</a:t>
-            </a:r>
-            <a:endParaRPr lang="en-US" sz="1100" dirty="0"/>
-          </a:p>
-        </p:txBody>
-      </p:sp>
-      <p:sp>
-        <p:nvSpPr>
-          <p:cNvPr id="20" name="Text 18"/>
-          <p:cNvSpPr/>
-          <p:nvPr/>
-        </p:nvSpPr>
-        <p:spPr>
-          <a:xfrm>
-            <a:off x="7690104" y="2011680"/>
-            <a:ext cx="73152" cy="640080"/>
-          </a:xfrm>
-          <a:prstGeom prst="rect">
-            <a:avLst/>
-          </a:prstGeom>
-          <a:noFill/>
-          <a:ln/>
-        </p:spPr>
-        <p:txBody>
-          <a:bodyPr wrap="square" lIns="0" tIns="0" rIns="0" bIns="0" rtlCol="0" anchor="ctr"/>
-          <a:lstStyle/>
-          <a:p>
-            <a:pPr algn="ctr" indent="0" marL="0">
-              <a:buNone/>
-            </a:pPr>
-            <a:r>
-              <a:rPr lang="en-US" sz="1100" dirty="0">
-                <a:solidFill>
-                  <a:srgbClr val="8B95A5"/>
-                </a:solidFill>
-                <a:latin typeface="Verdana" pitchFamily="34" charset="0"/>
-                <a:ea typeface="Verdana" pitchFamily="34" charset="-122"/>
-                <a:cs typeface="Verdana" pitchFamily="34" charset="-120"/>
-              </a:rPr>
-              <a:t>→</a:t>
-            </a:r>
-            <a:endParaRPr lang="en-US" sz="1100" dirty="0"/>
-          </a:p>
-        </p:txBody>
-      </p:sp>
-      <p:sp>
-        <p:nvSpPr>
-          <p:cNvPr id="21" name="Shape 19"/>
-          <p:cNvSpPr/>
-          <p:nvPr/>
-        </p:nvSpPr>
-        <p:spPr>
-          <a:xfrm>
-            <a:off x="7763256" y="2011680"/>
-            <a:ext cx="1188720" cy="640080"/>
-          </a:xfrm>
-          <a:prstGeom prst="roundRect">
-            <a:avLst>
-              <a:gd name="adj" fmla="val 11429"/>
-            </a:avLst>
-          </a:prstGeom>
-          <a:solidFill>
-            <a:srgbClr val="0A2540">
-              <a:alpha val="50000"/>
-            </a:srgbClr>
-          </a:solidFill>
-          <a:ln w="19050">
-            <a:solidFill>
-              <a:srgbClr val="8B95A5"/>
-            </a:solidFill>
-            <a:prstDash val="dash"/>
-          </a:ln>
-        </p:spPr>
-      </p:sp>
-      <p:sp>
-        <p:nvSpPr>
-          <p:cNvPr id="22" name="Text 20"/>
-          <p:cNvSpPr/>
-          <p:nvPr/>
-        </p:nvSpPr>
-        <p:spPr>
-          <a:xfrm>
-            <a:off x="7763256" y="2011680"/>
-            <a:ext cx="1188720" cy="640080"/>
-          </a:xfrm>
-          <a:prstGeom prst="rect">
-            <a:avLst/>
-          </a:prstGeom>
-          <a:noFill/>
-          <a:ln/>
-        </p:spPr>
-        <p:txBody>
-          <a:bodyPr wrap="square" lIns="0" tIns="0" rIns="0" bIns="0" rtlCol="0" anchor="ctr">
-            <a:normAutofit/>
-          </a:bodyPr>
-          <a:lstStyle/>
-          <a:p>
-            <a:pPr algn="ctr" indent="0" marL="0">
-              <a:buNone/>
-            </a:pPr>
-            <a:r>
-              <a:rPr lang="en-US" sz="1100" b="1" dirty="0">
-                <a:solidFill>
-                  <a:srgbClr val="8B95A5"/>
-                </a:solidFill>
-                <a:latin typeface="Verdana" pitchFamily="34" charset="0"/>
-                <a:ea typeface="Verdana" pitchFamily="34" charset="-122"/>
-                <a:cs typeface="Verdana" pitchFamily="34" charset="-120"/>
-              </a:rPr>
-              <a:t>Builder</a:t>
-            </a:r>
-            <a:endParaRPr lang="en-US" sz="1100" dirty="0"/>
-          </a:p>
-        </p:txBody>
-      </p:sp>
-      <p:sp>
-        <p:nvSpPr>
-          <p:cNvPr id="23" name="Text 21"/>
-          <p:cNvSpPr/>
-          <p:nvPr/>
-        </p:nvSpPr>
-        <p:spPr>
-          <a:xfrm>
-            <a:off x="914400" y="3108960"/>
-            <a:ext cx="7315200" cy="548640"/>
-          </a:xfrm>
-          <a:prstGeom prst="rect">
-            <a:avLst/>
-          </a:prstGeom>
-          <a:noFill/>
-          <a:ln/>
-        </p:spPr>
-        <p:txBody>
-          <a:bodyPr wrap="square" lIns="0" tIns="0" rIns="0" bIns="0" rtlCol="0" anchor="ctr"/>
-          <a:lstStyle/>
-          <a:p>
-            <a:pPr algn="ctr" indent="0" marL="0">
-              <a:buNone/>
-            </a:pPr>
-            <a:r>
-              <a:rPr lang="en-US" sz="2400" b="1" dirty="0">
-                <a:solidFill>
-                  <a:srgbClr val="635BFF"/>
-                </a:solidFill>
-                <a:latin typeface="Georgia" pitchFamily="34" charset="0"/>
-                <a:ea typeface="Georgia" pitchFamily="34" charset="-122"/>
-                <a:cs typeface="Georgia" pitchFamily="34" charset="-120"/>
-              </a:rPr>
-              <a:t>You started as an Explorer.</a:t>
-            </a:r>
-            <a:endParaRPr lang="en-US" sz="2400" dirty="0"/>
-          </a:p>
-          <a:p>
-            <a:pPr algn="ctr" indent="0" marL="0">
-              <a:buNone/>
-            </a:pPr>
-            <a:r>
-              <a:rPr lang="en-US" sz="2400" b="1" dirty="0">
-                <a:solidFill>
-                  <a:srgbClr val="635BFF"/>
-                </a:solidFill>
-                <a:latin typeface="Georgia" pitchFamily="34" charset="0"/>
-                <a:ea typeface="Georgia" pitchFamily="34" charset="-122"/>
-                <a:cs typeface="Georgia" pitchFamily="34" charset="-120"/>
-              </a:rPr>
-              <a:t>You’re now an Orchestrator.</a:t>
-            </a:r>
-            <a:endParaRPr lang="en-US" sz="2400" dirty="0"/>
-          </a:p>
-        </p:txBody>
-      </p:sp>
-    </p:spTree>
-  </p:cSld>
-  <p:clrMapOvr>
-    <a:masterClrMapping/>
-  </p:clrMapOvr>
-</p:sld>
-</file>
-
-<file path=ppt/slides/slide29.xml><?xml version="1.0" encoding="utf-8"?>
-<p:sld xmlns:a="http://schemas.openxmlformats.org/drawingml/2006/main" xmlns:r="http://schemas.openxmlformats.org/officeDocument/2006/relationships" xmlns:p="http://schemas.openxmlformats.org/presentationml/2006/main">
-  <p:cSld name="Slide 29">
     <p:bg>
       <p:bgPr>
         <a:solidFill>

</xml_diff>